<commit_message>
Acrescenta frente de atuação e status de acessos ao one-pager
Inclui a faixa com as frentes do recurso (desenvolvimento e evolução de
processos, automação de relatórios e rotinas operacionais, identificação
de oportunidades e estudos para levar dado às reuniões) e o selo de
acessos liberados no cabeçalho.

Co-Authored-By: Claude Opus 5 <noreply@anthropic.com>
Claude-Session: https://claude.ai/code/session_01LiBTDxNxgFCPijAoYiizN1
</commit_message>
<xml_diff>
--- a/apresentacoes/Planejamento_Ganhos.pptx
+++ b/apresentacoes/Planejamento_Ganhos.pptx
@@ -502,7 +502,7 @@
           <a:p>
             <a:r>
               <a:rPr lang="en-US" dirty="0"/>
-              <a:t>Mensagem central: o Planejamento (Willyan) assume o processo e todo o tratamento dos dados; a operação recebe a visão pronta e foca na ação. Hora a Hora: a operação passa a enxergar em tempo real o que está acontecendo e corrige a rota dentro do próprio turno, em vez de descobrir no dia seguinte. Dashboard D-1: N4 e N5 passam a ler o dia anterior na mesma régua — um só número, sem planilha paralela. O D-1 da N5 já foi entregue em 29/set; as demais visões saem em 05 e 09/out.</a:t>
+              <a:t>Mensagem central: o Planejamento (Willyan) assume o processo e todo o tratamento dos dados; a operação recebe a visão pronta e foca na ação. Hora a Hora: a operação passa a enxergar em tempo real o que está acontecendo e corrige a rota dentro do próprio turno, em vez de descobrir no dia seguinte. Dashboard D-1: N4 e N5 passam a ler o dia anterior na mesma régua — um só número, sem planilha paralela. O D-1 da N5 já foi entregue em 29/set; as demais visões saem em 05 e 09/out. Por trás das visões, o Willyan atua no desenvolvimento e na evolução dos processos, na automação dos relatórios e das rotinas operacionais, na identificação de oportunidades e gargalos, e nos estudos que levam dado — e não percepção — para as reuniões.</a:t>
             </a:r>
             <a:endParaRPr lang="en-US" dirty="0"/>
           </a:p>
@@ -940,7 +940,119 @@
       </p:sp>
       <p:sp>
         <p:nvSpPr>
-          <p:cNvPr id="4" name="Text 1"/>
+          <p:cNvPr id="4" name="Shape 1"/>
+          <p:cNvSpPr/>
+          <p:nvPr/>
+        </p:nvSpPr>
+        <p:spPr>
+          <a:xfrm>
+            <a:off x="8924544" y="411480"/>
+            <a:ext cx="2697480" cy="420624"/>
+          </a:xfrm>
+          <a:prstGeom prst="roundRect">
+            <a:avLst>
+              <a:gd name="adj" fmla="val 50000"/>
+            </a:avLst>
+          </a:prstGeom>
+          <a:solidFill>
+            <a:srgbClr val="E9A13B">
+              <a:alpha val="14000"/>
+            </a:srgbClr>
+          </a:solidFill>
+          <a:ln w="12700">
+            <a:solidFill>
+              <a:srgbClr val="E9A13B"/>
+            </a:solidFill>
+            <a:prstDash val="solid"/>
+          </a:ln>
+        </p:spPr>
+      </p:sp>
+      <p:sp>
+        <p:nvSpPr>
+          <p:cNvPr id="5" name="Shape 2"/>
+          <p:cNvSpPr/>
+          <p:nvPr/>
+        </p:nvSpPr>
+        <p:spPr>
+          <a:xfrm>
+            <a:off x="9107424" y="512064"/>
+            <a:ext cx="219456" cy="219456"/>
+          </a:xfrm>
+          <a:prstGeom prst="ellipse">
+            <a:avLst/>
+          </a:prstGeom>
+          <a:solidFill>
+            <a:srgbClr val="E9A13B"/>
+          </a:solidFill>
+          <a:ln/>
+        </p:spPr>
+      </p:sp>
+      <p:pic>
+        <p:nvPicPr>
+          <p:cNvPr id="6" name="Image 1" descr="preencoded.png">    </p:cNvPr>
+          <p:cNvPicPr>
+            <a:picLocks noChangeAspect="1"/>
+          </p:cNvPicPr>
+          <p:nvPr/>
+        </p:nvPicPr>
+        <p:blipFill>
+          <a:blip r:embed="rId2"/>
+          <a:stretch>
+            <a:fillRect/>
+          </a:stretch>
+        </p:blipFill>
+        <p:spPr>
+          <a:xfrm>
+            <a:off x="9162288" y="566928"/>
+            <a:ext cx="109728" cy="109728"/>
+          </a:xfrm>
+          <a:prstGeom prst="rect">
+            <a:avLst/>
+          </a:prstGeom>
+        </p:spPr>
+      </p:pic>
+      <p:sp>
+        <p:nvSpPr>
+          <p:cNvPr id="7" name="Text 3"/>
+          <p:cNvSpPr txBox="1"/>
+          <p:nvPr/>
+        </p:nvSpPr>
+        <p:spPr>
+          <a:xfrm>
+            <a:off x="9400032" y="411480"/>
+            <a:ext cx="2057400" cy="420624"/>
+          </a:xfrm>
+          <a:prstGeom prst="rect">
+            <a:avLst/>
+          </a:prstGeom>
+          <a:noFill/>
+          <a:ln/>
+        </p:spPr>
+        <p:txBody>
+          <a:bodyPr wrap="square" lIns="0" tIns="0" rIns="0" bIns="0" rtlCol="0" anchor="ctr"/>
+          <a:lstStyle/>
+          <a:p>
+            <a:pPr indent="0" marL="0">
+              <a:buNone/>
+            </a:pPr>
+            <a:r>
+              <a:rPr lang="en-US" sz="950" b="1" spc="100" kern="0" dirty="0">
+                <a:solidFill>
+                  <a:srgbClr val="E9A13B"/>
+                </a:solidFill>
+                <a:latin typeface="Calibri" pitchFamily="34" charset="0"/>
+                <a:ea typeface="Calibri" pitchFamily="34" charset="-122"/>
+                <a:cs typeface="Calibri" pitchFamily="34" charset="-120"/>
+              </a:rPr>
+              <a:t>ACESSOS LIBERADOS</a:t>
+            </a:r>
+            <a:endParaRPr lang="en-US" sz="950" dirty="0"/>
+          </a:p>
+        </p:txBody>
+      </p:sp>
+      <p:sp>
+        <p:nvSpPr>
+          <p:cNvPr id="8" name="Text 4"/>
           <p:cNvSpPr txBox="1"/>
           <p:nvPr/>
         </p:nvSpPr>
@@ -1000,7 +1112,7 @@
       </p:sp>
       <p:sp>
         <p:nvSpPr>
-          <p:cNvPr id="5" name="Text 2"/>
+          <p:cNvPr id="9" name="Text 5"/>
           <p:cNvSpPr txBox="1"/>
           <p:nvPr/>
         </p:nvSpPr>
@@ -1039,18 +1151,18 @@
       </p:sp>
       <p:sp>
         <p:nvSpPr>
-          <p:cNvPr id="6" name="Shape 3"/>
+          <p:cNvPr id="10" name="Shape 6"/>
           <p:cNvSpPr/>
           <p:nvPr/>
         </p:nvSpPr>
         <p:spPr>
           <a:xfrm>
-            <a:off x="566928" y="2596896"/>
-            <a:ext cx="5367528" cy="2670048"/>
+            <a:off x="566928" y="2560320"/>
+            <a:ext cx="5367528" cy="2523744"/>
           </a:xfrm>
           <a:prstGeom prst="roundRect">
             <a:avLst>
-              <a:gd name="adj" fmla="val 4110"/>
+              <a:gd name="adj" fmla="val 4348"/>
             </a:avLst>
           </a:prstGeom>
           <a:solidFill>
@@ -1075,13 +1187,13 @@
       </p:sp>
       <p:sp>
         <p:nvSpPr>
-          <p:cNvPr id="7" name="Text 4"/>
+          <p:cNvPr id="11" name="Text 7"/>
           <p:cNvSpPr txBox="1"/>
           <p:nvPr/>
         </p:nvSpPr>
         <p:spPr>
           <a:xfrm>
-            <a:off x="969264" y="2926080"/>
+            <a:off x="969264" y="2852928"/>
             <a:ext cx="4562856" cy="237744"/>
           </a:xfrm>
           <a:prstGeom prst="rect">
@@ -1114,14 +1226,14 @@
       </p:sp>
       <p:sp>
         <p:nvSpPr>
-          <p:cNvPr id="8" name="Shape 5"/>
+          <p:cNvPr id="12" name="Shape 8"/>
           <p:cNvSpPr/>
           <p:nvPr/>
         </p:nvSpPr>
         <p:spPr>
           <a:xfrm>
-            <a:off x="969264" y="3310128"/>
-            <a:ext cx="914400" cy="914400"/>
+            <a:off x="969264" y="3200400"/>
+            <a:ext cx="868680" cy="868680"/>
           </a:xfrm>
           <a:prstGeom prst="ellipse">
             <a:avLst/>
@@ -1134,22 +1246,22 @@
       </p:sp>
       <p:pic>
         <p:nvPicPr>
-          <p:cNvPr id="9" name="Image 1" descr="preencoded.png">    </p:cNvPr>
+          <p:cNvPr id="13" name="Image 2" descr="preencoded.png">    </p:cNvPr>
           <p:cNvPicPr>
             <a:picLocks noChangeAspect="1"/>
           </p:cNvPicPr>
           <p:nvPr/>
         </p:nvPicPr>
         <p:blipFill>
-          <a:blip r:embed="rId2"/>
+          <a:blip r:embed="rId3"/>
           <a:stretch>
             <a:fillRect/>
           </a:stretch>
         </p:blipFill>
         <p:spPr>
           <a:xfrm>
-            <a:off x="1216152" y="3557016"/>
-            <a:ext cx="420624" cy="420624"/>
+            <a:off x="1202436" y="3433572"/>
+            <a:ext cx="402336" cy="402336"/>
           </a:xfrm>
           <a:prstGeom prst="rect">
             <a:avLst/>
@@ -1158,14 +1270,14 @@
       </p:pic>
       <p:sp>
         <p:nvSpPr>
-          <p:cNvPr id="10" name="Text 6"/>
+          <p:cNvPr id="14" name="Text 9"/>
           <p:cNvSpPr txBox="1"/>
           <p:nvPr/>
         </p:nvSpPr>
         <p:spPr>
           <a:xfrm>
-            <a:off x="2084832" y="3474720"/>
-            <a:ext cx="3447288" cy="585216"/>
+            <a:off x="2029968" y="3346704"/>
+            <a:ext cx="3502152" cy="566928"/>
           </a:xfrm>
           <a:prstGeom prst="rect">
             <a:avLst/>
@@ -1197,14 +1309,14 @@
       </p:sp>
       <p:sp>
         <p:nvSpPr>
-          <p:cNvPr id="11" name="Text 7"/>
+          <p:cNvPr id="15" name="Text 10"/>
           <p:cNvSpPr txBox="1"/>
           <p:nvPr/>
         </p:nvSpPr>
         <p:spPr>
           <a:xfrm>
-            <a:off x="969264" y="4389120"/>
-            <a:ext cx="4562856" cy="566928"/>
+            <a:off x="969264" y="4242816"/>
+            <a:ext cx="4562856" cy="548640"/>
           </a:xfrm>
           <a:prstGeom prst="rect">
             <a:avLst/>
@@ -1239,13 +1351,13 @@
       </p:sp>
       <p:sp>
         <p:nvSpPr>
-          <p:cNvPr id="12" name="Text 8"/>
+          <p:cNvPr id="16" name="Text 11"/>
           <p:cNvSpPr txBox="1"/>
           <p:nvPr/>
         </p:nvSpPr>
         <p:spPr>
           <a:xfrm>
-            <a:off x="969264" y="4937760"/>
+            <a:off x="969264" y="4791456"/>
             <a:ext cx="4562856" cy="237744"/>
           </a:xfrm>
           <a:prstGeom prst="rect">
@@ -1278,18 +1390,18 @@
       </p:sp>
       <p:sp>
         <p:nvSpPr>
-          <p:cNvPr id="13" name="Shape 9"/>
+          <p:cNvPr id="17" name="Shape 12"/>
           <p:cNvSpPr/>
           <p:nvPr/>
         </p:nvSpPr>
         <p:spPr>
           <a:xfrm>
-            <a:off x="6254496" y="2596896"/>
-            <a:ext cx="5367528" cy="2670048"/>
+            <a:off x="6254496" y="2560320"/>
+            <a:ext cx="5367528" cy="2523744"/>
           </a:xfrm>
           <a:prstGeom prst="roundRect">
             <a:avLst>
-              <a:gd name="adj" fmla="val 4110"/>
+              <a:gd name="adj" fmla="val 4348"/>
             </a:avLst>
           </a:prstGeom>
           <a:solidFill>
@@ -1314,13 +1426,13 @@
       </p:sp>
       <p:sp>
         <p:nvSpPr>
-          <p:cNvPr id="14" name="Text 10"/>
+          <p:cNvPr id="18" name="Text 13"/>
           <p:cNvSpPr txBox="1"/>
           <p:nvPr/>
         </p:nvSpPr>
         <p:spPr>
           <a:xfrm>
-            <a:off x="6656832" y="2926080"/>
+            <a:off x="6656832" y="2852928"/>
             <a:ext cx="4562856" cy="237744"/>
           </a:xfrm>
           <a:prstGeom prst="rect">
@@ -1353,14 +1465,14 @@
       </p:sp>
       <p:sp>
         <p:nvSpPr>
-          <p:cNvPr id="15" name="Shape 11"/>
+          <p:cNvPr id="19" name="Shape 14"/>
           <p:cNvSpPr/>
           <p:nvPr/>
         </p:nvSpPr>
         <p:spPr>
           <a:xfrm>
-            <a:off x="6656832" y="3310128"/>
-            <a:ext cx="914400" cy="914400"/>
+            <a:off x="6656832" y="3200400"/>
+            <a:ext cx="868680" cy="868680"/>
           </a:xfrm>
           <a:prstGeom prst="ellipse">
             <a:avLst/>
@@ -1373,22 +1485,22 @@
       </p:sp>
       <p:pic>
         <p:nvPicPr>
-          <p:cNvPr id="16" name="Image 2" descr="preencoded.png">    </p:cNvPr>
+          <p:cNvPr id="20" name="Image 3" descr="preencoded.png">    </p:cNvPr>
           <p:cNvPicPr>
             <a:picLocks noChangeAspect="1"/>
           </p:cNvPicPr>
           <p:nvPr/>
         </p:nvPicPr>
         <p:blipFill>
-          <a:blip r:embed="rId3"/>
+          <a:blip r:embed="rId4"/>
           <a:stretch>
             <a:fillRect/>
           </a:stretch>
         </p:blipFill>
         <p:spPr>
           <a:xfrm>
-            <a:off x="6903720" y="3557016"/>
-            <a:ext cx="420624" cy="420624"/>
+            <a:off x="6890004" y="3433572"/>
+            <a:ext cx="402336" cy="402336"/>
           </a:xfrm>
           <a:prstGeom prst="rect">
             <a:avLst/>
@@ -1397,14 +1509,14 @@
       </p:pic>
       <p:sp>
         <p:nvSpPr>
-          <p:cNvPr id="17" name="Text 12"/>
+          <p:cNvPr id="21" name="Text 15"/>
           <p:cNvSpPr txBox="1"/>
           <p:nvPr/>
         </p:nvSpPr>
         <p:spPr>
           <a:xfrm>
-            <a:off x="7772400" y="3474720"/>
-            <a:ext cx="3447288" cy="585216"/>
+            <a:off x="7717536" y="3346704"/>
+            <a:ext cx="3502152" cy="566928"/>
           </a:xfrm>
           <a:prstGeom prst="rect">
             <a:avLst/>
@@ -1436,14 +1548,14 @@
       </p:sp>
       <p:sp>
         <p:nvSpPr>
-          <p:cNvPr id="18" name="Text 13"/>
+          <p:cNvPr id="22" name="Text 16"/>
           <p:cNvSpPr txBox="1"/>
           <p:nvPr/>
         </p:nvSpPr>
         <p:spPr>
           <a:xfrm>
-            <a:off x="6656832" y="4389120"/>
-            <a:ext cx="4562856" cy="566928"/>
+            <a:off x="6656832" y="4242816"/>
+            <a:ext cx="4562856" cy="548640"/>
           </a:xfrm>
           <a:prstGeom prst="rect">
             <a:avLst/>
@@ -1478,13 +1590,13 @@
       </p:sp>
       <p:sp>
         <p:nvSpPr>
-          <p:cNvPr id="19" name="Text 14"/>
+          <p:cNvPr id="23" name="Text 17"/>
           <p:cNvSpPr txBox="1"/>
           <p:nvPr/>
         </p:nvSpPr>
         <p:spPr>
           <a:xfrm>
-            <a:off x="6656832" y="4937760"/>
+            <a:off x="6656832" y="4791456"/>
             <a:ext cx="4562856" cy="237744"/>
           </a:xfrm>
           <a:prstGeom prst="rect">
@@ -1517,18 +1629,18 @@
       </p:sp>
       <p:sp>
         <p:nvSpPr>
-          <p:cNvPr id="20" name="Shape 15"/>
+          <p:cNvPr id="24" name="Shape 18"/>
           <p:cNvSpPr/>
           <p:nvPr/>
         </p:nvSpPr>
         <p:spPr>
           <a:xfrm>
-            <a:off x="566928" y="5541264"/>
-            <a:ext cx="11055096" cy="713232"/>
+            <a:off x="566928" y="5358384"/>
+            <a:ext cx="11055096" cy="1042416"/>
           </a:xfrm>
           <a:prstGeom prst="roundRect">
             <a:avLst>
-              <a:gd name="adj" fmla="val 12821"/>
+              <a:gd name="adj" fmla="val 8772"/>
             </a:avLst>
           </a:prstGeom>
           <a:solidFill>
@@ -1546,14 +1658,76 @@
       </p:sp>
       <p:sp>
         <p:nvSpPr>
-          <p:cNvPr id="21" name="Shape 16"/>
+          <p:cNvPr id="25" name="Text 19"/>
+          <p:cNvSpPr txBox="1"/>
+          <p:nvPr/>
+        </p:nvSpPr>
+        <p:spPr>
+          <a:xfrm>
+            <a:off x="896112" y="5358384"/>
+            <a:ext cx="1097280" cy="1042416"/>
+          </a:xfrm>
+          <a:prstGeom prst="rect">
+            <a:avLst/>
+          </a:prstGeom>
+          <a:noFill/>
+          <a:ln/>
+        </p:spPr>
+        <p:txBody>
+          <a:bodyPr wrap="square" lIns="0" tIns="0" rIns="0" bIns="0" rtlCol="0" anchor="ctr"/>
+          <a:lstStyle/>
+          <a:p>
+            <a:pPr indent="0" marL="0">
+              <a:lnSpc>
+                <a:spcPct val="105000"/>
+              </a:lnSpc>
+              <a:buNone/>
+            </a:pPr>
+            <a:r>
+              <a:rPr lang="en-US" sz="1000" b="1" spc="130" kern="0" dirty="0">
+                <a:solidFill>
+                  <a:srgbClr val="E9A13B"/>
+                </a:solidFill>
+                <a:latin typeface="Calibri" pitchFamily="34" charset="0"/>
+                <a:ea typeface="Calibri" pitchFamily="34" charset="-122"/>
+                <a:cs typeface="Calibri" pitchFamily="34" charset="-120"/>
+              </a:rPr>
+              <a:t>POR TRÁS</a:t>
+            </a:r>
+            <a:endParaRPr lang="en-US" sz="1000" dirty="0"/>
+          </a:p>
+          <a:p>
+            <a:pPr indent="0" marL="0">
+              <a:lnSpc>
+                <a:spcPct val="105000"/>
+              </a:lnSpc>
+              <a:buNone/>
+            </a:pPr>
+            <a:r>
+              <a:rPr lang="en-US" sz="1000" b="1" spc="130" kern="0" dirty="0">
+                <a:solidFill>
+                  <a:srgbClr val="E9A13B"/>
+                </a:solidFill>
+                <a:latin typeface="Calibri" pitchFamily="34" charset="0"/>
+                <a:ea typeface="Calibri" pitchFamily="34" charset="-122"/>
+                <a:cs typeface="Calibri" pitchFamily="34" charset="-120"/>
+              </a:rPr>
+              <a:t>DISSO</a:t>
+            </a:r>
+            <a:endParaRPr lang="en-US" sz="1000" dirty="0"/>
+          </a:p>
+        </p:txBody>
+      </p:sp>
+      <p:sp>
+        <p:nvSpPr>
+          <p:cNvPr id="26" name="Shape 20"/>
           <p:cNvSpPr/>
           <p:nvPr/>
         </p:nvSpPr>
         <p:spPr>
           <a:xfrm>
-            <a:off x="978408" y="5779008"/>
-            <a:ext cx="237744" cy="237744"/>
+            <a:off x="1984248" y="5596128"/>
+            <a:ext cx="256032" cy="256032"/>
           </a:xfrm>
           <a:prstGeom prst="ellipse">
             <a:avLst/>
@@ -1566,21 +1740,21 @@
       </p:sp>
       <p:pic>
         <p:nvPicPr>
-          <p:cNvPr id="22" name="Image 3" descr="preencoded.png">    </p:cNvPr>
+          <p:cNvPr id="27" name="Image 4" descr="preencoded.png">    </p:cNvPr>
           <p:cNvPicPr>
             <a:picLocks noChangeAspect="1"/>
           </p:cNvPicPr>
           <p:nvPr/>
         </p:nvPicPr>
         <p:blipFill>
-          <a:blip r:embed="rId4"/>
+          <a:blip r:embed="rId5"/>
           <a:stretch>
             <a:fillRect/>
           </a:stretch>
         </p:blipFill>
         <p:spPr>
           <a:xfrm>
-            <a:off x="1033272" y="5833872"/>
+            <a:off x="2048256" y="5660136"/>
             <a:ext cx="128016" cy="128016"/>
           </a:xfrm>
           <a:prstGeom prst="rect">
@@ -1590,14 +1764,14 @@
       </p:pic>
       <p:sp>
         <p:nvSpPr>
-          <p:cNvPr id="23" name="Text 17"/>
+          <p:cNvPr id="28" name="Text 21"/>
           <p:cNvSpPr txBox="1"/>
           <p:nvPr/>
         </p:nvSpPr>
         <p:spPr>
           <a:xfrm>
-            <a:off x="1344168" y="5541264"/>
-            <a:ext cx="2907792" cy="713232"/>
+            <a:off x="2331720" y="5577840"/>
+            <a:ext cx="1906524" cy="274320"/>
           </a:xfrm>
           <a:prstGeom prst="rect">
             <a:avLst/>
@@ -1613,7 +1787,7 @@
               <a:buNone/>
             </a:pPr>
             <a:r>
-              <a:rPr lang="en-US" sz="1250" dirty="0">
+              <a:rPr lang="en-US" sz="1150" b="1" dirty="0">
                 <a:solidFill>
                   <a:srgbClr val="FFFFFF"/>
                 </a:solidFill>
@@ -1621,22 +1795,64 @@
                 <a:ea typeface="Calibri" pitchFamily="34" charset="-122"/>
                 <a:cs typeface="Calibri" pitchFamily="34" charset="-120"/>
               </a:rPr>
-              <a:t>Sem extração manual</a:t>
-            </a:r>
-            <a:endParaRPr lang="en-US" sz="1250" dirty="0"/>
-          </a:p>
-        </p:txBody>
-      </p:sp>
-      <p:sp>
-        <p:nvSpPr>
-          <p:cNvPr id="24" name="Shape 18"/>
+              <a:t>Desenvolvimento</a:t>
+            </a:r>
+            <a:endParaRPr lang="en-US" sz="1150" dirty="0"/>
+          </a:p>
+        </p:txBody>
+      </p:sp>
+      <p:sp>
+        <p:nvSpPr>
+          <p:cNvPr id="29" name="Text 22"/>
+          <p:cNvSpPr txBox="1"/>
+          <p:nvPr/>
+        </p:nvSpPr>
+        <p:spPr>
+          <a:xfrm>
+            <a:off x="2331720" y="5870448"/>
+            <a:ext cx="1906524" cy="402336"/>
+          </a:xfrm>
+          <a:prstGeom prst="rect">
+            <a:avLst/>
+          </a:prstGeom>
+          <a:noFill/>
+          <a:ln/>
+        </p:spPr>
+        <p:txBody>
+          <a:bodyPr wrap="square" lIns="0" tIns="0" rIns="0" bIns="0" rtlCol="0" anchor="t"/>
+          <a:lstStyle/>
+          <a:p>
+            <a:pPr indent="0" marL="0">
+              <a:lnSpc>
+                <a:spcPct val="110000"/>
+              </a:lnSpc>
+              <a:buNone/>
+            </a:pPr>
+            <a:r>
+              <a:rPr lang="en-US" sz="900" dirty="0">
+                <a:solidFill>
+                  <a:srgbClr val="D8E4F4"/>
+                </a:solidFill>
+                <a:latin typeface="Calibri" pitchFamily="34" charset="0"/>
+                <a:ea typeface="Calibri" pitchFamily="34" charset="-122"/>
+                <a:cs typeface="Calibri" pitchFamily="34" charset="-120"/>
+              </a:rPr>
+              <a:t>Constrói e evolui processos</a:t>
+            </a:r>
+            <a:endParaRPr lang="en-US" sz="900" dirty="0"/>
+          </a:p>
+        </p:txBody>
+      </p:sp>
+      <p:sp>
+        <p:nvSpPr>
+          <p:cNvPr id="30" name="Shape 23"/>
           <p:cNvSpPr/>
           <p:nvPr/>
         </p:nvSpPr>
         <p:spPr>
           <a:xfrm>
-            <a:off x="4389120" y="5779008"/>
-            <a:ext cx="237744" cy="237744"/>
+            <a:off x="4439412" y="5596128"/>
+            <a:ext cx="256032" cy="256032"/>
           </a:xfrm>
           <a:prstGeom prst="ellipse">
             <a:avLst/>
@@ -1649,21 +1865,21 @@
       </p:sp>
       <p:pic>
         <p:nvPicPr>
-          <p:cNvPr id="25" name="Image 4" descr="preencoded.png">    </p:cNvPr>
+          <p:cNvPr id="31" name="Image 5" descr="preencoded.png">    </p:cNvPr>
           <p:cNvPicPr>
             <a:picLocks noChangeAspect="1"/>
           </p:cNvPicPr>
           <p:nvPr/>
         </p:nvPicPr>
         <p:blipFill>
-          <a:blip r:embed="rId5"/>
+          <a:blip r:embed="rId6"/>
           <a:stretch>
             <a:fillRect/>
           </a:stretch>
         </p:blipFill>
         <p:spPr>
           <a:xfrm>
-            <a:off x="4443984" y="5833872"/>
+            <a:off x="4503420" y="5660136"/>
             <a:ext cx="128016" cy="128016"/>
           </a:xfrm>
           <a:prstGeom prst="rect">
@@ -1673,14 +1889,14 @@
       </p:pic>
       <p:sp>
         <p:nvSpPr>
-          <p:cNvPr id="26" name="Text 19"/>
+          <p:cNvPr id="32" name="Text 24"/>
           <p:cNvSpPr txBox="1"/>
           <p:nvPr/>
         </p:nvSpPr>
         <p:spPr>
           <a:xfrm>
-            <a:off x="4754880" y="5541264"/>
-            <a:ext cx="2907792" cy="713232"/>
+            <a:off x="4786884" y="5577840"/>
+            <a:ext cx="1906524" cy="274320"/>
           </a:xfrm>
           <a:prstGeom prst="rect">
             <a:avLst/>
@@ -1696,7 +1912,7 @@
               <a:buNone/>
             </a:pPr>
             <a:r>
-              <a:rPr lang="en-US" sz="1250" dirty="0">
+              <a:rPr lang="en-US" sz="1150" b="1" dirty="0">
                 <a:solidFill>
                   <a:srgbClr val="FFFFFF"/>
                 </a:solidFill>
@@ -1704,22 +1920,64 @@
                 <a:ea typeface="Calibri" pitchFamily="34" charset="-122"/>
                 <a:cs typeface="Calibri" pitchFamily="34" charset="-120"/>
               </a:rPr>
-              <a:t>Uma única fonte de número</a:t>
-            </a:r>
-            <a:endParaRPr lang="en-US" sz="1250" dirty="0"/>
-          </a:p>
-        </p:txBody>
-      </p:sp>
-      <p:sp>
-        <p:nvSpPr>
-          <p:cNvPr id="27" name="Shape 20"/>
+              <a:t>Automação</a:t>
+            </a:r>
+            <a:endParaRPr lang="en-US" sz="1150" dirty="0"/>
+          </a:p>
+        </p:txBody>
+      </p:sp>
+      <p:sp>
+        <p:nvSpPr>
+          <p:cNvPr id="33" name="Text 25"/>
+          <p:cNvSpPr txBox="1"/>
+          <p:nvPr/>
+        </p:nvSpPr>
+        <p:spPr>
+          <a:xfrm>
+            <a:off x="4786884" y="5870448"/>
+            <a:ext cx="1906524" cy="402336"/>
+          </a:xfrm>
+          <a:prstGeom prst="rect">
+            <a:avLst/>
+          </a:prstGeom>
+          <a:noFill/>
+          <a:ln/>
+        </p:spPr>
+        <p:txBody>
+          <a:bodyPr wrap="square" lIns="0" tIns="0" rIns="0" bIns="0" rtlCol="0" anchor="t"/>
+          <a:lstStyle/>
+          <a:p>
+            <a:pPr indent="0" marL="0">
+              <a:lnSpc>
+                <a:spcPct val="110000"/>
+              </a:lnSpc>
+              <a:buNone/>
+            </a:pPr>
+            <a:r>
+              <a:rPr lang="en-US" sz="900" dirty="0">
+                <a:solidFill>
+                  <a:srgbClr val="D8E4F4"/>
+                </a:solidFill>
+                <a:latin typeface="Calibri" pitchFamily="34" charset="0"/>
+                <a:ea typeface="Calibri" pitchFamily="34" charset="-122"/>
+                <a:cs typeface="Calibri" pitchFamily="34" charset="-120"/>
+              </a:rPr>
+              <a:t>Relatórios e rotinas operacionais</a:t>
+            </a:r>
+            <a:endParaRPr lang="en-US" sz="900" dirty="0"/>
+          </a:p>
+        </p:txBody>
+      </p:sp>
+      <p:sp>
+        <p:nvSpPr>
+          <p:cNvPr id="34" name="Shape 26"/>
           <p:cNvSpPr/>
           <p:nvPr/>
         </p:nvSpPr>
         <p:spPr>
           <a:xfrm>
-            <a:off x="7799832" y="5779008"/>
-            <a:ext cx="237744" cy="237744"/>
+            <a:off x="6894576" y="5596128"/>
+            <a:ext cx="256032" cy="256032"/>
           </a:xfrm>
           <a:prstGeom prst="ellipse">
             <a:avLst/>
@@ -1732,21 +1990,21 @@
       </p:sp>
       <p:pic>
         <p:nvPicPr>
-          <p:cNvPr id="28" name="Image 5" descr="preencoded.png">    </p:cNvPr>
+          <p:cNvPr id="35" name="Image 6" descr="preencoded.png">    </p:cNvPr>
           <p:cNvPicPr>
             <a:picLocks noChangeAspect="1"/>
           </p:cNvPicPr>
           <p:nvPr/>
         </p:nvPicPr>
         <p:blipFill>
-          <a:blip r:embed="rId6"/>
+          <a:blip r:embed="rId7"/>
           <a:stretch>
             <a:fillRect/>
           </a:stretch>
         </p:blipFill>
         <p:spPr>
           <a:xfrm>
-            <a:off x="7854696" y="5833872"/>
+            <a:off x="6958584" y="5660136"/>
             <a:ext cx="128016" cy="128016"/>
           </a:xfrm>
           <a:prstGeom prst="rect">
@@ -1756,14 +2014,14 @@
       </p:pic>
       <p:sp>
         <p:nvSpPr>
-          <p:cNvPr id="29" name="Text 21"/>
+          <p:cNvPr id="36" name="Text 27"/>
           <p:cNvSpPr txBox="1"/>
           <p:nvPr/>
         </p:nvSpPr>
         <p:spPr>
           <a:xfrm>
-            <a:off x="8165592" y="5541264"/>
-            <a:ext cx="2907792" cy="713232"/>
+            <a:off x="7242048" y="5577840"/>
+            <a:ext cx="1906524" cy="274320"/>
           </a:xfrm>
           <a:prstGeom prst="rect">
             <a:avLst/>
@@ -1779,7 +2037,7 @@
               <a:buNone/>
             </a:pPr>
             <a:r>
-              <a:rPr lang="en-US" sz="1250" dirty="0">
+              <a:rPr lang="en-US" sz="1150" b="1" dirty="0">
                 <a:solidFill>
                   <a:srgbClr val="FFFFFF"/>
                 </a:solidFill>
@@ -1787,9 +2045,176 @@
                 <a:ea typeface="Calibri" pitchFamily="34" charset="-122"/>
                 <a:cs typeface="Calibri" pitchFamily="34" charset="-120"/>
               </a:rPr>
-              <a:t>Alinhado às metas do cliente</a:t>
-            </a:r>
-            <a:endParaRPr lang="en-US" sz="1250" dirty="0"/>
+              <a:t>Oportunidades</a:t>
+            </a:r>
+            <a:endParaRPr lang="en-US" sz="1150" dirty="0"/>
+          </a:p>
+        </p:txBody>
+      </p:sp>
+      <p:sp>
+        <p:nvSpPr>
+          <p:cNvPr id="37" name="Text 28"/>
+          <p:cNvSpPr txBox="1"/>
+          <p:nvPr/>
+        </p:nvSpPr>
+        <p:spPr>
+          <a:xfrm>
+            <a:off x="7242048" y="5870448"/>
+            <a:ext cx="1906524" cy="402336"/>
+          </a:xfrm>
+          <a:prstGeom prst="rect">
+            <a:avLst/>
+          </a:prstGeom>
+          <a:noFill/>
+          <a:ln/>
+        </p:spPr>
+        <p:txBody>
+          <a:bodyPr wrap="square" lIns="0" tIns="0" rIns="0" bIns="0" rtlCol="0" anchor="t"/>
+          <a:lstStyle/>
+          <a:p>
+            <a:pPr indent="0" marL="0">
+              <a:lnSpc>
+                <a:spcPct val="110000"/>
+              </a:lnSpc>
+              <a:buNone/>
+            </a:pPr>
+            <a:r>
+              <a:rPr lang="en-US" sz="900" dirty="0">
+                <a:solidFill>
+                  <a:srgbClr val="D8E4F4"/>
+                </a:solidFill>
+                <a:latin typeface="Calibri" pitchFamily="34" charset="0"/>
+                <a:ea typeface="Calibri" pitchFamily="34" charset="-122"/>
+                <a:cs typeface="Calibri" pitchFamily="34" charset="-120"/>
+              </a:rPr>
+              <a:t>Identifica gargalos e ganhos</a:t>
+            </a:r>
+            <a:endParaRPr lang="en-US" sz="900" dirty="0"/>
+          </a:p>
+        </p:txBody>
+      </p:sp>
+      <p:sp>
+        <p:nvSpPr>
+          <p:cNvPr id="38" name="Shape 29"/>
+          <p:cNvSpPr/>
+          <p:nvPr/>
+        </p:nvSpPr>
+        <p:spPr>
+          <a:xfrm>
+            <a:off x="9349740" y="5596128"/>
+            <a:ext cx="256032" cy="256032"/>
+          </a:xfrm>
+          <a:prstGeom prst="ellipse">
+            <a:avLst/>
+          </a:prstGeom>
+          <a:solidFill>
+            <a:srgbClr val="E9A13B"/>
+          </a:solidFill>
+          <a:ln/>
+        </p:spPr>
+      </p:sp>
+      <p:pic>
+        <p:nvPicPr>
+          <p:cNvPr id="39" name="Image 7" descr="preencoded.png">    </p:cNvPr>
+          <p:cNvPicPr>
+            <a:picLocks noChangeAspect="1"/>
+          </p:cNvPicPr>
+          <p:nvPr/>
+        </p:nvPicPr>
+        <p:blipFill>
+          <a:blip r:embed="rId8"/>
+          <a:stretch>
+            <a:fillRect/>
+          </a:stretch>
+        </p:blipFill>
+        <p:spPr>
+          <a:xfrm>
+            <a:off x="9413748" y="5660136"/>
+            <a:ext cx="128016" cy="128016"/>
+          </a:xfrm>
+          <a:prstGeom prst="rect">
+            <a:avLst/>
+          </a:prstGeom>
+        </p:spPr>
+      </p:pic>
+      <p:sp>
+        <p:nvSpPr>
+          <p:cNvPr id="40" name="Text 30"/>
+          <p:cNvSpPr txBox="1"/>
+          <p:nvPr/>
+        </p:nvSpPr>
+        <p:spPr>
+          <a:xfrm>
+            <a:off x="9697212" y="5577840"/>
+            <a:ext cx="1906524" cy="274320"/>
+          </a:xfrm>
+          <a:prstGeom prst="rect">
+            <a:avLst/>
+          </a:prstGeom>
+          <a:noFill/>
+          <a:ln/>
+        </p:spPr>
+        <p:txBody>
+          <a:bodyPr wrap="square" lIns="0" tIns="0" rIns="0" bIns="0" rtlCol="0" anchor="ctr"/>
+          <a:lstStyle/>
+          <a:p>
+            <a:pPr indent="0" marL="0">
+              <a:buNone/>
+            </a:pPr>
+            <a:r>
+              <a:rPr lang="en-US" sz="1150" b="1" dirty="0">
+                <a:solidFill>
+                  <a:srgbClr val="FFFFFF"/>
+                </a:solidFill>
+                <a:latin typeface="Calibri" pitchFamily="34" charset="0"/>
+                <a:ea typeface="Calibri" pitchFamily="34" charset="-122"/>
+                <a:cs typeface="Calibri" pitchFamily="34" charset="-120"/>
+              </a:rPr>
+              <a:t>Estudos</a:t>
+            </a:r>
+            <a:endParaRPr lang="en-US" sz="1150" dirty="0"/>
+          </a:p>
+        </p:txBody>
+      </p:sp>
+      <p:sp>
+        <p:nvSpPr>
+          <p:cNvPr id="41" name="Text 31"/>
+          <p:cNvSpPr txBox="1"/>
+          <p:nvPr/>
+        </p:nvSpPr>
+        <p:spPr>
+          <a:xfrm>
+            <a:off x="9697212" y="5870448"/>
+            <a:ext cx="1906524" cy="402336"/>
+          </a:xfrm>
+          <a:prstGeom prst="rect">
+            <a:avLst/>
+          </a:prstGeom>
+          <a:noFill/>
+          <a:ln/>
+        </p:spPr>
+        <p:txBody>
+          <a:bodyPr wrap="square" lIns="0" tIns="0" rIns="0" bIns="0" rtlCol="0" anchor="t"/>
+          <a:lstStyle/>
+          <a:p>
+            <a:pPr indent="0" marL="0">
+              <a:lnSpc>
+                <a:spcPct val="110000"/>
+              </a:lnSpc>
+              <a:buNone/>
+            </a:pPr>
+            <a:r>
+              <a:rPr lang="en-US" sz="900" dirty="0">
+                <a:solidFill>
+                  <a:srgbClr val="D8E4F4"/>
+                </a:solidFill>
+                <a:latin typeface="Calibri" pitchFamily="34" charset="0"/>
+                <a:ea typeface="Calibri" pitchFamily="34" charset="-122"/>
+                <a:cs typeface="Calibri" pitchFamily="34" charset="-120"/>
+              </a:rPr>
+              <a:t>Dado pronto para a reunião</a:t>
+            </a:r>
+            <a:endParaRPr lang="en-US" sz="900" dirty="0"/>
           </a:p>
         </p:txBody>
       </p:sp>

</xml_diff>

<commit_message>
Reforca os ganhos e destaca a frente de atuacao no one-pager
Inclui metas e comparativos como terceiro ganho (mes a mes e atingimento
contra o mes corrente), reescreve as descricoes em chave consultiva e
promove a frente de atuacao do recurso a bloco de destaque.

Co-Authored-By: Claude Opus 5 <noreply@anthropic.com>
Claude-Session: https://claude.ai/code/session_01LiBTDxNxgFCPijAoYiizN1
</commit_message>
<xml_diff>
--- a/apresentacoes/Planejamento_Ganhos.pptx
+++ b/apresentacoes/Planejamento_Ganhos.pptx
@@ -502,7 +502,7 @@
           <a:p>
             <a:r>
               <a:rPr lang="en-US" dirty="0"/>
-              <a:t>Mensagem central: o Planejamento (Willyan) assume o processo e todo o tratamento dos dados; a operação recebe a visão pronta e foca na ação. Hora a Hora: a operação passa a enxergar em tempo real o que está acontecendo e corrige a rota dentro do próprio turno, em vez de descobrir no dia seguinte. Dashboard D-1: N4 e N5 passam a ler o dia anterior na mesma régua — um só número, sem planilha paralela. O D-1 da N5 já foi entregue em 29/set; as demais visões saem em 05 e 09/out. Por trás das visões, o Willyan atua no desenvolvimento e na evolução dos processos, na automação dos relatórios e das rotinas operacionais, na identificação de oportunidades e gargalos, e nos estudos que levam dado — e não percepção — para as reuniões.</a:t>
+              <a:t>Mensagem central: o Willyan assume o processo, o tratamento dos dados e a construção das visões. A operação recebe a leitura pronta e decide. Hora a Hora: acompanhamento intradiário contra a meta do dia — dá para ver onde o ritmo cai, em qual carteira, e reagir no mesmo turno em vez de descobrir no dia seguinte. Dashboard D-1: dia anterior fechado com N4 e N5 na mesma régua, permitindo comparação direta entre carteiras sem planilha paralela. O D-1 da N5 foi entregue em 29/set; as demais saem em 05 e 09/out. Metas e comparativos: como os relatórios passam a carregar a meta, ganhamos visão mês a mês e atingimento contra o mês corrente — o que mostra tendência e distância da meta, não apenas a foto do dia. Por trás das visões, o Will atua no desenvolvimento e na evolução dos processos, na automação de relatórios e rotinas operacionais, na identificação de oportunidades e nos estudos que levam análise e recomendação para as reuniões. Os acessos às ferramentas já estão todos liberados — nada bloqueando o desenvolvimento.</a:t>
             </a:r>
             <a:endParaRPr lang="en-US" dirty="0"/>
           </a:p>
@@ -907,8 +907,8 @@
         </p:nvSpPr>
         <p:spPr>
           <a:xfrm>
-            <a:off x="566928" y="502920"/>
-            <a:ext cx="11055096" cy="237744"/>
+            <a:off x="566928" y="457200"/>
+            <a:ext cx="6858000" cy="237744"/>
           </a:xfrm>
           <a:prstGeom prst="rect">
             <a:avLst/>
@@ -946,7 +946,7 @@
         </p:nvSpPr>
         <p:spPr>
           <a:xfrm>
-            <a:off x="8924544" y="411480"/>
+            <a:off x="8924544" y="365760"/>
             <a:ext cx="2697480" cy="420624"/>
           </a:xfrm>
           <a:prstGeom prst="roundRect">
@@ -975,7 +975,7 @@
         </p:nvSpPr>
         <p:spPr>
           <a:xfrm>
-            <a:off x="9107424" y="512064"/>
+            <a:off x="9107424" y="466344"/>
             <a:ext cx="219456" cy="219456"/>
           </a:xfrm>
           <a:prstGeom prst="ellipse">
@@ -1003,7 +1003,7 @@
         </p:blipFill>
         <p:spPr>
           <a:xfrm>
-            <a:off x="9162288" y="566928"/>
+            <a:off x="9162288" y="521208"/>
             <a:ext cx="109728" cy="109728"/>
           </a:xfrm>
           <a:prstGeom prst="rect">
@@ -1019,7 +1019,7 @@
         </p:nvSpPr>
         <p:spPr>
           <a:xfrm>
-            <a:off x="9400032" y="411480"/>
+            <a:off x="9400032" y="365760"/>
             <a:ext cx="2057400" cy="420624"/>
           </a:xfrm>
           <a:prstGeom prst="rect">
@@ -1058,8 +1058,8 @@
         </p:nvSpPr>
         <p:spPr>
           <a:xfrm>
-            <a:off x="566928" y="841248"/>
-            <a:ext cx="8686800" cy="1051560"/>
+            <a:off x="566928" y="777240"/>
+            <a:ext cx="10881360" cy="566928"/>
           </a:xfrm>
           <a:prstGeom prst="rect">
             <a:avLst/>
@@ -1072,13 +1072,10 @@
           <a:lstStyle/>
           <a:p>
             <a:pPr indent="0" marL="0">
-              <a:lnSpc>
-                <a:spcPct val="104000"/>
-              </a:lnSpc>
               <a:buNone/>
             </a:pPr>
             <a:r>
-              <a:rPr lang="en-US" sz="3400" b="1" dirty="0">
+              <a:rPr lang="en-US" sz="2900" b="1" dirty="0">
                 <a:solidFill>
                   <a:srgbClr val="FFFFFF"/>
                 </a:solidFill>
@@ -1086,17 +1083,13 @@
                 <a:ea typeface="Cambria" pitchFamily="34" charset="-122"/>
                 <a:cs typeface="Cambria" pitchFamily="34" charset="-120"/>
               </a:rPr>
-              <a:t>O dado deixa de ser relatório
-</a:t>
+              <a:t>O dado deixa de ser relatório </a:t>
             </a:r>
             <a:pPr indent="0" marL="0">
-              <a:lnSpc>
-                <a:spcPct val="104000"/>
-              </a:lnSpc>
               <a:buNone/>
             </a:pPr>
             <a:r>
-              <a:rPr lang="en-US" sz="3400" b="1" dirty="0">
+              <a:rPr lang="en-US" sz="2900" b="1" dirty="0">
                 <a:solidFill>
                   <a:srgbClr val="E9A13B"/>
                 </a:solidFill>
@@ -1106,7 +1099,7 @@
               </a:rPr>
               <a:t>e vira decisão</a:t>
             </a:r>
-            <a:endParaRPr lang="en-US" sz="3400" dirty="0"/>
+            <a:endParaRPr lang="en-US" sz="2900" dirty="0"/>
           </a:p>
         </p:txBody>
       </p:sp>
@@ -1118,8 +1111,8 @@
         </p:nvSpPr>
         <p:spPr>
           <a:xfrm>
-            <a:off x="566928" y="2048256"/>
-            <a:ext cx="9601200" cy="292608"/>
+            <a:off x="566928" y="1371600"/>
+            <a:ext cx="10881360" cy="274320"/>
           </a:xfrm>
           <a:prstGeom prst="rect">
             <a:avLst/>
@@ -1135,7 +1128,7 @@
               <a:buNone/>
             </a:pPr>
             <a:r>
-              <a:rPr lang="en-US" sz="1400" dirty="0">
+              <a:rPr lang="en-US" sz="1350" dirty="0">
                 <a:solidFill>
                   <a:srgbClr val="D8E4F4"/>
                 </a:solidFill>
@@ -1143,9 +1136,9 @@
                 <a:ea typeface="Calibri" pitchFamily="34" charset="-122"/>
                 <a:cs typeface="Calibri" pitchFamily="34" charset="-120"/>
               </a:rPr>
-              <a:t>Willyan assume o processo e todo o tratamento dos dados. A operação recebe a visão pronta — e age.</a:t>
-            </a:r>
-            <a:endParaRPr lang="en-US" sz="1400" dirty="0"/>
+              <a:t>Willyan assume o processo, o tratamento dos dados e a construção das visões — agora com a meta dentro do relatório.</a:t>
+            </a:r>
+            <a:endParaRPr lang="en-US" sz="1350" dirty="0"/>
           </a:p>
         </p:txBody>
       </p:sp>
@@ -1157,29 +1150,29 @@
         </p:nvSpPr>
         <p:spPr>
           <a:xfrm>
-            <a:off x="566928" y="2560320"/>
-            <a:ext cx="5367528" cy="2523744"/>
+            <a:off x="566928" y="1828800"/>
+            <a:ext cx="3502152" cy="2340864"/>
           </a:xfrm>
           <a:prstGeom prst="roundRect">
             <a:avLst>
-              <a:gd name="adj" fmla="val 4348"/>
+              <a:gd name="adj" fmla="val 4688"/>
             </a:avLst>
           </a:prstGeom>
           <a:solidFill>
             <a:srgbClr val="FFFFFF">
-              <a:alpha val="11000"/>
+              <a:alpha val="9000"/>
             </a:srgbClr>
           </a:solidFill>
-          <a:ln w="19050">
+          <a:ln w="12700">
             <a:solidFill>
-              <a:srgbClr val="E9A13B"/>
+              <a:srgbClr val="31507F"/>
             </a:solidFill>
             <a:prstDash val="solid"/>
           </a:ln>
           <a:effectLst>
-            <a:outerShdw sx="100000" sy="100000" kx="0" ky="0" algn="bl" rotWithShape="0" blurRad="203200" dist="50800" dir="5400000">
+            <a:outerShdw sx="100000" sy="100000" kx="0" ky="0" algn="bl" rotWithShape="0" blurRad="177800" dist="38100" dir="5400000">
               <a:srgbClr val="030913">
-                <a:alpha val="40000"/>
+                <a:alpha val="35000"/>
               </a:srgbClr>
             </a:outerShdw>
           </a:effectLst>
@@ -1193,8 +1186,8 @@
         </p:nvSpPr>
         <p:spPr>
           <a:xfrm>
-            <a:off x="969264" y="2852928"/>
-            <a:ext cx="4562856" cy="237744"/>
+            <a:off x="877824" y="2066544"/>
+            <a:ext cx="2880360" cy="219456"/>
           </a:xfrm>
           <a:prstGeom prst="rect">
             <a:avLst/>
@@ -1210,7 +1203,7 @@
               <a:buNone/>
             </a:pPr>
             <a:r>
-              <a:rPr lang="en-US" sz="1050" b="1" spc="180" kern="0" dirty="0">
+              <a:rPr lang="en-US" sz="950" b="1" spc="150" kern="0" dirty="0">
                 <a:solidFill>
                   <a:srgbClr val="E9A13B"/>
                 </a:solidFill>
@@ -1220,7 +1213,7 @@
               </a:rPr>
               <a:t>HORA A HORA</a:t>
             </a:r>
-            <a:endParaRPr lang="en-US" sz="1050" dirty="0"/>
+            <a:endParaRPr lang="en-US" sz="950" dirty="0"/>
           </a:p>
         </p:txBody>
       </p:sp>
@@ -1232,8 +1225,8 @@
         </p:nvSpPr>
         <p:spPr>
           <a:xfrm>
-            <a:off x="969264" y="3200400"/>
-            <a:ext cx="868680" cy="868680"/>
+            <a:off x="877824" y="2340864"/>
+            <a:ext cx="658368" cy="658368"/>
           </a:xfrm>
           <a:prstGeom prst="ellipse">
             <a:avLst/>
@@ -1260,8 +1253,8 @@
         </p:blipFill>
         <p:spPr>
           <a:xfrm>
-            <a:off x="1202436" y="3433572"/>
-            <a:ext cx="402336" cy="402336"/>
+            <a:off x="1060704" y="2523744"/>
+            <a:ext cx="292608" cy="292608"/>
           </a:xfrm>
           <a:prstGeom prst="rect">
             <a:avLst/>
@@ -1276,8 +1269,8 @@
         </p:nvSpPr>
         <p:spPr>
           <a:xfrm>
-            <a:off x="2029968" y="3346704"/>
-            <a:ext cx="3502152" cy="566928"/>
+            <a:off x="1664208" y="2340864"/>
+            <a:ext cx="2112264" cy="658368"/>
           </a:xfrm>
           <a:prstGeom prst="rect">
             <a:avLst/>
@@ -1293,7 +1286,7 @@
               <a:buNone/>
             </a:pPr>
             <a:r>
-              <a:rPr lang="en-US" sz="3000" b="1" dirty="0">
+              <a:rPr lang="en-US" sz="2000" b="1" dirty="0">
                 <a:solidFill>
                   <a:srgbClr val="FFFFFF"/>
                 </a:solidFill>
@@ -1303,7 +1296,7 @@
               </a:rPr>
               <a:t>Tempo real</a:t>
             </a:r>
-            <a:endParaRPr lang="en-US" sz="3000" dirty="0"/>
+            <a:endParaRPr lang="en-US" sz="2000" dirty="0"/>
           </a:p>
         </p:txBody>
       </p:sp>
@@ -1315,8 +1308,8 @@
         </p:nvSpPr>
         <p:spPr>
           <a:xfrm>
-            <a:off x="969264" y="4242816"/>
-            <a:ext cx="4562856" cy="548640"/>
+            <a:off x="877824" y="3090672"/>
+            <a:ext cx="2880360" cy="548640"/>
           </a:xfrm>
           <a:prstGeom prst="rect">
             <a:avLst/>
@@ -1330,12 +1323,12 @@
           <a:p>
             <a:pPr indent="0" marL="0">
               <a:lnSpc>
-                <a:spcPct val="116000"/>
+                <a:spcPct val="114000"/>
               </a:lnSpc>
               <a:buNone/>
             </a:pPr>
             <a:r>
-              <a:rPr lang="en-US" sz="1350" dirty="0">
+              <a:rPr lang="en-US" sz="1050" dirty="0">
                 <a:solidFill>
                   <a:srgbClr val="D8E4F4"/>
                 </a:solidFill>
@@ -1343,9 +1336,9 @@
                 <a:ea typeface="Calibri" pitchFamily="34" charset="-122"/>
                 <a:cs typeface="Calibri" pitchFamily="34" charset="-120"/>
               </a:rPr>
-              <a:t>A operação enxerga o que está acontecendo agora e corrige a rota no mesmo turno.</a:t>
-            </a:r>
-            <a:endParaRPr lang="en-US" sz="1350" dirty="0"/>
+              <a:t>Acompanhamento contra a meta do dia: aponta onde o ritmo cai e em qual carteira, a tempo de reagir.</a:t>
+            </a:r>
+            <a:endParaRPr lang="en-US" sz="1050" dirty="0"/>
           </a:p>
         </p:txBody>
       </p:sp>
@@ -1357,8 +1350,8 @@
         </p:nvSpPr>
         <p:spPr>
           <a:xfrm>
-            <a:off x="969264" y="4791456"/>
-            <a:ext cx="4562856" cy="237744"/>
+            <a:off x="877824" y="3785616"/>
+            <a:ext cx="2880360" cy="201168"/>
           </a:xfrm>
           <a:prstGeom prst="rect">
             <a:avLst/>
@@ -1374,7 +1367,7 @@
               <a:buNone/>
             </a:pPr>
             <a:r>
-              <a:rPr lang="en-US" sz="1050" dirty="0">
+              <a:rPr lang="en-US" sz="900" dirty="0">
                 <a:solidFill>
                   <a:srgbClr val="93A9C6"/>
                 </a:solidFill>
@@ -1382,9 +1375,9 @@
                 <a:ea typeface="Calibri" pitchFamily="34" charset="-122"/>
                 <a:cs typeface="Calibri" pitchFamily="34" charset="-120"/>
               </a:rPr>
-              <a:t>Em desenvolvimento  ·  N5 e N4  ·  05 e 09/out</a:t>
-            </a:r>
-            <a:endParaRPr lang="en-US" sz="1050" dirty="0"/>
+              <a:t>Em desenvolvimento  ·  05 e 09/out</a:t>
+            </a:r>
+            <a:endParaRPr lang="en-US" sz="900" dirty="0"/>
           </a:p>
         </p:txBody>
       </p:sp>
@@ -1396,17 +1389,17 @@
         </p:nvSpPr>
         <p:spPr>
           <a:xfrm>
-            <a:off x="6254496" y="2560320"/>
-            <a:ext cx="5367528" cy="2523744"/>
+            <a:off x="4343400" y="1828800"/>
+            <a:ext cx="3502152" cy="2340864"/>
           </a:xfrm>
           <a:prstGeom prst="roundRect">
             <a:avLst>
-              <a:gd name="adj" fmla="val 4348"/>
+              <a:gd name="adj" fmla="val 4688"/>
             </a:avLst>
           </a:prstGeom>
           <a:solidFill>
             <a:srgbClr val="FFFFFF">
-              <a:alpha val="8000"/>
+              <a:alpha val="9000"/>
             </a:srgbClr>
           </a:solidFill>
           <a:ln w="12700">
@@ -1416,9 +1409,9 @@
             <a:prstDash val="solid"/>
           </a:ln>
           <a:effectLst>
-            <a:outerShdw sx="100000" sy="100000" kx="0" ky="0" algn="bl" rotWithShape="0" blurRad="203200" dist="50800" dir="5400000">
+            <a:outerShdw sx="100000" sy="100000" kx="0" ky="0" algn="bl" rotWithShape="0" blurRad="177800" dist="38100" dir="5400000">
               <a:srgbClr val="030913">
-                <a:alpha val="40000"/>
+                <a:alpha val="35000"/>
               </a:srgbClr>
             </a:outerShdw>
           </a:effectLst>
@@ -1432,8 +1425,8 @@
         </p:nvSpPr>
         <p:spPr>
           <a:xfrm>
-            <a:off x="6656832" y="2852928"/>
-            <a:ext cx="4562856" cy="237744"/>
+            <a:off x="4654296" y="2066544"/>
+            <a:ext cx="2880360" cy="219456"/>
           </a:xfrm>
           <a:prstGeom prst="rect">
             <a:avLst/>
@@ -1449,9 +1442,9 @@
               <a:buNone/>
             </a:pPr>
             <a:r>
-              <a:rPr lang="en-US" sz="1050" b="1" spc="180" kern="0" dirty="0">
+              <a:rPr lang="en-US" sz="950" b="1" spc="150" kern="0" dirty="0">
                 <a:solidFill>
-                  <a:srgbClr val="93A9C6"/>
+                  <a:srgbClr val="E9A13B"/>
                 </a:solidFill>
                 <a:latin typeface="Calibri" pitchFamily="34" charset="0"/>
                 <a:ea typeface="Calibri" pitchFamily="34" charset="-122"/>
@@ -1459,7 +1452,7 @@
               </a:rPr>
               <a:t>DASHBOARD D-1</a:t>
             </a:r>
-            <a:endParaRPr lang="en-US" sz="1050" dirty="0"/>
+            <a:endParaRPr lang="en-US" sz="950" dirty="0"/>
           </a:p>
         </p:txBody>
       </p:sp>
@@ -1471,14 +1464,14 @@
         </p:nvSpPr>
         <p:spPr>
           <a:xfrm>
-            <a:off x="6656832" y="3200400"/>
-            <a:ext cx="868680" cy="868680"/>
+            <a:off x="4654296" y="2340864"/>
+            <a:ext cx="658368" cy="658368"/>
           </a:xfrm>
           <a:prstGeom prst="ellipse">
             <a:avLst/>
           </a:prstGeom>
           <a:solidFill>
-            <a:srgbClr val="FFFFFF"/>
+            <a:srgbClr val="E9A13B"/>
           </a:solidFill>
           <a:ln/>
         </p:spPr>
@@ -1499,8 +1492,8 @@
         </p:blipFill>
         <p:spPr>
           <a:xfrm>
-            <a:off x="6890004" y="3433572"/>
-            <a:ext cx="402336" cy="402336"/>
+            <a:off x="4837176" y="2523744"/>
+            <a:ext cx="292608" cy="292608"/>
           </a:xfrm>
           <a:prstGeom prst="rect">
             <a:avLst/>
@@ -1515,8 +1508,8 @@
         </p:nvSpPr>
         <p:spPr>
           <a:xfrm>
-            <a:off x="7717536" y="3346704"/>
-            <a:ext cx="3502152" cy="566928"/>
+            <a:off x="5440680" y="2340864"/>
+            <a:ext cx="2112264" cy="658368"/>
           </a:xfrm>
           <a:prstGeom prst="rect">
             <a:avLst/>
@@ -1532,7 +1525,7 @@
               <a:buNone/>
             </a:pPr>
             <a:r>
-              <a:rPr lang="en-US" sz="3000" b="1" dirty="0">
+              <a:rPr lang="en-US" sz="2000" b="1" dirty="0">
                 <a:solidFill>
                   <a:srgbClr val="FFFFFF"/>
                 </a:solidFill>
@@ -1542,7 +1535,7 @@
               </a:rPr>
               <a:t>Um só número</a:t>
             </a:r>
-            <a:endParaRPr lang="en-US" sz="3000" dirty="0"/>
+            <a:endParaRPr lang="en-US" sz="2000" dirty="0"/>
           </a:p>
         </p:txBody>
       </p:sp>
@@ -1554,8 +1547,8 @@
         </p:nvSpPr>
         <p:spPr>
           <a:xfrm>
-            <a:off x="6656832" y="4242816"/>
-            <a:ext cx="4562856" cy="548640"/>
+            <a:off x="4654296" y="3090672"/>
+            <a:ext cx="2880360" cy="548640"/>
           </a:xfrm>
           <a:prstGeom prst="rect">
             <a:avLst/>
@@ -1569,12 +1562,12 @@
           <a:p>
             <a:pPr indent="0" marL="0">
               <a:lnSpc>
-                <a:spcPct val="116000"/>
+                <a:spcPct val="114000"/>
               </a:lnSpc>
               <a:buNone/>
             </a:pPr>
             <a:r>
-              <a:rPr lang="en-US" sz="1350" dirty="0">
+              <a:rPr lang="en-US" sz="1050" dirty="0">
                 <a:solidFill>
                   <a:srgbClr val="D8E4F4"/>
                 </a:solidFill>
@@ -1582,9 +1575,9 @@
                 <a:ea typeface="Calibri" pitchFamily="34" charset="-122"/>
                 <a:cs typeface="Calibri" pitchFamily="34" charset="-120"/>
               </a:rPr>
-              <a:t>N4 e N5 na mesma régua: o dia anterior fechado e comparável, sem planilha paralela.</a:t>
-            </a:r>
-            <a:endParaRPr lang="en-US" sz="1350" dirty="0"/>
+              <a:t>Dia anterior fechado com N4 e N5 na mesma régua: comparação direta entre carteiras, sem planilha paralela.</a:t>
+            </a:r>
+            <a:endParaRPr lang="en-US" sz="1050" dirty="0"/>
           </a:p>
         </p:txBody>
       </p:sp>
@@ -1596,8 +1589,8 @@
         </p:nvSpPr>
         <p:spPr>
           <a:xfrm>
-            <a:off x="6656832" y="4791456"/>
-            <a:ext cx="4562856" cy="237744"/>
+            <a:off x="4654296" y="3785616"/>
+            <a:ext cx="2880360" cy="201168"/>
           </a:xfrm>
           <a:prstGeom prst="rect">
             <a:avLst/>
@@ -1613,7 +1606,7 @@
               <a:buNone/>
             </a:pPr>
             <a:r>
-              <a:rPr lang="en-US" sz="1050" dirty="0">
+              <a:rPr lang="en-US" sz="900" dirty="0">
                 <a:solidFill>
                   <a:srgbClr val="93A9C6"/>
                 </a:solidFill>
@@ -1621,9 +1614,9 @@
                 <a:ea typeface="Calibri" pitchFamily="34" charset="-122"/>
                 <a:cs typeface="Calibri" pitchFamily="34" charset="-120"/>
               </a:rPr>
-              <a:t>N5 entregue em 29/set  ·  mais 2 em 05 e 09/out</a:t>
-            </a:r>
-            <a:endParaRPr lang="en-US" sz="1050" dirty="0"/>
+              <a:t>N5 entregue em 29/set  ·  mais 2 em out</a:t>
+            </a:r>
+            <a:endParaRPr lang="en-US" sz="900" dirty="0"/>
           </a:p>
         </p:txBody>
       </p:sp>
@@ -1635,17 +1628,17 @@
         </p:nvSpPr>
         <p:spPr>
           <a:xfrm>
-            <a:off x="566928" y="5358384"/>
-            <a:ext cx="11055096" cy="1042416"/>
+            <a:off x="8119872" y="1828800"/>
+            <a:ext cx="3502152" cy="2340864"/>
           </a:xfrm>
           <a:prstGeom prst="roundRect">
             <a:avLst>
-              <a:gd name="adj" fmla="val 8772"/>
+              <a:gd name="adj" fmla="val 4688"/>
             </a:avLst>
           </a:prstGeom>
           <a:solidFill>
             <a:srgbClr val="FFFFFF">
-              <a:alpha val="6000"/>
+              <a:alpha val="9000"/>
             </a:srgbClr>
           </a:solidFill>
           <a:ln w="12700">
@@ -1654,6 +1647,13 @@
             </a:solidFill>
             <a:prstDash val="solid"/>
           </a:ln>
+          <a:effectLst>
+            <a:outerShdw sx="100000" sy="100000" kx="0" ky="0" algn="bl" rotWithShape="0" blurRad="177800" dist="38100" dir="5400000">
+              <a:srgbClr val="030913">
+                <a:alpha val="35000"/>
+              </a:srgbClr>
+            </a:outerShdw>
+          </a:effectLst>
         </p:spPr>
       </p:sp>
       <p:sp>
@@ -1664,8 +1664,8 @@
         </p:nvSpPr>
         <p:spPr>
           <a:xfrm>
-            <a:off x="896112" y="5358384"/>
-            <a:ext cx="1097280" cy="1042416"/>
+            <a:off x="8430768" y="2066544"/>
+            <a:ext cx="2880360" cy="219456"/>
           </a:xfrm>
           <a:prstGeom prst="rect">
             <a:avLst/>
@@ -1674,17 +1674,14 @@
           <a:ln/>
         </p:spPr>
         <p:txBody>
-          <a:bodyPr wrap="square" lIns="0" tIns="0" rIns="0" bIns="0" rtlCol="0" anchor="ctr"/>
+          <a:bodyPr wrap="square" lIns="0" tIns="0" rIns="0" bIns="0" rtlCol="0" anchor="t"/>
           <a:lstStyle/>
           <a:p>
             <a:pPr indent="0" marL="0">
-              <a:lnSpc>
-                <a:spcPct val="105000"/>
-              </a:lnSpc>
               <a:buNone/>
             </a:pPr>
             <a:r>
-              <a:rPr lang="en-US" sz="1000" b="1" spc="130" kern="0" dirty="0">
+              <a:rPr lang="en-US" sz="950" b="1" spc="150" kern="0" dirty="0">
                 <a:solidFill>
                   <a:srgbClr val="E9A13B"/>
                 </a:solidFill>
@@ -1692,19 +1689,238 @@
                 <a:ea typeface="Calibri" pitchFamily="34" charset="-122"/>
                 <a:cs typeface="Calibri" pitchFamily="34" charset="-120"/>
               </a:rPr>
-              <a:t>POR TRÁS</a:t>
-            </a:r>
-            <a:endParaRPr lang="en-US" sz="1000" dirty="0"/>
-          </a:p>
+              <a:t>METAS E COMPARATIVOS</a:t>
+            </a:r>
+            <a:endParaRPr lang="en-US" sz="950" dirty="0"/>
+          </a:p>
+        </p:txBody>
+      </p:sp>
+      <p:sp>
+        <p:nvSpPr>
+          <p:cNvPr id="26" name="Shape 20"/>
+          <p:cNvSpPr/>
+          <p:nvPr/>
+        </p:nvSpPr>
+        <p:spPr>
+          <a:xfrm>
+            <a:off x="8430768" y="2340864"/>
+            <a:ext cx="658368" cy="658368"/>
+          </a:xfrm>
+          <a:prstGeom prst="ellipse">
+            <a:avLst/>
+          </a:prstGeom>
+          <a:solidFill>
+            <a:srgbClr val="E9A13B"/>
+          </a:solidFill>
+          <a:ln/>
+        </p:spPr>
+      </p:sp>
+      <p:pic>
+        <p:nvPicPr>
+          <p:cNvPr id="27" name="Image 4" descr="preencoded.png">    </p:cNvPr>
+          <p:cNvPicPr>
+            <a:picLocks noChangeAspect="1"/>
+          </p:cNvPicPr>
+          <p:nvPr/>
+        </p:nvPicPr>
+        <p:blipFill>
+          <a:blip r:embed="rId5"/>
+          <a:stretch>
+            <a:fillRect/>
+          </a:stretch>
+        </p:blipFill>
+        <p:spPr>
+          <a:xfrm>
+            <a:off x="8613648" y="2523744"/>
+            <a:ext cx="292608" cy="292608"/>
+          </a:xfrm>
+          <a:prstGeom prst="rect">
+            <a:avLst/>
+          </a:prstGeom>
+        </p:spPr>
+      </p:pic>
+      <p:sp>
+        <p:nvSpPr>
+          <p:cNvPr id="28" name="Text 21"/>
+          <p:cNvSpPr txBox="1"/>
+          <p:nvPr/>
+        </p:nvSpPr>
+        <p:spPr>
+          <a:xfrm>
+            <a:off x="9217152" y="2340864"/>
+            <a:ext cx="2112264" cy="658368"/>
+          </a:xfrm>
+          <a:prstGeom prst="rect">
+            <a:avLst/>
+          </a:prstGeom>
+          <a:noFill/>
+          <a:ln/>
+        </p:spPr>
+        <p:txBody>
+          <a:bodyPr wrap="square" lIns="0" tIns="0" rIns="0" bIns="0" rtlCol="0" anchor="ctr"/>
+          <a:lstStyle/>
+          <a:p>
+            <a:pPr indent="0" marL="0">
+              <a:buNone/>
+            </a:pPr>
+            <a:r>
+              <a:rPr lang="en-US" sz="2000" b="1" dirty="0">
+                <a:solidFill>
+                  <a:srgbClr val="FFFFFF"/>
+                </a:solidFill>
+                <a:latin typeface="Cambria" pitchFamily="34" charset="0"/>
+                <a:ea typeface="Cambria" pitchFamily="34" charset="-122"/>
+                <a:cs typeface="Cambria" pitchFamily="34" charset="-120"/>
+              </a:rPr>
+              <a:t>Atingimento</a:t>
+            </a:r>
+            <a:endParaRPr lang="en-US" sz="2000" dirty="0"/>
+          </a:p>
+        </p:txBody>
+      </p:sp>
+      <p:sp>
+        <p:nvSpPr>
+          <p:cNvPr id="29" name="Text 22"/>
+          <p:cNvSpPr txBox="1"/>
+          <p:nvPr/>
+        </p:nvSpPr>
+        <p:spPr>
+          <a:xfrm>
+            <a:off x="8430768" y="3090672"/>
+            <a:ext cx="2880360" cy="548640"/>
+          </a:xfrm>
+          <a:prstGeom prst="rect">
+            <a:avLst/>
+          </a:prstGeom>
+          <a:noFill/>
+          <a:ln/>
+        </p:spPr>
+        <p:txBody>
+          <a:bodyPr wrap="square" lIns="0" tIns="0" rIns="0" bIns="0" rtlCol="0" anchor="t"/>
+          <a:lstStyle/>
           <a:p>
             <a:pPr indent="0" marL="0">
               <a:lnSpc>
-                <a:spcPct val="105000"/>
+                <a:spcPct val="114000"/>
               </a:lnSpc>
               <a:buNone/>
             </a:pPr>
             <a:r>
-              <a:rPr lang="en-US" sz="1000" b="1" spc="130" kern="0" dirty="0">
+              <a:rPr lang="en-US" sz="1050" dirty="0">
+                <a:solidFill>
+                  <a:srgbClr val="D8E4F4"/>
+                </a:solidFill>
+                <a:latin typeface="Calibri" pitchFamily="34" charset="0"/>
+                <a:ea typeface="Calibri" pitchFamily="34" charset="-122"/>
+                <a:cs typeface="Calibri" pitchFamily="34" charset="-120"/>
+              </a:rPr>
+              <a:t>Mês a mês e contra o mês corrente: mostra a tendência e a distância da meta, não só a foto do dia.</a:t>
+            </a:r>
+            <a:endParaRPr lang="en-US" sz="1050" dirty="0"/>
+          </a:p>
+        </p:txBody>
+      </p:sp>
+      <p:sp>
+        <p:nvSpPr>
+          <p:cNvPr id="30" name="Text 23"/>
+          <p:cNvSpPr txBox="1"/>
+          <p:nvPr/>
+        </p:nvSpPr>
+        <p:spPr>
+          <a:xfrm>
+            <a:off x="8430768" y="3785616"/>
+            <a:ext cx="2880360" cy="201168"/>
+          </a:xfrm>
+          <a:prstGeom prst="rect">
+            <a:avLst/>
+          </a:prstGeom>
+          <a:noFill/>
+          <a:ln/>
+        </p:spPr>
+        <p:txBody>
+          <a:bodyPr wrap="square" lIns="0" tIns="0" rIns="0" bIns="0" rtlCol="0" anchor="t"/>
+          <a:lstStyle/>
+          <a:p>
+            <a:pPr indent="0" marL="0">
+              <a:buNone/>
+            </a:pPr>
+            <a:r>
+              <a:rPr lang="en-US" sz="900" dirty="0">
+                <a:solidFill>
+                  <a:srgbClr val="93A9C6"/>
+                </a:solidFill>
+                <a:latin typeface="Calibri" pitchFamily="34" charset="0"/>
+                <a:ea typeface="Calibri" pitchFamily="34" charset="-122"/>
+                <a:cs typeface="Calibri" pitchFamily="34" charset="-120"/>
+              </a:rPr>
+              <a:t>Aplicado ao Hora a Hora e ao D-1</a:t>
+            </a:r>
+            <a:endParaRPr lang="en-US" sz="900" dirty="0"/>
+          </a:p>
+        </p:txBody>
+      </p:sp>
+      <p:sp>
+        <p:nvSpPr>
+          <p:cNvPr id="31" name="Shape 24"/>
+          <p:cNvSpPr/>
+          <p:nvPr/>
+        </p:nvSpPr>
+        <p:spPr>
+          <a:xfrm>
+            <a:off x="566928" y="4370832"/>
+            <a:ext cx="11055096" cy="1993392"/>
+          </a:xfrm>
+          <a:prstGeom prst="roundRect">
+            <a:avLst>
+              <a:gd name="adj" fmla="val 5505"/>
+            </a:avLst>
+          </a:prstGeom>
+          <a:solidFill>
+            <a:srgbClr val="E9A13B">
+              <a:alpha val="12000"/>
+            </a:srgbClr>
+          </a:solidFill>
+          <a:ln w="22225">
+            <a:solidFill>
+              <a:srgbClr val="E9A13B"/>
+            </a:solidFill>
+            <a:prstDash val="solid"/>
+          </a:ln>
+          <a:effectLst>
+            <a:outerShdw sx="100000" sy="100000" kx="0" ky="0" algn="bl" rotWithShape="0" blurRad="228600" dist="50800" dir="5400000">
+              <a:srgbClr val="030913">
+                <a:alpha val="40000"/>
+              </a:srgbClr>
+            </a:outerShdw>
+          </a:effectLst>
+        </p:spPr>
+      </p:sp>
+      <p:sp>
+        <p:nvSpPr>
+          <p:cNvPr id="32" name="Text 25"/>
+          <p:cNvSpPr txBox="1"/>
+          <p:nvPr/>
+        </p:nvSpPr>
+        <p:spPr>
+          <a:xfrm>
+            <a:off x="950976" y="4608576"/>
+            <a:ext cx="6858000" cy="274320"/>
+          </a:xfrm>
+          <a:prstGeom prst="rect">
+            <a:avLst/>
+          </a:prstGeom>
+          <a:noFill/>
+          <a:ln/>
+        </p:spPr>
+        <p:txBody>
+          <a:bodyPr wrap="square" lIns="0" tIns="0" rIns="0" bIns="0" rtlCol="0" anchor="t"/>
+          <a:lstStyle/>
+          <a:p>
+            <a:pPr indent="0" marL="0">
+              <a:buNone/>
+            </a:pPr>
+            <a:r>
+              <a:rPr lang="en-US" sz="1150" b="1" spc="220" kern="0" dirty="0">
                 <a:solidFill>
                   <a:srgbClr val="E9A13B"/>
                 </a:solidFill>
@@ -1712,22 +1928,22 @@
                 <a:ea typeface="Calibri" pitchFamily="34" charset="-122"/>
                 <a:cs typeface="Calibri" pitchFamily="34" charset="-120"/>
               </a:rPr>
-              <a:t>DISSO</a:t>
-            </a:r>
-            <a:endParaRPr lang="en-US" sz="1000" dirty="0"/>
-          </a:p>
-        </p:txBody>
-      </p:sp>
-      <p:sp>
-        <p:nvSpPr>
-          <p:cNvPr id="26" name="Shape 20"/>
+              <a:t>O QUE O WILL ENTREGA POR TRÁS DAS VISÕES</a:t>
+            </a:r>
+            <a:endParaRPr lang="en-US" sz="1150" dirty="0"/>
+          </a:p>
+        </p:txBody>
+      </p:sp>
+      <p:sp>
+        <p:nvSpPr>
+          <p:cNvPr id="33" name="Shape 26"/>
           <p:cNvSpPr/>
           <p:nvPr/>
         </p:nvSpPr>
         <p:spPr>
           <a:xfrm>
-            <a:off x="1984248" y="5596128"/>
-            <a:ext cx="256032" cy="256032"/>
+            <a:off x="950976" y="5047488"/>
+            <a:ext cx="420624" cy="420624"/>
           </a:xfrm>
           <a:prstGeom prst="ellipse">
             <a:avLst/>
@@ -1740,22 +1956,22 @@
       </p:sp>
       <p:pic>
         <p:nvPicPr>
-          <p:cNvPr id="27" name="Image 4" descr="preencoded.png">    </p:cNvPr>
+          <p:cNvPr id="34" name="Image 5" descr="preencoded.png">    </p:cNvPr>
           <p:cNvPicPr>
             <a:picLocks noChangeAspect="1"/>
           </p:cNvPicPr>
           <p:nvPr/>
         </p:nvPicPr>
         <p:blipFill>
-          <a:blip r:embed="rId5"/>
+          <a:blip r:embed="rId6"/>
           <a:stretch>
             <a:fillRect/>
           </a:stretch>
         </p:blipFill>
         <p:spPr>
           <a:xfrm>
-            <a:off x="2048256" y="5660136"/>
-            <a:ext cx="128016" cy="128016"/>
+            <a:off x="1065276" y="5161788"/>
+            <a:ext cx="192024" cy="192024"/>
           </a:xfrm>
           <a:prstGeom prst="rect">
             <a:avLst/>
@@ -1764,14 +1980,14 @@
       </p:pic>
       <p:sp>
         <p:nvSpPr>
-          <p:cNvPr id="28" name="Text 21"/>
+          <p:cNvPr id="35" name="Text 27"/>
           <p:cNvSpPr txBox="1"/>
           <p:nvPr/>
         </p:nvSpPr>
         <p:spPr>
           <a:xfrm>
-            <a:off x="2331720" y="5577840"/>
-            <a:ext cx="1906524" cy="274320"/>
+            <a:off x="950976" y="5577840"/>
+            <a:ext cx="2393442" cy="274320"/>
           </a:xfrm>
           <a:prstGeom prst="rect">
             <a:avLst/>
@@ -1780,14 +1996,14 @@
           <a:ln/>
         </p:spPr>
         <p:txBody>
-          <a:bodyPr wrap="square" lIns="0" tIns="0" rIns="0" bIns="0" rtlCol="0" anchor="ctr"/>
+          <a:bodyPr wrap="square" lIns="0" tIns="0" rIns="0" bIns="0" rtlCol="0" anchor="t"/>
           <a:lstStyle/>
           <a:p>
             <a:pPr indent="0" marL="0">
               <a:buNone/>
             </a:pPr>
             <a:r>
-              <a:rPr lang="en-US" sz="1150" b="1" dirty="0">
+              <a:rPr lang="en-US" sz="1300" b="1" dirty="0">
                 <a:solidFill>
                   <a:srgbClr val="FFFFFF"/>
                 </a:solidFill>
@@ -1797,20 +2013,20 @@
               </a:rPr>
               <a:t>Desenvolvimento</a:t>
             </a:r>
-            <a:endParaRPr lang="en-US" sz="1150" dirty="0"/>
-          </a:p>
-        </p:txBody>
-      </p:sp>
-      <p:sp>
-        <p:nvSpPr>
-          <p:cNvPr id="29" name="Text 22"/>
+            <a:endParaRPr lang="en-US" sz="1300" dirty="0"/>
+          </a:p>
+        </p:txBody>
+      </p:sp>
+      <p:sp>
+        <p:nvSpPr>
+          <p:cNvPr id="36" name="Text 28"/>
           <p:cNvSpPr txBox="1"/>
           <p:nvPr/>
         </p:nvSpPr>
         <p:spPr>
           <a:xfrm>
-            <a:off x="2331720" y="5870448"/>
-            <a:ext cx="1906524" cy="402336"/>
+            <a:off x="950976" y="5870448"/>
+            <a:ext cx="2393442" cy="402336"/>
           </a:xfrm>
           <a:prstGeom prst="rect">
             <a:avLst/>
@@ -1829,7 +2045,7 @@
               <a:buNone/>
             </a:pPr>
             <a:r>
-              <a:rPr lang="en-US" sz="900" dirty="0">
+              <a:rPr lang="en-US" sz="1050" dirty="0">
                 <a:solidFill>
                   <a:srgbClr val="D8E4F4"/>
                 </a:solidFill>
@@ -1837,22 +2053,22 @@
                 <a:ea typeface="Calibri" pitchFamily="34" charset="-122"/>
                 <a:cs typeface="Calibri" pitchFamily="34" charset="-120"/>
               </a:rPr>
-              <a:t>Constrói e evolui processos</a:t>
-            </a:r>
-            <a:endParaRPr lang="en-US" sz="900" dirty="0"/>
-          </a:p>
-        </p:txBody>
-      </p:sp>
-      <p:sp>
-        <p:nvSpPr>
-          <p:cNvPr id="30" name="Shape 23"/>
+              <a:t>Constrói e evolui as visões junto com a operação</a:t>
+            </a:r>
+            <a:endParaRPr lang="en-US" sz="1050" dirty="0"/>
+          </a:p>
+        </p:txBody>
+      </p:sp>
+      <p:sp>
+        <p:nvSpPr>
+          <p:cNvPr id="37" name="Shape 29"/>
           <p:cNvSpPr/>
           <p:nvPr/>
         </p:nvSpPr>
         <p:spPr>
           <a:xfrm>
-            <a:off x="4439412" y="5596128"/>
-            <a:ext cx="256032" cy="256032"/>
+            <a:off x="3582162" y="5047488"/>
+            <a:ext cx="420624" cy="420624"/>
           </a:xfrm>
           <a:prstGeom prst="ellipse">
             <a:avLst/>
@@ -1865,22 +2081,22 @@
       </p:sp>
       <p:pic>
         <p:nvPicPr>
-          <p:cNvPr id="31" name="Image 5" descr="preencoded.png">    </p:cNvPr>
+          <p:cNvPr id="38" name="Image 6" descr="preencoded.png">    </p:cNvPr>
           <p:cNvPicPr>
             <a:picLocks noChangeAspect="1"/>
           </p:cNvPicPr>
           <p:nvPr/>
         </p:nvPicPr>
         <p:blipFill>
-          <a:blip r:embed="rId6"/>
+          <a:blip r:embed="rId7"/>
           <a:stretch>
             <a:fillRect/>
           </a:stretch>
         </p:blipFill>
         <p:spPr>
           <a:xfrm>
-            <a:off x="4503420" y="5660136"/>
-            <a:ext cx="128016" cy="128016"/>
+            <a:off x="3696462" y="5161788"/>
+            <a:ext cx="192024" cy="192024"/>
           </a:xfrm>
           <a:prstGeom prst="rect">
             <a:avLst/>
@@ -1889,14 +2105,14 @@
       </p:pic>
       <p:sp>
         <p:nvSpPr>
-          <p:cNvPr id="32" name="Text 24"/>
+          <p:cNvPr id="39" name="Text 30"/>
           <p:cNvSpPr txBox="1"/>
           <p:nvPr/>
         </p:nvSpPr>
         <p:spPr>
           <a:xfrm>
-            <a:off x="4786884" y="5577840"/>
-            <a:ext cx="1906524" cy="274320"/>
+            <a:off x="3582162" y="5577840"/>
+            <a:ext cx="2393442" cy="274320"/>
           </a:xfrm>
           <a:prstGeom prst="rect">
             <a:avLst/>
@@ -1905,14 +2121,14 @@
           <a:ln/>
         </p:spPr>
         <p:txBody>
-          <a:bodyPr wrap="square" lIns="0" tIns="0" rIns="0" bIns="0" rtlCol="0" anchor="ctr"/>
+          <a:bodyPr wrap="square" lIns="0" tIns="0" rIns="0" bIns="0" rtlCol="0" anchor="t"/>
           <a:lstStyle/>
           <a:p>
             <a:pPr indent="0" marL="0">
               <a:buNone/>
             </a:pPr>
             <a:r>
-              <a:rPr lang="en-US" sz="1150" b="1" dirty="0">
+              <a:rPr lang="en-US" sz="1300" b="1" dirty="0">
                 <a:solidFill>
                   <a:srgbClr val="FFFFFF"/>
                 </a:solidFill>
@@ -1922,20 +2138,20 @@
               </a:rPr>
               <a:t>Automação</a:t>
             </a:r>
-            <a:endParaRPr lang="en-US" sz="1150" dirty="0"/>
-          </a:p>
-        </p:txBody>
-      </p:sp>
-      <p:sp>
-        <p:nvSpPr>
-          <p:cNvPr id="33" name="Text 25"/>
+            <a:endParaRPr lang="en-US" sz="1300" dirty="0"/>
+          </a:p>
+        </p:txBody>
+      </p:sp>
+      <p:sp>
+        <p:nvSpPr>
+          <p:cNvPr id="40" name="Text 31"/>
           <p:cNvSpPr txBox="1"/>
           <p:nvPr/>
         </p:nvSpPr>
         <p:spPr>
           <a:xfrm>
-            <a:off x="4786884" y="5870448"/>
-            <a:ext cx="1906524" cy="402336"/>
+            <a:off x="3582162" y="5870448"/>
+            <a:ext cx="2393442" cy="402336"/>
           </a:xfrm>
           <a:prstGeom prst="rect">
             <a:avLst/>
@@ -1954,7 +2170,7 @@
               <a:buNone/>
             </a:pPr>
             <a:r>
-              <a:rPr lang="en-US" sz="900" dirty="0">
+              <a:rPr lang="en-US" sz="1050" dirty="0">
                 <a:solidFill>
                   <a:srgbClr val="D8E4F4"/>
                 </a:solidFill>
@@ -1962,22 +2178,22 @@
                 <a:ea typeface="Calibri" pitchFamily="34" charset="-122"/>
                 <a:cs typeface="Calibri" pitchFamily="34" charset="-120"/>
               </a:rPr>
-              <a:t>Relatórios e rotinas operacionais</a:t>
-            </a:r>
-            <a:endParaRPr lang="en-US" sz="900" dirty="0"/>
-          </a:p>
-        </p:txBody>
-      </p:sp>
-      <p:sp>
-        <p:nvSpPr>
-          <p:cNvPr id="34" name="Shape 26"/>
+              <a:t>Elimina o trabalho manual de relatórios e rotinas</a:t>
+            </a:r>
+            <a:endParaRPr lang="en-US" sz="1050" dirty="0"/>
+          </a:p>
+        </p:txBody>
+      </p:sp>
+      <p:sp>
+        <p:nvSpPr>
+          <p:cNvPr id="41" name="Shape 32"/>
           <p:cNvSpPr/>
           <p:nvPr/>
         </p:nvSpPr>
         <p:spPr>
           <a:xfrm>
-            <a:off x="6894576" y="5596128"/>
-            <a:ext cx="256032" cy="256032"/>
+            <a:off x="6213348" y="5047488"/>
+            <a:ext cx="420624" cy="420624"/>
           </a:xfrm>
           <a:prstGeom prst="ellipse">
             <a:avLst/>
@@ -1990,22 +2206,22 @@
       </p:sp>
       <p:pic>
         <p:nvPicPr>
-          <p:cNvPr id="35" name="Image 6" descr="preencoded.png">    </p:cNvPr>
+          <p:cNvPr id="42" name="Image 7" descr="preencoded.png">    </p:cNvPr>
           <p:cNvPicPr>
             <a:picLocks noChangeAspect="1"/>
           </p:cNvPicPr>
           <p:nvPr/>
         </p:nvPicPr>
         <p:blipFill>
-          <a:blip r:embed="rId7"/>
+          <a:blip r:embed="rId8"/>
           <a:stretch>
             <a:fillRect/>
           </a:stretch>
         </p:blipFill>
         <p:spPr>
           <a:xfrm>
-            <a:off x="6958584" y="5660136"/>
-            <a:ext cx="128016" cy="128016"/>
+            <a:off x="6327648" y="5161788"/>
+            <a:ext cx="192024" cy="192024"/>
           </a:xfrm>
           <a:prstGeom prst="rect">
             <a:avLst/>
@@ -2014,14 +2230,14 @@
       </p:pic>
       <p:sp>
         <p:nvSpPr>
-          <p:cNvPr id="36" name="Text 27"/>
+          <p:cNvPr id="43" name="Text 33"/>
           <p:cNvSpPr txBox="1"/>
           <p:nvPr/>
         </p:nvSpPr>
         <p:spPr>
           <a:xfrm>
-            <a:off x="7242048" y="5577840"/>
-            <a:ext cx="1906524" cy="274320"/>
+            <a:off x="6213348" y="5577840"/>
+            <a:ext cx="2393442" cy="274320"/>
           </a:xfrm>
           <a:prstGeom prst="rect">
             <a:avLst/>
@@ -2030,14 +2246,14 @@
           <a:ln/>
         </p:spPr>
         <p:txBody>
-          <a:bodyPr wrap="square" lIns="0" tIns="0" rIns="0" bIns="0" rtlCol="0" anchor="ctr"/>
+          <a:bodyPr wrap="square" lIns="0" tIns="0" rIns="0" bIns="0" rtlCol="0" anchor="t"/>
           <a:lstStyle/>
           <a:p>
             <a:pPr indent="0" marL="0">
               <a:buNone/>
             </a:pPr>
             <a:r>
-              <a:rPr lang="en-US" sz="1150" b="1" dirty="0">
+              <a:rPr lang="en-US" sz="1300" b="1" dirty="0">
                 <a:solidFill>
                   <a:srgbClr val="FFFFFF"/>
                 </a:solidFill>
@@ -2047,20 +2263,20 @@
               </a:rPr>
               <a:t>Oportunidades</a:t>
             </a:r>
-            <a:endParaRPr lang="en-US" sz="1150" dirty="0"/>
-          </a:p>
-        </p:txBody>
-      </p:sp>
-      <p:sp>
-        <p:nvSpPr>
-          <p:cNvPr id="37" name="Text 28"/>
+            <a:endParaRPr lang="en-US" sz="1300" dirty="0"/>
+          </a:p>
+        </p:txBody>
+      </p:sp>
+      <p:sp>
+        <p:nvSpPr>
+          <p:cNvPr id="44" name="Text 34"/>
           <p:cNvSpPr txBox="1"/>
           <p:nvPr/>
         </p:nvSpPr>
         <p:spPr>
           <a:xfrm>
-            <a:off x="7242048" y="5870448"/>
-            <a:ext cx="1906524" cy="402336"/>
+            <a:off x="6213348" y="5870448"/>
+            <a:ext cx="2393442" cy="402336"/>
           </a:xfrm>
           <a:prstGeom prst="rect">
             <a:avLst/>
@@ -2079,7 +2295,7 @@
               <a:buNone/>
             </a:pPr>
             <a:r>
-              <a:rPr lang="en-US" sz="900" dirty="0">
+              <a:rPr lang="en-US" sz="1050" dirty="0">
                 <a:solidFill>
                   <a:srgbClr val="D8E4F4"/>
                 </a:solidFill>
@@ -2087,22 +2303,22 @@
                 <a:ea typeface="Calibri" pitchFamily="34" charset="-122"/>
                 <a:cs typeface="Calibri" pitchFamily="34" charset="-120"/>
               </a:rPr>
-              <a:t>Identifica gargalos e ganhos</a:t>
-            </a:r>
-            <a:endParaRPr lang="en-US" sz="900" dirty="0"/>
-          </a:p>
-        </p:txBody>
-      </p:sp>
-      <p:sp>
-        <p:nvSpPr>
-          <p:cNvPr id="38" name="Shape 29"/>
+              <a:t>Lê o processo e aponta onde está o ganho</a:t>
+            </a:r>
+            <a:endParaRPr lang="en-US" sz="1050" dirty="0"/>
+          </a:p>
+        </p:txBody>
+      </p:sp>
+      <p:sp>
+        <p:nvSpPr>
+          <p:cNvPr id="45" name="Shape 35"/>
           <p:cNvSpPr/>
           <p:nvPr/>
         </p:nvSpPr>
         <p:spPr>
           <a:xfrm>
-            <a:off x="9349740" y="5596128"/>
-            <a:ext cx="256032" cy="256032"/>
+            <a:off x="8844534" y="5047488"/>
+            <a:ext cx="420624" cy="420624"/>
           </a:xfrm>
           <a:prstGeom prst="ellipse">
             <a:avLst/>
@@ -2115,22 +2331,22 @@
       </p:sp>
       <p:pic>
         <p:nvPicPr>
-          <p:cNvPr id="39" name="Image 7" descr="preencoded.png">    </p:cNvPr>
+          <p:cNvPr id="46" name="Image 8" descr="preencoded.png">    </p:cNvPr>
           <p:cNvPicPr>
             <a:picLocks noChangeAspect="1"/>
           </p:cNvPicPr>
           <p:nvPr/>
         </p:nvPicPr>
         <p:blipFill>
-          <a:blip r:embed="rId8"/>
+          <a:blip r:embed="rId9"/>
           <a:stretch>
             <a:fillRect/>
           </a:stretch>
         </p:blipFill>
         <p:spPr>
           <a:xfrm>
-            <a:off x="9413748" y="5660136"/>
-            <a:ext cx="128016" cy="128016"/>
+            <a:off x="8958834" y="5161788"/>
+            <a:ext cx="192024" cy="192024"/>
           </a:xfrm>
           <a:prstGeom prst="rect">
             <a:avLst/>
@@ -2139,14 +2355,14 @@
       </p:pic>
       <p:sp>
         <p:nvSpPr>
-          <p:cNvPr id="40" name="Text 30"/>
+          <p:cNvPr id="47" name="Text 36"/>
           <p:cNvSpPr txBox="1"/>
           <p:nvPr/>
         </p:nvSpPr>
         <p:spPr>
           <a:xfrm>
-            <a:off x="9697212" y="5577840"/>
-            <a:ext cx="1906524" cy="274320"/>
+            <a:off x="8844534" y="5577840"/>
+            <a:ext cx="2393442" cy="274320"/>
           </a:xfrm>
           <a:prstGeom prst="rect">
             <a:avLst/>
@@ -2155,14 +2371,14 @@
           <a:ln/>
         </p:spPr>
         <p:txBody>
-          <a:bodyPr wrap="square" lIns="0" tIns="0" rIns="0" bIns="0" rtlCol="0" anchor="ctr"/>
+          <a:bodyPr wrap="square" lIns="0" tIns="0" rIns="0" bIns="0" rtlCol="0" anchor="t"/>
           <a:lstStyle/>
           <a:p>
             <a:pPr indent="0" marL="0">
               <a:buNone/>
             </a:pPr>
             <a:r>
-              <a:rPr lang="en-US" sz="1150" b="1" dirty="0">
+              <a:rPr lang="en-US" sz="1300" b="1" dirty="0">
                 <a:solidFill>
                   <a:srgbClr val="FFFFFF"/>
                 </a:solidFill>
@@ -2172,20 +2388,20 @@
               </a:rPr>
               <a:t>Estudos</a:t>
             </a:r>
-            <a:endParaRPr lang="en-US" sz="1150" dirty="0"/>
-          </a:p>
-        </p:txBody>
-      </p:sp>
-      <p:sp>
-        <p:nvSpPr>
-          <p:cNvPr id="41" name="Text 31"/>
+            <a:endParaRPr lang="en-US" sz="1300" dirty="0"/>
+          </a:p>
+        </p:txBody>
+      </p:sp>
+      <p:sp>
+        <p:nvSpPr>
+          <p:cNvPr id="48" name="Text 37"/>
           <p:cNvSpPr txBox="1"/>
           <p:nvPr/>
         </p:nvSpPr>
         <p:spPr>
           <a:xfrm>
-            <a:off x="9697212" y="5870448"/>
-            <a:ext cx="1906524" cy="402336"/>
+            <a:off x="8844534" y="5870448"/>
+            <a:ext cx="2393442" cy="402336"/>
           </a:xfrm>
           <a:prstGeom prst="rect">
             <a:avLst/>
@@ -2204,7 +2420,7 @@
               <a:buNone/>
             </a:pPr>
             <a:r>
-              <a:rPr lang="en-US" sz="900" dirty="0">
+              <a:rPr lang="en-US" sz="1050" dirty="0">
                 <a:solidFill>
                   <a:srgbClr val="D8E4F4"/>
                 </a:solidFill>
@@ -2212,9 +2428,9 @@
                 <a:ea typeface="Calibri" pitchFamily="34" charset="-122"/>
                 <a:cs typeface="Calibri" pitchFamily="34" charset="-120"/>
               </a:rPr>
-              <a:t>Dado pronto para a reunião</a:t>
-            </a:r>
-            <a:endParaRPr lang="en-US" sz="900" dirty="0"/>
+              <a:t>Leva análise e recomendação para a reunião</a:t>
+            </a:r>
+            <a:endParaRPr lang="en-US" sz="1050" dirty="0"/>
           </a:p>
         </p:txBody>
       </p:sp>

</xml_diff>

<commit_message>
Adiciona slide de PMO e consolida o deck em dois slides
Segundo slide com o PMO do mapeamento: cinco entregas por produto,
carteira, supervisor, status, prazo e apresentacao, com indicador de
progresso e pontos de atencao. Remove as versoes anteriores do one-pager
que foram substituidas.

Co-Authored-By: Claude Opus 5 <noreply@anthropic.com>
Claude-Session: https://claude.ai/code/session_01LiBTDxNxgFCPijAoYiizN1
</commit_message>
<xml_diff>
--- a/apresentacoes/Planejamento_Ganhos.pptx
+++ b/apresentacoes/Planejamento_Ganhos.pptx
@@ -6,9 +6,10 @@
   </p:sldMasterIdLst>
   <p:sldIdLst>
     <p:sldId id="256" r:id="rId2"/>
+    <p:sldId id="257" r:id="rId3"/>
   </p:sldIdLst>
   <p:notesMasterIdLst>
-    <p:notesMasterId r:id="rId3"/>
+    <p:notesMasterId r:id="rId4"/>
   </p:notesMasterIdLst>
   <p:sldSz cx="12192000" cy="6858000"/>
   <p:notesSz cx="6858000" cy="12192000"/>
@@ -502,7 +503,7 @@
           <a:p>
             <a:r>
               <a:rPr lang="en-US" dirty="0"/>
-              <a:t>Mensagem central: o Willyan assume o processo, o tratamento dos dados e a construção das visões. A operação recebe a leitura pronta e decide. Hora a Hora: acompanhamento intradiário contra a meta do dia — dá para ver onde o ritmo cai, em qual carteira, e reagir no mesmo turno em vez de descobrir no dia seguinte. Dashboard D-1: dia anterior fechado com N4 e N5 na mesma régua, permitindo comparação direta entre carteiras sem planilha paralela. O D-1 da N5 foi entregue em 29/set; as demais saem em 05 e 09/out. Metas e comparativos: como os relatórios passam a carregar a meta, ganhamos visão mês a mês e atingimento contra o mês corrente — o que mostra tendência e distância da meta, não apenas a foto do dia. Por trás das visões, o Will atua no desenvolvimento e na evolução dos processos, na automação de relatórios e rotinas operacionais, na identificação de oportunidades e nos estudos que levam análise e recomendação para as reuniões. Os acessos às ferramentas já estão todos liberados — nada bloqueando o desenvolvimento.</a:t>
+              <a:t>Mensagem central: o Willyan assume o processo, o tratamento dos dados e a construção das visões. A operação recebe a leitura pronta e decide. Hora a Hora: acompanhamento intradiário contra a meta do dia — dá para ver onde o ritmo cai, em qual carteira, e reagir no mesmo turno em vez de descobrir no dia seguinte. Dashboard D-1: dia anterior fechado com N4 e N5 na mesma régua, permitindo comparação direta entre carteiras sem planilha paralela. O D-1 da N5 foi entregue em 29/set; as demais saem em 05 e 09/out. Metas e comparativos: como os relatórios passam a carregar a meta, ganhamos visão mês a mês e atingimento contra o mês corrente — tendência e distância da meta, não apenas a foto do dia. Por trás das visões, o Will atua no desenvolvimento e evolução dos processos, na automação de relatórios e rotinas operacionais, na identificação de oportunidades e nos estudos que levam análise e recomendação para as reuniões. Os acessos às ferramentas já estão todos liberados.</a:t>
             </a:r>
             <a:endParaRPr lang="en-US" dirty="0"/>
           </a:p>
@@ -526,6 +527,94 @@
             <a:fld id="{F7021451-1387-4CA6-816F-3879F97B5CBC}" type="slidenum">
               <a:rPr lang="en-US"/>
               <a:t>1</a:t>
+            </a:fld>
+            <a:endParaRPr lang="en-US"/>
+          </a:p>
+        </p:txBody>
+      </p:sp>
+    </p:spTree>
+    <p:extLst>
+      <p:ext uri="{BB962C8B-B14F-4D97-AF65-F5344CB8AC3E}">
+        <p14:creationId xmlns:p14="http://schemas.microsoft.com/office/powerpoint/2010/main" val="1024086991"/>
+      </p:ext>
+    </p:extLst>
+  </p:cSld>
+  <p:clrMapOvr>
+    <a:masterClrMapping/>
+  </p:clrMapOvr>
+</p:notes>
+</file>
+
+<file path=ppt/notesSlides/notesSlide2.xml><?xml version="1.0" encoding="utf-8"?>
+<p:notes xmlns:a="http://schemas.openxmlformats.org/drawingml/2006/main" xmlns:r="http://schemas.openxmlformats.org/officeDocument/2006/relationships" xmlns:p="http://schemas.openxmlformats.org/presentationml/2006/main">
+  <p:cSld>
+    <p:spTree>
+      <p:nvGrpSpPr>
+        <p:cNvPr id="1" name=""/>
+        <p:cNvGrpSpPr/>
+        <p:nvPr/>
+      </p:nvGrpSpPr>
+      <p:grpSpPr>
+        <a:xfrm>
+          <a:off x="0" y="0"/>
+          <a:ext cx="0" cy="0"/>
+          <a:chOff x="0" y="0"/>
+          <a:chExt cx="0" cy="0"/>
+        </a:xfrm>
+      </p:grpSpPr>
+      <p:sp>
+        <p:nvSpPr>
+          <p:cNvPr id="2" name="Slide Image Placeholder 1"/>
+          <p:cNvSpPr>
+            <a:spLocks noGrp="1" noRot="1" noChangeAspect="1"/>
+          </p:cNvSpPr>
+          <p:nvPr>
+            <p:ph type="sldImg"/>
+          </p:nvPr>
+        </p:nvSpPr>
+        <p:spPr/>
+      </p:sp>
+      <p:sp>
+        <p:nvSpPr>
+          <p:cNvPr id="3" name="Notes Placeholder 2"/>
+          <p:cNvSpPr>
+            <a:spLocks noGrp="1"/>
+          </p:cNvSpPr>
+          <p:nvPr>
+            <p:ph type="body" idx="1"/>
+          </p:nvPr>
+        </p:nvSpPr>
+        <p:spPr/>
+        <p:txBody>
+          <a:bodyPr/>
+          <a:lstStyle/>
+          <a:p>
+            <a:r>
+              <a:rPr lang="en-US" dirty="0"/>
+              <a:t>PMO do mapeamento. Cinco entregas entre as carteiras N4 e N5, distribuídas em dois produtos. Dashboard D-1: N5 do Deyvid concluído e apresentado em 29/set; N5 da Andressa para 05/out e N4 do Lucas para 09/out, ambos com apresentação prevista. Hora a Hora: N5 (Andressa e Deyvid) para 05/out e N4 (Lucas) para 09/out, sem apresentação nesta rodada. Pontos de atenção: na N5 seguem os conceitos de base e o onboarding com a Andressa; na N4 o relatório está com a operação e depende de reunião com o Lucas para entender os KPIs e estruturar o desenvolvimento. Acessos às ferramentas: todos liberados.</a:t>
+            </a:r>
+            <a:endParaRPr lang="en-US" dirty="0"/>
+          </a:p>
+        </p:txBody>
+      </p:sp>
+      <p:sp>
+        <p:nvSpPr>
+          <p:cNvPr id="4" name="Slide Number Placeholder 3"/>
+          <p:cNvSpPr>
+            <a:spLocks noGrp="1"/>
+          </p:cNvSpPr>
+          <p:nvPr>
+            <p:ph type="sldNum" sz="quarter" idx="10"/>
+          </p:nvPr>
+        </p:nvSpPr>
+        <p:spPr/>
+        <p:txBody>
+          <a:bodyPr/>
+          <a:lstStyle/>
+          <a:p>
+            <a:fld id="{F7021451-1387-4CA6-816F-3879F97B5CBC}" type="slidenum">
+              <a:rPr lang="en-US"/>
+              <a:t>2</a:t>
             </a:fld>
             <a:endParaRPr lang="en-US"/>
           </a:p>
@@ -2442,6 +2531,2776 @@
 </p:sld>
 </file>
 
+<file path=ppt/slides/slide2.xml><?xml version="1.0" encoding="utf-8"?>
+<p:sld xmlns:a="http://schemas.openxmlformats.org/drawingml/2006/main" xmlns:r="http://schemas.openxmlformats.org/officeDocument/2006/relationships" xmlns:p="http://schemas.openxmlformats.org/presentationml/2006/main">
+  <p:cSld name="Slide 2">
+    <p:bg>
+      <p:bgPr>
+        <a:solidFill>
+          <a:srgbClr val="12203A"/>
+        </a:solidFill>
+      </p:bgPr>
+    </p:bg>
+    <p:spTree>
+      <p:nvGrpSpPr>
+        <p:cNvPr id="1" name=""/>
+        <p:cNvGrpSpPr/>
+        <p:nvPr/>
+      </p:nvGrpSpPr>
+      <p:grpSpPr>
+        <a:xfrm>
+          <a:off x="0" y="0"/>
+          <a:ext cx="0" cy="0"/>
+          <a:chOff x="0" y="0"/>
+          <a:chExt cx="0" cy="0"/>
+        </a:xfrm>
+      </p:grpSpPr>
+      <p:pic>
+        <p:nvPicPr>
+          <p:cNvPr id="2" name="Image 0" descr="preencoded.png">    </p:cNvPr>
+          <p:cNvPicPr>
+            <a:picLocks noChangeAspect="1"/>
+          </p:cNvPicPr>
+          <p:nvPr/>
+        </p:nvPicPr>
+        <p:blipFill>
+          <a:blip r:embed="rId1"/>
+          <a:stretch>
+            <a:fillRect/>
+          </a:stretch>
+        </p:blipFill>
+        <p:spPr>
+          <a:xfrm>
+            <a:off x="0" y="0"/>
+            <a:ext cx="12188952" cy="6858000"/>
+          </a:xfrm>
+          <a:prstGeom prst="rect">
+            <a:avLst/>
+          </a:prstGeom>
+        </p:spPr>
+      </p:pic>
+      <p:sp>
+        <p:nvSpPr>
+          <p:cNvPr id="3" name="Text 0"/>
+          <p:cNvSpPr txBox="1"/>
+          <p:nvPr/>
+        </p:nvSpPr>
+        <p:spPr>
+          <a:xfrm>
+            <a:off x="566928" y="457200"/>
+            <a:ext cx="6858000" cy="237744"/>
+          </a:xfrm>
+          <a:prstGeom prst="rect">
+            <a:avLst/>
+          </a:prstGeom>
+          <a:noFill/>
+          <a:ln/>
+        </p:spPr>
+        <p:txBody>
+          <a:bodyPr wrap="square" lIns="0" tIns="0" rIns="0" bIns="0" rtlCol="0" anchor="t"/>
+          <a:lstStyle/>
+          <a:p>
+            <a:pPr indent="0" marL="0">
+              <a:buNone/>
+            </a:pPr>
+            <a:r>
+              <a:rPr lang="en-US" sz="1150" b="1" spc="280" kern="0" dirty="0">
+                <a:solidFill>
+                  <a:srgbClr val="E9A13B"/>
+                </a:solidFill>
+                <a:latin typeface="Calibri" pitchFamily="34" charset="0"/>
+                <a:ea typeface="Calibri" pitchFamily="34" charset="-122"/>
+                <a:cs typeface="Calibri" pitchFamily="34" charset="-120"/>
+              </a:rPr>
+              <a:t>PMO   ·   MAPEAMENTO DAS ENTREGAS</a:t>
+            </a:r>
+            <a:endParaRPr lang="en-US" sz="1150" dirty="0"/>
+          </a:p>
+        </p:txBody>
+      </p:sp>
+      <p:sp>
+        <p:nvSpPr>
+          <p:cNvPr id="4" name="Text 1"/>
+          <p:cNvSpPr txBox="1"/>
+          <p:nvPr/>
+        </p:nvSpPr>
+        <p:spPr>
+          <a:xfrm>
+            <a:off x="566928" y="777240"/>
+            <a:ext cx="7772400" cy="566928"/>
+          </a:xfrm>
+          <a:prstGeom prst="rect">
+            <a:avLst/>
+          </a:prstGeom>
+          <a:noFill/>
+          <a:ln/>
+        </p:spPr>
+        <p:txBody>
+          <a:bodyPr wrap="square" lIns="0" tIns="0" rIns="0" bIns="0" rtlCol="0" anchor="t"/>
+          <a:lstStyle/>
+          <a:p>
+            <a:pPr indent="0" marL="0">
+              <a:buNone/>
+            </a:pPr>
+            <a:r>
+              <a:rPr lang="en-US" sz="2900" b="1" dirty="0">
+                <a:solidFill>
+                  <a:srgbClr val="FFFFFF"/>
+                </a:solidFill>
+                <a:latin typeface="Cambria" pitchFamily="34" charset="0"/>
+                <a:ea typeface="Cambria" pitchFamily="34" charset="-122"/>
+                <a:cs typeface="Cambria" pitchFamily="34" charset="-120"/>
+              </a:rPr>
+              <a:t>Onde cada entrega está</a:t>
+            </a:r>
+            <a:endParaRPr lang="en-US" sz="2900" dirty="0"/>
+          </a:p>
+        </p:txBody>
+      </p:sp>
+      <p:sp>
+        <p:nvSpPr>
+          <p:cNvPr id="5" name="Text 2"/>
+          <p:cNvSpPr txBox="1"/>
+          <p:nvPr/>
+        </p:nvSpPr>
+        <p:spPr>
+          <a:xfrm>
+            <a:off x="566928" y="1371600"/>
+            <a:ext cx="7772400" cy="274320"/>
+          </a:xfrm>
+          <a:prstGeom prst="rect">
+            <a:avLst/>
+          </a:prstGeom>
+          <a:noFill/>
+          <a:ln/>
+        </p:spPr>
+        <p:txBody>
+          <a:bodyPr wrap="square" lIns="0" tIns="0" rIns="0" bIns="0" rtlCol="0" anchor="t"/>
+          <a:lstStyle/>
+          <a:p>
+            <a:pPr indent="0" marL="0">
+              <a:buNone/>
+            </a:pPr>
+            <a:r>
+              <a:rPr lang="en-US" sz="1350" dirty="0">
+                <a:solidFill>
+                  <a:srgbClr val="D8E4F4"/>
+                </a:solidFill>
+                <a:latin typeface="Calibri" pitchFamily="34" charset="0"/>
+                <a:ea typeface="Calibri" pitchFamily="34" charset="-122"/>
+                <a:cs typeface="Calibri" pitchFamily="34" charset="-120"/>
+              </a:rPr>
+              <a:t>5 entregas mapeadas entre N4 e N5 — 1 concluída e 4 com data definida.</a:t>
+            </a:r>
+            <a:endParaRPr lang="en-US" sz="1350" dirty="0"/>
+          </a:p>
+        </p:txBody>
+      </p:sp>
+      <p:sp>
+        <p:nvSpPr>
+          <p:cNvPr id="6" name="Shape 3"/>
+          <p:cNvSpPr/>
+          <p:nvPr/>
+        </p:nvSpPr>
+        <p:spPr>
+          <a:xfrm>
+            <a:off x="8650224" y="457200"/>
+            <a:ext cx="2971800" cy="914400"/>
+          </a:xfrm>
+          <a:prstGeom prst="roundRect">
+            <a:avLst>
+              <a:gd name="adj" fmla="val 10000"/>
+            </a:avLst>
+          </a:prstGeom>
+          <a:solidFill>
+            <a:srgbClr val="FFFFFF">
+              <a:alpha val="8000"/>
+            </a:srgbClr>
+          </a:solidFill>
+          <a:ln w="12700">
+            <a:solidFill>
+              <a:srgbClr val="31507F"/>
+            </a:solidFill>
+            <a:prstDash val="solid"/>
+          </a:ln>
+        </p:spPr>
+      </p:sp>
+      <p:sp>
+        <p:nvSpPr>
+          <p:cNvPr id="7" name="Text 4"/>
+          <p:cNvSpPr txBox="1"/>
+          <p:nvPr/>
+        </p:nvSpPr>
+        <p:spPr>
+          <a:xfrm>
+            <a:off x="8924544" y="621792"/>
+            <a:ext cx="2423160" cy="219456"/>
+          </a:xfrm>
+          <a:prstGeom prst="rect">
+            <a:avLst/>
+          </a:prstGeom>
+          <a:noFill/>
+          <a:ln/>
+        </p:spPr>
+        <p:txBody>
+          <a:bodyPr wrap="square" lIns="0" tIns="0" rIns="0" bIns="0" rtlCol="0" anchor="t"/>
+          <a:lstStyle/>
+          <a:p>
+            <a:pPr indent="0" marL="0">
+              <a:buNone/>
+            </a:pPr>
+            <a:r>
+              <a:rPr lang="en-US" sz="900" b="1" spc="140" kern="0" dirty="0">
+                <a:solidFill>
+                  <a:srgbClr val="93A9C6"/>
+                </a:solidFill>
+                <a:latin typeface="Calibri" pitchFamily="34" charset="0"/>
+                <a:ea typeface="Calibri" pitchFamily="34" charset="-122"/>
+                <a:cs typeface="Calibri" pitchFamily="34" charset="-120"/>
+              </a:rPr>
+              <a:t>PROGRESSO</a:t>
+            </a:r>
+            <a:endParaRPr lang="en-US" sz="900" dirty="0"/>
+          </a:p>
+        </p:txBody>
+      </p:sp>
+      <p:sp>
+        <p:nvSpPr>
+          <p:cNvPr id="8" name="Text 5"/>
+          <p:cNvSpPr txBox="1"/>
+          <p:nvPr/>
+        </p:nvSpPr>
+        <p:spPr>
+          <a:xfrm>
+            <a:off x="8924544" y="804672"/>
+            <a:ext cx="2423160" cy="292608"/>
+          </a:xfrm>
+          <a:prstGeom prst="rect">
+            <a:avLst/>
+          </a:prstGeom>
+          <a:noFill/>
+          <a:ln/>
+        </p:spPr>
+        <p:txBody>
+          <a:bodyPr wrap="square" lIns="0" tIns="0" rIns="0" bIns="0" rtlCol="0" anchor="ctr"/>
+          <a:lstStyle/>
+          <a:p>
+            <a:pPr indent="0" marL="0">
+              <a:buNone/>
+            </a:pPr>
+            <a:r>
+              <a:rPr lang="en-US" sz="2000" b="1" dirty="0">
+                <a:solidFill>
+                  <a:srgbClr val="E9A13B"/>
+                </a:solidFill>
+                <a:latin typeface="Cambria" pitchFamily="34" charset="0"/>
+                <a:ea typeface="Cambria" pitchFamily="34" charset="-122"/>
+                <a:cs typeface="Cambria" pitchFamily="34" charset="-120"/>
+              </a:rPr>
+              <a:t>1</a:t>
+            </a:r>
+            <a:pPr indent="0" marL="0">
+              <a:buNone/>
+            </a:pPr>
+            <a:r>
+              <a:rPr lang="en-US" sz="1200" dirty="0">
+                <a:solidFill>
+                  <a:srgbClr val="FFFFFF"/>
+                </a:solidFill>
+                <a:latin typeface="Calibri" pitchFamily="34" charset="0"/>
+                <a:ea typeface="Calibri" pitchFamily="34" charset="-122"/>
+                <a:cs typeface="Calibri" pitchFamily="34" charset="-120"/>
+              </a:rPr>
+              <a:t>  de 5 entregues</a:t>
+            </a:r>
+            <a:endParaRPr lang="en-US" sz="2000" dirty="0"/>
+          </a:p>
+        </p:txBody>
+      </p:sp>
+      <p:sp>
+        <p:nvSpPr>
+          <p:cNvPr id="9" name="Shape 6"/>
+          <p:cNvSpPr/>
+          <p:nvPr/>
+        </p:nvSpPr>
+        <p:spPr>
+          <a:xfrm>
+            <a:off x="8924544" y="1152144"/>
+            <a:ext cx="2423160" cy="91440"/>
+          </a:xfrm>
+          <a:prstGeom prst="roundRect">
+            <a:avLst>
+              <a:gd name="adj" fmla="val 50000"/>
+            </a:avLst>
+          </a:prstGeom>
+          <a:solidFill>
+            <a:srgbClr val="FFFFFF">
+              <a:alpha val="20000"/>
+            </a:srgbClr>
+          </a:solidFill>
+          <a:ln w="6350">
+            <a:solidFill>
+              <a:srgbClr val="FFFFFF">
+                <a:alpha val="30000"/>
+              </a:srgbClr>
+            </a:solidFill>
+            <a:prstDash val="solid"/>
+          </a:ln>
+        </p:spPr>
+      </p:sp>
+      <p:sp>
+        <p:nvSpPr>
+          <p:cNvPr id="10" name="Shape 7"/>
+          <p:cNvSpPr/>
+          <p:nvPr/>
+        </p:nvSpPr>
+        <p:spPr>
+          <a:xfrm>
+            <a:off x="8924544" y="1152144"/>
+            <a:ext cx="484632" cy="91440"/>
+          </a:xfrm>
+          <a:prstGeom prst="roundRect">
+            <a:avLst>
+              <a:gd name="adj" fmla="val 50000"/>
+            </a:avLst>
+          </a:prstGeom>
+          <a:solidFill>
+            <a:srgbClr val="E9A13B"/>
+          </a:solidFill>
+          <a:ln/>
+        </p:spPr>
+      </p:sp>
+      <p:sp>
+        <p:nvSpPr>
+          <p:cNvPr id="11" name="Text 8"/>
+          <p:cNvSpPr txBox="1"/>
+          <p:nvPr/>
+        </p:nvSpPr>
+        <p:spPr>
+          <a:xfrm>
+            <a:off x="822960" y="1828800"/>
+            <a:ext cx="2194560" cy="256032"/>
+          </a:xfrm>
+          <a:prstGeom prst="rect">
+            <a:avLst/>
+          </a:prstGeom>
+          <a:noFill/>
+          <a:ln/>
+        </p:spPr>
+        <p:txBody>
+          <a:bodyPr wrap="square" lIns="0" tIns="0" rIns="0" bIns="0" rtlCol="0" anchor="ctr"/>
+          <a:lstStyle/>
+          <a:p>
+            <a:pPr indent="0" marL="0">
+              <a:buNone/>
+            </a:pPr>
+            <a:r>
+              <a:rPr lang="en-US" sz="850" b="1" spc="100" kern="0" dirty="0">
+                <a:solidFill>
+                  <a:srgbClr val="E9A13B"/>
+                </a:solidFill>
+                <a:latin typeface="Calibri" pitchFamily="34" charset="0"/>
+                <a:ea typeface="Calibri" pitchFamily="34" charset="-122"/>
+                <a:cs typeface="Calibri" pitchFamily="34" charset="-120"/>
+              </a:rPr>
+              <a:t>ENTREGA</a:t>
+            </a:r>
+            <a:endParaRPr lang="en-US" sz="850" dirty="0"/>
+          </a:p>
+        </p:txBody>
+      </p:sp>
+      <p:sp>
+        <p:nvSpPr>
+          <p:cNvPr id="12" name="Text 9"/>
+          <p:cNvSpPr txBox="1"/>
+          <p:nvPr/>
+        </p:nvSpPr>
+        <p:spPr>
+          <a:xfrm>
+            <a:off x="3054096" y="1828800"/>
+            <a:ext cx="731520" cy="256032"/>
+          </a:xfrm>
+          <a:prstGeom prst="rect">
+            <a:avLst/>
+          </a:prstGeom>
+          <a:noFill/>
+          <a:ln/>
+        </p:spPr>
+        <p:txBody>
+          <a:bodyPr wrap="square" lIns="0" tIns="0" rIns="0" bIns="0" rtlCol="0" anchor="ctr"/>
+          <a:lstStyle/>
+          <a:p>
+            <a:pPr indent="0" marL="0">
+              <a:buNone/>
+            </a:pPr>
+            <a:r>
+              <a:rPr lang="en-US" sz="850" b="1" spc="100" kern="0" dirty="0">
+                <a:solidFill>
+                  <a:srgbClr val="E9A13B"/>
+                </a:solidFill>
+                <a:latin typeface="Calibri" pitchFamily="34" charset="0"/>
+                <a:ea typeface="Calibri" pitchFamily="34" charset="-122"/>
+                <a:cs typeface="Calibri" pitchFamily="34" charset="-120"/>
+              </a:rPr>
+              <a:t>CARTEIRA</a:t>
+            </a:r>
+            <a:endParaRPr lang="en-US" sz="850" dirty="0"/>
+          </a:p>
+        </p:txBody>
+      </p:sp>
+      <p:sp>
+        <p:nvSpPr>
+          <p:cNvPr id="13" name="Text 10"/>
+          <p:cNvSpPr txBox="1"/>
+          <p:nvPr/>
+        </p:nvSpPr>
+        <p:spPr>
+          <a:xfrm>
+            <a:off x="3968496" y="1828800"/>
+            <a:ext cx="1554480" cy="256032"/>
+          </a:xfrm>
+          <a:prstGeom prst="rect">
+            <a:avLst/>
+          </a:prstGeom>
+          <a:noFill/>
+          <a:ln/>
+        </p:spPr>
+        <p:txBody>
+          <a:bodyPr wrap="square" lIns="0" tIns="0" rIns="0" bIns="0" rtlCol="0" anchor="ctr"/>
+          <a:lstStyle/>
+          <a:p>
+            <a:pPr indent="0" marL="0">
+              <a:buNone/>
+            </a:pPr>
+            <a:r>
+              <a:rPr lang="en-US" sz="850" b="1" spc="100" kern="0" dirty="0">
+                <a:solidFill>
+                  <a:srgbClr val="E9A13B"/>
+                </a:solidFill>
+                <a:latin typeface="Calibri" pitchFamily="34" charset="0"/>
+                <a:ea typeface="Calibri" pitchFamily="34" charset="-122"/>
+                <a:cs typeface="Calibri" pitchFamily="34" charset="-120"/>
+              </a:rPr>
+              <a:t>SUPERVISOR</a:t>
+            </a:r>
+            <a:endParaRPr lang="en-US" sz="850" dirty="0"/>
+          </a:p>
+        </p:txBody>
+      </p:sp>
+      <p:sp>
+        <p:nvSpPr>
+          <p:cNvPr id="14" name="Text 11"/>
+          <p:cNvSpPr txBox="1"/>
+          <p:nvPr/>
+        </p:nvSpPr>
+        <p:spPr>
+          <a:xfrm>
+            <a:off x="5705856" y="1828800"/>
+            <a:ext cx="1371600" cy="256032"/>
+          </a:xfrm>
+          <a:prstGeom prst="rect">
+            <a:avLst/>
+          </a:prstGeom>
+          <a:noFill/>
+          <a:ln/>
+        </p:spPr>
+        <p:txBody>
+          <a:bodyPr wrap="square" lIns="0" tIns="0" rIns="0" bIns="0" rtlCol="0" anchor="ctr"/>
+          <a:lstStyle/>
+          <a:p>
+            <a:pPr indent="0" marL="0">
+              <a:buNone/>
+            </a:pPr>
+            <a:r>
+              <a:rPr lang="en-US" sz="850" b="1" spc="100" kern="0" dirty="0">
+                <a:solidFill>
+                  <a:srgbClr val="E9A13B"/>
+                </a:solidFill>
+                <a:latin typeface="Calibri" pitchFamily="34" charset="0"/>
+                <a:ea typeface="Calibri" pitchFamily="34" charset="-122"/>
+                <a:cs typeface="Calibri" pitchFamily="34" charset="-120"/>
+              </a:rPr>
+              <a:t>STATUS</a:t>
+            </a:r>
+            <a:endParaRPr lang="en-US" sz="850" dirty="0"/>
+          </a:p>
+        </p:txBody>
+      </p:sp>
+      <p:sp>
+        <p:nvSpPr>
+          <p:cNvPr id="15" name="Text 12"/>
+          <p:cNvSpPr txBox="1"/>
+          <p:nvPr/>
+        </p:nvSpPr>
+        <p:spPr>
+          <a:xfrm>
+            <a:off x="7260336" y="1828800"/>
+            <a:ext cx="731520" cy="256032"/>
+          </a:xfrm>
+          <a:prstGeom prst="rect">
+            <a:avLst/>
+          </a:prstGeom>
+          <a:noFill/>
+          <a:ln/>
+        </p:spPr>
+        <p:txBody>
+          <a:bodyPr wrap="square" lIns="0" tIns="0" rIns="0" bIns="0" rtlCol="0" anchor="ctr"/>
+          <a:lstStyle/>
+          <a:p>
+            <a:pPr indent="0" marL="0">
+              <a:buNone/>
+            </a:pPr>
+            <a:r>
+              <a:rPr lang="en-US" sz="850" b="1" spc="100" kern="0" dirty="0">
+                <a:solidFill>
+                  <a:srgbClr val="E9A13B"/>
+                </a:solidFill>
+                <a:latin typeface="Calibri" pitchFamily="34" charset="0"/>
+                <a:ea typeface="Calibri" pitchFamily="34" charset="-122"/>
+                <a:cs typeface="Calibri" pitchFamily="34" charset="-120"/>
+              </a:rPr>
+              <a:t>PRAZO</a:t>
+            </a:r>
+            <a:endParaRPr lang="en-US" sz="850" dirty="0"/>
+          </a:p>
+        </p:txBody>
+      </p:sp>
+      <p:sp>
+        <p:nvSpPr>
+          <p:cNvPr id="16" name="Text 13"/>
+          <p:cNvSpPr txBox="1"/>
+          <p:nvPr/>
+        </p:nvSpPr>
+        <p:spPr>
+          <a:xfrm>
+            <a:off x="8174736" y="1828800"/>
+            <a:ext cx="1298448" cy="256032"/>
+          </a:xfrm>
+          <a:prstGeom prst="rect">
+            <a:avLst/>
+          </a:prstGeom>
+          <a:noFill/>
+          <a:ln/>
+        </p:spPr>
+        <p:txBody>
+          <a:bodyPr wrap="square" lIns="0" tIns="0" rIns="0" bIns="0" rtlCol="0" anchor="ctr"/>
+          <a:lstStyle/>
+          <a:p>
+            <a:pPr indent="0" marL="0">
+              <a:buNone/>
+            </a:pPr>
+            <a:r>
+              <a:rPr lang="en-US" sz="850" b="1" spc="100" kern="0" dirty="0">
+                <a:solidFill>
+                  <a:srgbClr val="E9A13B"/>
+                </a:solidFill>
+                <a:latin typeface="Calibri" pitchFamily="34" charset="0"/>
+                <a:ea typeface="Calibri" pitchFamily="34" charset="-122"/>
+                <a:cs typeface="Calibri" pitchFamily="34" charset="-120"/>
+              </a:rPr>
+              <a:t>APRESENTAÇÃO</a:t>
+            </a:r>
+            <a:endParaRPr lang="en-US" sz="850" dirty="0"/>
+          </a:p>
+        </p:txBody>
+      </p:sp>
+      <p:sp>
+        <p:nvSpPr>
+          <p:cNvPr id="17" name="Text 14"/>
+          <p:cNvSpPr txBox="1"/>
+          <p:nvPr/>
+        </p:nvSpPr>
+        <p:spPr>
+          <a:xfrm>
+            <a:off x="9656064" y="1828800"/>
+            <a:ext cx="1892808" cy="256032"/>
+          </a:xfrm>
+          <a:prstGeom prst="rect">
+            <a:avLst/>
+          </a:prstGeom>
+          <a:noFill/>
+          <a:ln/>
+        </p:spPr>
+        <p:txBody>
+          <a:bodyPr wrap="square" lIns="0" tIns="0" rIns="0" bIns="0" rtlCol="0" anchor="ctr"/>
+          <a:lstStyle/>
+          <a:p>
+            <a:pPr indent="0" marL="0">
+              <a:buNone/>
+            </a:pPr>
+            <a:r>
+              <a:rPr lang="en-US" sz="850" b="1" spc="100" kern="0" dirty="0">
+                <a:solidFill>
+                  <a:srgbClr val="E9A13B"/>
+                </a:solidFill>
+                <a:latin typeface="Calibri" pitchFamily="34" charset="0"/>
+                <a:ea typeface="Calibri" pitchFamily="34" charset="-122"/>
+                <a:cs typeface="Calibri" pitchFamily="34" charset="-120"/>
+              </a:rPr>
+              <a:t>OBSERVAÇÃO</a:t>
+            </a:r>
+            <a:endParaRPr lang="en-US" sz="850" dirty="0"/>
+          </a:p>
+        </p:txBody>
+      </p:sp>
+      <p:sp>
+        <p:nvSpPr>
+          <p:cNvPr id="18" name="Shape 15"/>
+          <p:cNvSpPr/>
+          <p:nvPr/>
+        </p:nvSpPr>
+        <p:spPr>
+          <a:xfrm>
+            <a:off x="566928" y="2157984"/>
+            <a:ext cx="11055096" cy="548640"/>
+          </a:xfrm>
+          <a:prstGeom prst="roundRect">
+            <a:avLst>
+              <a:gd name="adj" fmla="val 11667"/>
+            </a:avLst>
+          </a:prstGeom>
+          <a:solidFill>
+            <a:srgbClr val="FFFFFF">
+              <a:alpha val="10000"/>
+            </a:srgbClr>
+          </a:solidFill>
+          <a:ln w="12700">
+            <a:solidFill>
+              <a:srgbClr val="E9A13B"/>
+            </a:solidFill>
+            <a:prstDash val="solid"/>
+          </a:ln>
+        </p:spPr>
+      </p:sp>
+      <p:sp>
+        <p:nvSpPr>
+          <p:cNvPr id="19" name="Text 16"/>
+          <p:cNvSpPr txBox="1"/>
+          <p:nvPr/>
+        </p:nvSpPr>
+        <p:spPr>
+          <a:xfrm>
+            <a:off x="822960" y="2157984"/>
+            <a:ext cx="2011680" cy="548640"/>
+          </a:xfrm>
+          <a:prstGeom prst="rect">
+            <a:avLst/>
+          </a:prstGeom>
+          <a:noFill/>
+          <a:ln/>
+        </p:spPr>
+        <p:txBody>
+          <a:bodyPr wrap="square" lIns="0" tIns="0" rIns="0" bIns="0" rtlCol="0" anchor="ctr"/>
+          <a:lstStyle/>
+          <a:p>
+            <a:pPr indent="0" marL="0">
+              <a:buNone/>
+            </a:pPr>
+            <a:r>
+              <a:rPr lang="en-US" sz="1150" b="1" dirty="0">
+                <a:solidFill>
+                  <a:srgbClr val="FFFFFF"/>
+                </a:solidFill>
+                <a:latin typeface="Calibri" pitchFamily="34" charset="0"/>
+                <a:ea typeface="Calibri" pitchFamily="34" charset="-122"/>
+                <a:cs typeface="Calibri" pitchFamily="34" charset="-120"/>
+              </a:rPr>
+              <a:t>Dashboard D-1</a:t>
+            </a:r>
+            <a:endParaRPr lang="en-US" sz="1150" dirty="0"/>
+          </a:p>
+        </p:txBody>
+      </p:sp>
+      <p:sp>
+        <p:nvSpPr>
+          <p:cNvPr id="20" name="Text 17"/>
+          <p:cNvSpPr txBox="1"/>
+          <p:nvPr/>
+        </p:nvSpPr>
+        <p:spPr>
+          <a:xfrm>
+            <a:off x="3054096" y="2157984"/>
+            <a:ext cx="731520" cy="548640"/>
+          </a:xfrm>
+          <a:prstGeom prst="rect">
+            <a:avLst/>
+          </a:prstGeom>
+          <a:noFill/>
+          <a:ln/>
+        </p:spPr>
+        <p:txBody>
+          <a:bodyPr wrap="square" lIns="0" tIns="0" rIns="0" bIns="0" rtlCol="0" anchor="ctr"/>
+          <a:lstStyle/>
+          <a:p>
+            <a:pPr indent="0" marL="0">
+              <a:buNone/>
+            </a:pPr>
+            <a:r>
+              <a:rPr lang="en-US" sz="1100" dirty="0">
+                <a:solidFill>
+                  <a:srgbClr val="D8E4F4"/>
+                </a:solidFill>
+                <a:latin typeface="Calibri" pitchFamily="34" charset="0"/>
+                <a:ea typeface="Calibri" pitchFamily="34" charset="-122"/>
+                <a:cs typeface="Calibri" pitchFamily="34" charset="-120"/>
+              </a:rPr>
+              <a:t>N5</a:t>
+            </a:r>
+            <a:endParaRPr lang="en-US" sz="1100" dirty="0"/>
+          </a:p>
+        </p:txBody>
+      </p:sp>
+      <p:sp>
+        <p:nvSpPr>
+          <p:cNvPr id="21" name="Text 18"/>
+          <p:cNvSpPr txBox="1"/>
+          <p:nvPr/>
+        </p:nvSpPr>
+        <p:spPr>
+          <a:xfrm>
+            <a:off x="3968496" y="2157984"/>
+            <a:ext cx="1554480" cy="548640"/>
+          </a:xfrm>
+          <a:prstGeom prst="rect">
+            <a:avLst/>
+          </a:prstGeom>
+          <a:noFill/>
+          <a:ln/>
+        </p:spPr>
+        <p:txBody>
+          <a:bodyPr wrap="square" lIns="0" tIns="0" rIns="0" bIns="0" rtlCol="0" anchor="ctr"/>
+          <a:lstStyle/>
+          <a:p>
+            <a:pPr indent="0" marL="0">
+              <a:buNone/>
+            </a:pPr>
+            <a:r>
+              <a:rPr lang="en-US" sz="1100" dirty="0">
+                <a:solidFill>
+                  <a:srgbClr val="D8E4F4"/>
+                </a:solidFill>
+                <a:latin typeface="Calibri" pitchFamily="34" charset="0"/>
+                <a:ea typeface="Calibri" pitchFamily="34" charset="-122"/>
+                <a:cs typeface="Calibri" pitchFamily="34" charset="-120"/>
+              </a:rPr>
+              <a:t>Deyvid</a:t>
+            </a:r>
+            <a:endParaRPr lang="en-US" sz="1100" dirty="0"/>
+          </a:p>
+        </p:txBody>
+      </p:sp>
+      <p:sp>
+        <p:nvSpPr>
+          <p:cNvPr id="22" name="Shape 19"/>
+          <p:cNvSpPr/>
+          <p:nvPr/>
+        </p:nvSpPr>
+        <p:spPr>
+          <a:xfrm>
+            <a:off x="5705856" y="2313432"/>
+            <a:ext cx="1371600" cy="237744"/>
+          </a:xfrm>
+          <a:prstGeom prst="roundRect">
+            <a:avLst>
+              <a:gd name="adj" fmla="val 23077"/>
+            </a:avLst>
+          </a:prstGeom>
+          <a:solidFill>
+            <a:srgbClr val="E9A13B"/>
+          </a:solidFill>
+          <a:ln w="9525">
+            <a:solidFill>
+              <a:srgbClr val="E9A13B"/>
+            </a:solidFill>
+            <a:prstDash val="solid"/>
+          </a:ln>
+        </p:spPr>
+      </p:sp>
+      <p:sp>
+        <p:nvSpPr>
+          <p:cNvPr id="23" name="Text 20"/>
+          <p:cNvSpPr txBox="1"/>
+          <p:nvPr/>
+        </p:nvSpPr>
+        <p:spPr>
+          <a:xfrm>
+            <a:off x="5705856" y="2313432"/>
+            <a:ext cx="1371600" cy="237744"/>
+          </a:xfrm>
+          <a:prstGeom prst="rect">
+            <a:avLst/>
+          </a:prstGeom>
+          <a:noFill/>
+          <a:ln/>
+        </p:spPr>
+        <p:txBody>
+          <a:bodyPr wrap="square" lIns="0" tIns="0" rIns="0" bIns="0" rtlCol="0" anchor="ctr"/>
+          <a:lstStyle/>
+          <a:p>
+            <a:pPr algn="ctr" indent="0" marL="0">
+              <a:buNone/>
+            </a:pPr>
+            <a:r>
+              <a:rPr lang="en-US" sz="800" b="1" spc="60" kern="0" dirty="0">
+                <a:solidFill>
+                  <a:srgbClr val="16273F"/>
+                </a:solidFill>
+                <a:latin typeface="Calibri" pitchFamily="34" charset="0"/>
+                <a:ea typeface="Calibri" pitchFamily="34" charset="-122"/>
+                <a:cs typeface="Calibri" pitchFamily="34" charset="-120"/>
+              </a:rPr>
+              <a:t>CONCLUÍDO</a:t>
+            </a:r>
+            <a:endParaRPr lang="en-US" sz="800" dirty="0"/>
+          </a:p>
+        </p:txBody>
+      </p:sp>
+      <p:sp>
+        <p:nvSpPr>
+          <p:cNvPr id="24" name="Text 21"/>
+          <p:cNvSpPr txBox="1"/>
+          <p:nvPr/>
+        </p:nvSpPr>
+        <p:spPr>
+          <a:xfrm>
+            <a:off x="7260336" y="2157984"/>
+            <a:ext cx="731520" cy="548640"/>
+          </a:xfrm>
+          <a:prstGeom prst="rect">
+            <a:avLst/>
+          </a:prstGeom>
+          <a:noFill/>
+          <a:ln/>
+        </p:spPr>
+        <p:txBody>
+          <a:bodyPr wrap="square" lIns="0" tIns="0" rIns="0" bIns="0" rtlCol="0" anchor="ctr"/>
+          <a:lstStyle/>
+          <a:p>
+            <a:pPr indent="0" marL="0">
+              <a:buNone/>
+            </a:pPr>
+            <a:r>
+              <a:rPr lang="en-US" sz="1100" b="1" dirty="0">
+                <a:solidFill>
+                  <a:srgbClr val="FFFFFF"/>
+                </a:solidFill>
+                <a:latin typeface="Calibri" pitchFamily="34" charset="0"/>
+                <a:ea typeface="Calibri" pitchFamily="34" charset="-122"/>
+                <a:cs typeface="Calibri" pitchFamily="34" charset="-120"/>
+              </a:rPr>
+              <a:t>29/set</a:t>
+            </a:r>
+            <a:endParaRPr lang="en-US" sz="1100" dirty="0"/>
+          </a:p>
+        </p:txBody>
+      </p:sp>
+      <p:sp>
+        <p:nvSpPr>
+          <p:cNvPr id="25" name="Text 22"/>
+          <p:cNvSpPr txBox="1"/>
+          <p:nvPr/>
+        </p:nvSpPr>
+        <p:spPr>
+          <a:xfrm>
+            <a:off x="8174736" y="2157984"/>
+            <a:ext cx="1298448" cy="548640"/>
+          </a:xfrm>
+          <a:prstGeom prst="rect">
+            <a:avLst/>
+          </a:prstGeom>
+          <a:noFill/>
+          <a:ln/>
+        </p:spPr>
+        <p:txBody>
+          <a:bodyPr wrap="square" lIns="0" tIns="0" rIns="0" bIns="0" rtlCol="0" anchor="ctr"/>
+          <a:lstStyle/>
+          <a:p>
+            <a:pPr indent="0" marL="0">
+              <a:buNone/>
+            </a:pPr>
+            <a:r>
+              <a:rPr lang="en-US" sz="1100" dirty="0">
+                <a:solidFill>
+                  <a:srgbClr val="D8E4F4"/>
+                </a:solidFill>
+                <a:latin typeface="Calibri" pitchFamily="34" charset="0"/>
+                <a:ea typeface="Calibri" pitchFamily="34" charset="-122"/>
+                <a:cs typeface="Calibri" pitchFamily="34" charset="-120"/>
+              </a:rPr>
+              <a:t>Sim</a:t>
+            </a:r>
+            <a:endParaRPr lang="en-US" sz="1100" dirty="0"/>
+          </a:p>
+        </p:txBody>
+      </p:sp>
+      <p:sp>
+        <p:nvSpPr>
+          <p:cNvPr id="26" name="Text 23"/>
+          <p:cNvSpPr txBox="1"/>
+          <p:nvPr/>
+        </p:nvSpPr>
+        <p:spPr>
+          <a:xfrm>
+            <a:off x="9656064" y="2157984"/>
+            <a:ext cx="1856232" cy="548640"/>
+          </a:xfrm>
+          <a:prstGeom prst="rect">
+            <a:avLst/>
+          </a:prstGeom>
+          <a:noFill/>
+          <a:ln/>
+        </p:spPr>
+        <p:txBody>
+          <a:bodyPr wrap="square" lIns="0" tIns="0" rIns="0" bIns="0" rtlCol="0" anchor="ctr"/>
+          <a:lstStyle/>
+          <a:p>
+            <a:pPr indent="0" marL="0">
+              <a:lnSpc>
+                <a:spcPct val="108000"/>
+              </a:lnSpc>
+              <a:buNone/>
+            </a:pPr>
+            <a:r>
+              <a:rPr lang="en-US" sz="950" dirty="0">
+                <a:solidFill>
+                  <a:srgbClr val="93A9C6"/>
+                </a:solidFill>
+                <a:latin typeface="Calibri" pitchFamily="34" charset="0"/>
+                <a:ea typeface="Calibri" pitchFamily="34" charset="-122"/>
+                <a:cs typeface="Calibri" pitchFamily="34" charset="-120"/>
+              </a:rPr>
+              <a:t>Entregue e apresentado</a:t>
+            </a:r>
+            <a:endParaRPr lang="en-US" sz="950" dirty="0"/>
+          </a:p>
+        </p:txBody>
+      </p:sp>
+      <p:sp>
+        <p:nvSpPr>
+          <p:cNvPr id="27" name="Shape 24"/>
+          <p:cNvSpPr/>
+          <p:nvPr/>
+        </p:nvSpPr>
+        <p:spPr>
+          <a:xfrm>
+            <a:off x="566928" y="2779776"/>
+            <a:ext cx="11055096" cy="548640"/>
+          </a:xfrm>
+          <a:prstGeom prst="roundRect">
+            <a:avLst>
+              <a:gd name="adj" fmla="val 11667"/>
+            </a:avLst>
+          </a:prstGeom>
+          <a:solidFill>
+            <a:srgbClr val="FFFFFF">
+              <a:alpha val="6000"/>
+            </a:srgbClr>
+          </a:solidFill>
+          <a:ln w="12700">
+            <a:solidFill>
+              <a:srgbClr val="31507F">
+                <a:alpha val="55000"/>
+              </a:srgbClr>
+            </a:solidFill>
+            <a:prstDash val="solid"/>
+          </a:ln>
+        </p:spPr>
+      </p:sp>
+      <p:sp>
+        <p:nvSpPr>
+          <p:cNvPr id="28" name="Text 25"/>
+          <p:cNvSpPr txBox="1"/>
+          <p:nvPr/>
+        </p:nvSpPr>
+        <p:spPr>
+          <a:xfrm>
+            <a:off x="822960" y="2779776"/>
+            <a:ext cx="2011680" cy="548640"/>
+          </a:xfrm>
+          <a:prstGeom prst="rect">
+            <a:avLst/>
+          </a:prstGeom>
+          <a:noFill/>
+          <a:ln/>
+        </p:spPr>
+        <p:txBody>
+          <a:bodyPr wrap="square" lIns="0" tIns="0" rIns="0" bIns="0" rtlCol="0" anchor="ctr"/>
+          <a:lstStyle/>
+          <a:p>
+            <a:pPr indent="0" marL="0">
+              <a:buNone/>
+            </a:pPr>
+            <a:r>
+              <a:rPr lang="en-US" sz="1150" b="1" dirty="0">
+                <a:solidFill>
+                  <a:srgbClr val="FFFFFF"/>
+                </a:solidFill>
+                <a:latin typeface="Calibri" pitchFamily="34" charset="0"/>
+                <a:ea typeface="Calibri" pitchFamily="34" charset="-122"/>
+                <a:cs typeface="Calibri" pitchFamily="34" charset="-120"/>
+              </a:rPr>
+              <a:t>Dashboard D-1</a:t>
+            </a:r>
+            <a:endParaRPr lang="en-US" sz="1150" dirty="0"/>
+          </a:p>
+        </p:txBody>
+      </p:sp>
+      <p:sp>
+        <p:nvSpPr>
+          <p:cNvPr id="29" name="Text 26"/>
+          <p:cNvSpPr txBox="1"/>
+          <p:nvPr/>
+        </p:nvSpPr>
+        <p:spPr>
+          <a:xfrm>
+            <a:off x="3054096" y="2779776"/>
+            <a:ext cx="731520" cy="548640"/>
+          </a:xfrm>
+          <a:prstGeom prst="rect">
+            <a:avLst/>
+          </a:prstGeom>
+          <a:noFill/>
+          <a:ln/>
+        </p:spPr>
+        <p:txBody>
+          <a:bodyPr wrap="square" lIns="0" tIns="0" rIns="0" bIns="0" rtlCol="0" anchor="ctr"/>
+          <a:lstStyle/>
+          <a:p>
+            <a:pPr indent="0" marL="0">
+              <a:buNone/>
+            </a:pPr>
+            <a:r>
+              <a:rPr lang="en-US" sz="1100" dirty="0">
+                <a:solidFill>
+                  <a:srgbClr val="D8E4F4"/>
+                </a:solidFill>
+                <a:latin typeface="Calibri" pitchFamily="34" charset="0"/>
+                <a:ea typeface="Calibri" pitchFamily="34" charset="-122"/>
+                <a:cs typeface="Calibri" pitchFamily="34" charset="-120"/>
+              </a:rPr>
+              <a:t>N5</a:t>
+            </a:r>
+            <a:endParaRPr lang="en-US" sz="1100" dirty="0"/>
+          </a:p>
+        </p:txBody>
+      </p:sp>
+      <p:sp>
+        <p:nvSpPr>
+          <p:cNvPr id="30" name="Text 27"/>
+          <p:cNvSpPr txBox="1"/>
+          <p:nvPr/>
+        </p:nvSpPr>
+        <p:spPr>
+          <a:xfrm>
+            <a:off x="3968496" y="2779776"/>
+            <a:ext cx="1554480" cy="548640"/>
+          </a:xfrm>
+          <a:prstGeom prst="rect">
+            <a:avLst/>
+          </a:prstGeom>
+          <a:noFill/>
+          <a:ln/>
+        </p:spPr>
+        <p:txBody>
+          <a:bodyPr wrap="square" lIns="0" tIns="0" rIns="0" bIns="0" rtlCol="0" anchor="ctr"/>
+          <a:lstStyle/>
+          <a:p>
+            <a:pPr indent="0" marL="0">
+              <a:buNone/>
+            </a:pPr>
+            <a:r>
+              <a:rPr lang="en-US" sz="1100" dirty="0">
+                <a:solidFill>
+                  <a:srgbClr val="D8E4F4"/>
+                </a:solidFill>
+                <a:latin typeface="Calibri" pitchFamily="34" charset="0"/>
+                <a:ea typeface="Calibri" pitchFamily="34" charset="-122"/>
+                <a:cs typeface="Calibri" pitchFamily="34" charset="-120"/>
+              </a:rPr>
+              <a:t>Andressa</a:t>
+            </a:r>
+            <a:endParaRPr lang="en-US" sz="1100" dirty="0"/>
+          </a:p>
+        </p:txBody>
+      </p:sp>
+      <p:sp>
+        <p:nvSpPr>
+          <p:cNvPr id="31" name="Shape 28"/>
+          <p:cNvSpPr/>
+          <p:nvPr/>
+        </p:nvSpPr>
+        <p:spPr>
+          <a:xfrm>
+            <a:off x="5705856" y="2935224"/>
+            <a:ext cx="1371600" cy="237744"/>
+          </a:xfrm>
+          <a:prstGeom prst="roundRect">
+            <a:avLst>
+              <a:gd name="adj" fmla="val 23077"/>
+            </a:avLst>
+          </a:prstGeom>
+          <a:solidFill>
+            <a:srgbClr val="FFFFFF">
+              <a:alpha val="12000"/>
+            </a:srgbClr>
+          </a:solidFill>
+          <a:ln w="9525">
+            <a:solidFill>
+              <a:srgbClr val="E9A13B">
+                <a:alpha val="50000"/>
+              </a:srgbClr>
+            </a:solidFill>
+            <a:prstDash val="solid"/>
+          </a:ln>
+        </p:spPr>
+      </p:sp>
+      <p:sp>
+        <p:nvSpPr>
+          <p:cNvPr id="32" name="Text 29"/>
+          <p:cNvSpPr txBox="1"/>
+          <p:nvPr/>
+        </p:nvSpPr>
+        <p:spPr>
+          <a:xfrm>
+            <a:off x="5705856" y="2935224"/>
+            <a:ext cx="1371600" cy="237744"/>
+          </a:xfrm>
+          <a:prstGeom prst="rect">
+            <a:avLst/>
+          </a:prstGeom>
+          <a:noFill/>
+          <a:ln/>
+        </p:spPr>
+        <p:txBody>
+          <a:bodyPr wrap="square" lIns="0" tIns="0" rIns="0" bIns="0" rtlCol="0" anchor="ctr"/>
+          <a:lstStyle/>
+          <a:p>
+            <a:pPr algn="ctr" indent="0" marL="0">
+              <a:buNone/>
+            </a:pPr>
+            <a:r>
+              <a:rPr lang="en-US" sz="800" b="1" spc="60" kern="0" dirty="0">
+                <a:solidFill>
+                  <a:srgbClr val="E9A13B"/>
+                </a:solidFill>
+                <a:latin typeface="Calibri" pitchFamily="34" charset="0"/>
+                <a:ea typeface="Calibri" pitchFamily="34" charset="-122"/>
+                <a:cs typeface="Calibri" pitchFamily="34" charset="-120"/>
+              </a:rPr>
+              <a:t>EM DEV</a:t>
+            </a:r>
+            <a:endParaRPr lang="en-US" sz="800" dirty="0"/>
+          </a:p>
+        </p:txBody>
+      </p:sp>
+      <p:sp>
+        <p:nvSpPr>
+          <p:cNvPr id="33" name="Text 30"/>
+          <p:cNvSpPr txBox="1"/>
+          <p:nvPr/>
+        </p:nvSpPr>
+        <p:spPr>
+          <a:xfrm>
+            <a:off x="7260336" y="2779776"/>
+            <a:ext cx="731520" cy="548640"/>
+          </a:xfrm>
+          <a:prstGeom prst="rect">
+            <a:avLst/>
+          </a:prstGeom>
+          <a:noFill/>
+          <a:ln/>
+        </p:spPr>
+        <p:txBody>
+          <a:bodyPr wrap="square" lIns="0" tIns="0" rIns="0" bIns="0" rtlCol="0" anchor="ctr"/>
+          <a:lstStyle/>
+          <a:p>
+            <a:pPr indent="0" marL="0">
+              <a:buNone/>
+            </a:pPr>
+            <a:r>
+              <a:rPr lang="en-US" sz="1100" b="1" dirty="0">
+                <a:solidFill>
+                  <a:srgbClr val="FFFFFF"/>
+                </a:solidFill>
+                <a:latin typeface="Calibri" pitchFamily="34" charset="0"/>
+                <a:ea typeface="Calibri" pitchFamily="34" charset="-122"/>
+                <a:cs typeface="Calibri" pitchFamily="34" charset="-120"/>
+              </a:rPr>
+              <a:t>05/out</a:t>
+            </a:r>
+            <a:endParaRPr lang="en-US" sz="1100" dirty="0"/>
+          </a:p>
+        </p:txBody>
+      </p:sp>
+      <p:sp>
+        <p:nvSpPr>
+          <p:cNvPr id="34" name="Text 31"/>
+          <p:cNvSpPr txBox="1"/>
+          <p:nvPr/>
+        </p:nvSpPr>
+        <p:spPr>
+          <a:xfrm>
+            <a:off x="8174736" y="2779776"/>
+            <a:ext cx="1298448" cy="548640"/>
+          </a:xfrm>
+          <a:prstGeom prst="rect">
+            <a:avLst/>
+          </a:prstGeom>
+          <a:noFill/>
+          <a:ln/>
+        </p:spPr>
+        <p:txBody>
+          <a:bodyPr wrap="square" lIns="0" tIns="0" rIns="0" bIns="0" rtlCol="0" anchor="ctr"/>
+          <a:lstStyle/>
+          <a:p>
+            <a:pPr indent="0" marL="0">
+              <a:buNone/>
+            </a:pPr>
+            <a:r>
+              <a:rPr lang="en-US" sz="1100" dirty="0">
+                <a:solidFill>
+                  <a:srgbClr val="D8E4F4"/>
+                </a:solidFill>
+                <a:latin typeface="Calibri" pitchFamily="34" charset="0"/>
+                <a:ea typeface="Calibri" pitchFamily="34" charset="-122"/>
+                <a:cs typeface="Calibri" pitchFamily="34" charset="-120"/>
+              </a:rPr>
+              <a:t>Sim</a:t>
+            </a:r>
+            <a:endParaRPr lang="en-US" sz="1100" dirty="0"/>
+          </a:p>
+        </p:txBody>
+      </p:sp>
+      <p:sp>
+        <p:nvSpPr>
+          <p:cNvPr id="35" name="Text 32"/>
+          <p:cNvSpPr txBox="1"/>
+          <p:nvPr/>
+        </p:nvSpPr>
+        <p:spPr>
+          <a:xfrm>
+            <a:off x="9656064" y="2779776"/>
+            <a:ext cx="1856232" cy="548640"/>
+          </a:xfrm>
+          <a:prstGeom prst="rect">
+            <a:avLst/>
+          </a:prstGeom>
+          <a:noFill/>
+          <a:ln/>
+        </p:spPr>
+        <p:txBody>
+          <a:bodyPr wrap="square" lIns="0" tIns="0" rIns="0" bIns="0" rtlCol="0" anchor="ctr"/>
+          <a:lstStyle/>
+          <a:p>
+            <a:pPr indent="0" marL="0">
+              <a:lnSpc>
+                <a:spcPct val="108000"/>
+              </a:lnSpc>
+              <a:buNone/>
+            </a:pPr>
+            <a:r>
+              <a:rPr lang="en-US" sz="950" dirty="0">
+                <a:solidFill>
+                  <a:srgbClr val="93A9C6"/>
+                </a:solidFill>
+                <a:latin typeface="Calibri" pitchFamily="34" charset="0"/>
+                <a:ea typeface="Calibri" pitchFamily="34" charset="-122"/>
+                <a:cs typeface="Calibri" pitchFamily="34" charset="-120"/>
+              </a:rPr>
+              <a:t>Em construção</a:t>
+            </a:r>
+            <a:endParaRPr lang="en-US" sz="950" dirty="0"/>
+          </a:p>
+        </p:txBody>
+      </p:sp>
+      <p:sp>
+        <p:nvSpPr>
+          <p:cNvPr id="36" name="Shape 33"/>
+          <p:cNvSpPr/>
+          <p:nvPr/>
+        </p:nvSpPr>
+        <p:spPr>
+          <a:xfrm>
+            <a:off x="566928" y="3401568"/>
+            <a:ext cx="11055096" cy="548640"/>
+          </a:xfrm>
+          <a:prstGeom prst="roundRect">
+            <a:avLst>
+              <a:gd name="adj" fmla="val 11667"/>
+            </a:avLst>
+          </a:prstGeom>
+          <a:solidFill>
+            <a:srgbClr val="FFFFFF">
+              <a:alpha val="6000"/>
+            </a:srgbClr>
+          </a:solidFill>
+          <a:ln w="12700">
+            <a:solidFill>
+              <a:srgbClr val="31507F">
+                <a:alpha val="55000"/>
+              </a:srgbClr>
+            </a:solidFill>
+            <a:prstDash val="solid"/>
+          </a:ln>
+        </p:spPr>
+      </p:sp>
+      <p:sp>
+        <p:nvSpPr>
+          <p:cNvPr id="37" name="Text 34"/>
+          <p:cNvSpPr txBox="1"/>
+          <p:nvPr/>
+        </p:nvSpPr>
+        <p:spPr>
+          <a:xfrm>
+            <a:off x="822960" y="3401568"/>
+            <a:ext cx="2011680" cy="548640"/>
+          </a:xfrm>
+          <a:prstGeom prst="rect">
+            <a:avLst/>
+          </a:prstGeom>
+          <a:noFill/>
+          <a:ln/>
+        </p:spPr>
+        <p:txBody>
+          <a:bodyPr wrap="square" lIns="0" tIns="0" rIns="0" bIns="0" rtlCol="0" anchor="ctr"/>
+          <a:lstStyle/>
+          <a:p>
+            <a:pPr indent="0" marL="0">
+              <a:buNone/>
+            </a:pPr>
+            <a:r>
+              <a:rPr lang="en-US" sz="1150" b="1" dirty="0">
+                <a:solidFill>
+                  <a:srgbClr val="FFFFFF"/>
+                </a:solidFill>
+                <a:latin typeface="Calibri" pitchFamily="34" charset="0"/>
+                <a:ea typeface="Calibri" pitchFamily="34" charset="-122"/>
+                <a:cs typeface="Calibri" pitchFamily="34" charset="-120"/>
+              </a:rPr>
+              <a:t>Dashboard D-1</a:t>
+            </a:r>
+            <a:endParaRPr lang="en-US" sz="1150" dirty="0"/>
+          </a:p>
+        </p:txBody>
+      </p:sp>
+      <p:sp>
+        <p:nvSpPr>
+          <p:cNvPr id="38" name="Text 35"/>
+          <p:cNvSpPr txBox="1"/>
+          <p:nvPr/>
+        </p:nvSpPr>
+        <p:spPr>
+          <a:xfrm>
+            <a:off x="3054096" y="3401568"/>
+            <a:ext cx="731520" cy="548640"/>
+          </a:xfrm>
+          <a:prstGeom prst="rect">
+            <a:avLst/>
+          </a:prstGeom>
+          <a:noFill/>
+          <a:ln/>
+        </p:spPr>
+        <p:txBody>
+          <a:bodyPr wrap="square" lIns="0" tIns="0" rIns="0" bIns="0" rtlCol="0" anchor="ctr"/>
+          <a:lstStyle/>
+          <a:p>
+            <a:pPr indent="0" marL="0">
+              <a:buNone/>
+            </a:pPr>
+            <a:r>
+              <a:rPr lang="en-US" sz="1100" dirty="0">
+                <a:solidFill>
+                  <a:srgbClr val="D8E4F4"/>
+                </a:solidFill>
+                <a:latin typeface="Calibri" pitchFamily="34" charset="0"/>
+                <a:ea typeface="Calibri" pitchFamily="34" charset="-122"/>
+                <a:cs typeface="Calibri" pitchFamily="34" charset="-120"/>
+              </a:rPr>
+              <a:t>N4</a:t>
+            </a:r>
+            <a:endParaRPr lang="en-US" sz="1100" dirty="0"/>
+          </a:p>
+        </p:txBody>
+      </p:sp>
+      <p:sp>
+        <p:nvSpPr>
+          <p:cNvPr id="39" name="Text 36"/>
+          <p:cNvSpPr txBox="1"/>
+          <p:nvPr/>
+        </p:nvSpPr>
+        <p:spPr>
+          <a:xfrm>
+            <a:off x="3968496" y="3401568"/>
+            <a:ext cx="1554480" cy="548640"/>
+          </a:xfrm>
+          <a:prstGeom prst="rect">
+            <a:avLst/>
+          </a:prstGeom>
+          <a:noFill/>
+          <a:ln/>
+        </p:spPr>
+        <p:txBody>
+          <a:bodyPr wrap="square" lIns="0" tIns="0" rIns="0" bIns="0" rtlCol="0" anchor="ctr"/>
+          <a:lstStyle/>
+          <a:p>
+            <a:pPr indent="0" marL="0">
+              <a:buNone/>
+            </a:pPr>
+            <a:r>
+              <a:rPr lang="en-US" sz="1100" dirty="0">
+                <a:solidFill>
+                  <a:srgbClr val="D8E4F4"/>
+                </a:solidFill>
+                <a:latin typeface="Calibri" pitchFamily="34" charset="0"/>
+                <a:ea typeface="Calibri" pitchFamily="34" charset="-122"/>
+                <a:cs typeface="Calibri" pitchFamily="34" charset="-120"/>
+              </a:rPr>
+              <a:t>Lucas</a:t>
+            </a:r>
+            <a:endParaRPr lang="en-US" sz="1100" dirty="0"/>
+          </a:p>
+        </p:txBody>
+      </p:sp>
+      <p:sp>
+        <p:nvSpPr>
+          <p:cNvPr id="40" name="Shape 37"/>
+          <p:cNvSpPr/>
+          <p:nvPr/>
+        </p:nvSpPr>
+        <p:spPr>
+          <a:xfrm>
+            <a:off x="5705856" y="3557016"/>
+            <a:ext cx="1371600" cy="237744"/>
+          </a:xfrm>
+          <a:prstGeom prst="roundRect">
+            <a:avLst>
+              <a:gd name="adj" fmla="val 23077"/>
+            </a:avLst>
+          </a:prstGeom>
+          <a:solidFill>
+            <a:srgbClr val="FFFFFF">
+              <a:alpha val="12000"/>
+            </a:srgbClr>
+          </a:solidFill>
+          <a:ln w="9525">
+            <a:solidFill>
+              <a:srgbClr val="E9A13B">
+                <a:alpha val="50000"/>
+              </a:srgbClr>
+            </a:solidFill>
+            <a:prstDash val="solid"/>
+          </a:ln>
+        </p:spPr>
+      </p:sp>
+      <p:sp>
+        <p:nvSpPr>
+          <p:cNvPr id="41" name="Text 38"/>
+          <p:cNvSpPr txBox="1"/>
+          <p:nvPr/>
+        </p:nvSpPr>
+        <p:spPr>
+          <a:xfrm>
+            <a:off x="5705856" y="3557016"/>
+            <a:ext cx="1371600" cy="237744"/>
+          </a:xfrm>
+          <a:prstGeom prst="rect">
+            <a:avLst/>
+          </a:prstGeom>
+          <a:noFill/>
+          <a:ln/>
+        </p:spPr>
+        <p:txBody>
+          <a:bodyPr wrap="square" lIns="0" tIns="0" rIns="0" bIns="0" rtlCol="0" anchor="ctr"/>
+          <a:lstStyle/>
+          <a:p>
+            <a:pPr algn="ctr" indent="0" marL="0">
+              <a:buNone/>
+            </a:pPr>
+            <a:r>
+              <a:rPr lang="en-US" sz="800" b="1" spc="60" kern="0" dirty="0">
+                <a:solidFill>
+                  <a:srgbClr val="E9A13B"/>
+                </a:solidFill>
+                <a:latin typeface="Calibri" pitchFamily="34" charset="0"/>
+                <a:ea typeface="Calibri" pitchFamily="34" charset="-122"/>
+                <a:cs typeface="Calibri" pitchFamily="34" charset="-120"/>
+              </a:rPr>
+              <a:t>EM DEV</a:t>
+            </a:r>
+            <a:endParaRPr lang="en-US" sz="800" dirty="0"/>
+          </a:p>
+        </p:txBody>
+      </p:sp>
+      <p:sp>
+        <p:nvSpPr>
+          <p:cNvPr id="42" name="Text 39"/>
+          <p:cNvSpPr txBox="1"/>
+          <p:nvPr/>
+        </p:nvSpPr>
+        <p:spPr>
+          <a:xfrm>
+            <a:off x="7260336" y="3401568"/>
+            <a:ext cx="731520" cy="548640"/>
+          </a:xfrm>
+          <a:prstGeom prst="rect">
+            <a:avLst/>
+          </a:prstGeom>
+          <a:noFill/>
+          <a:ln/>
+        </p:spPr>
+        <p:txBody>
+          <a:bodyPr wrap="square" lIns="0" tIns="0" rIns="0" bIns="0" rtlCol="0" anchor="ctr"/>
+          <a:lstStyle/>
+          <a:p>
+            <a:pPr indent="0" marL="0">
+              <a:buNone/>
+            </a:pPr>
+            <a:r>
+              <a:rPr lang="en-US" sz="1100" b="1" dirty="0">
+                <a:solidFill>
+                  <a:srgbClr val="FFFFFF"/>
+                </a:solidFill>
+                <a:latin typeface="Calibri" pitchFamily="34" charset="0"/>
+                <a:ea typeface="Calibri" pitchFamily="34" charset="-122"/>
+                <a:cs typeface="Calibri" pitchFamily="34" charset="-120"/>
+              </a:rPr>
+              <a:t>09/out</a:t>
+            </a:r>
+            <a:endParaRPr lang="en-US" sz="1100" dirty="0"/>
+          </a:p>
+        </p:txBody>
+      </p:sp>
+      <p:sp>
+        <p:nvSpPr>
+          <p:cNvPr id="43" name="Text 40"/>
+          <p:cNvSpPr txBox="1"/>
+          <p:nvPr/>
+        </p:nvSpPr>
+        <p:spPr>
+          <a:xfrm>
+            <a:off x="8174736" y="3401568"/>
+            <a:ext cx="1298448" cy="548640"/>
+          </a:xfrm>
+          <a:prstGeom prst="rect">
+            <a:avLst/>
+          </a:prstGeom>
+          <a:noFill/>
+          <a:ln/>
+        </p:spPr>
+        <p:txBody>
+          <a:bodyPr wrap="square" lIns="0" tIns="0" rIns="0" bIns="0" rtlCol="0" anchor="ctr"/>
+          <a:lstStyle/>
+          <a:p>
+            <a:pPr indent="0" marL="0">
+              <a:buNone/>
+            </a:pPr>
+            <a:r>
+              <a:rPr lang="en-US" sz="1100" dirty="0">
+                <a:solidFill>
+                  <a:srgbClr val="D8E4F4"/>
+                </a:solidFill>
+                <a:latin typeface="Calibri" pitchFamily="34" charset="0"/>
+                <a:ea typeface="Calibri" pitchFamily="34" charset="-122"/>
+                <a:cs typeface="Calibri" pitchFamily="34" charset="-120"/>
+              </a:rPr>
+              <a:t>Sim</a:t>
+            </a:r>
+            <a:endParaRPr lang="en-US" sz="1100" dirty="0"/>
+          </a:p>
+        </p:txBody>
+      </p:sp>
+      <p:sp>
+        <p:nvSpPr>
+          <p:cNvPr id="44" name="Text 41"/>
+          <p:cNvSpPr txBox="1"/>
+          <p:nvPr/>
+        </p:nvSpPr>
+        <p:spPr>
+          <a:xfrm>
+            <a:off x="9656064" y="3401568"/>
+            <a:ext cx="1856232" cy="548640"/>
+          </a:xfrm>
+          <a:prstGeom prst="rect">
+            <a:avLst/>
+          </a:prstGeom>
+          <a:noFill/>
+          <a:ln/>
+        </p:spPr>
+        <p:txBody>
+          <a:bodyPr wrap="square" lIns="0" tIns="0" rIns="0" bIns="0" rtlCol="0" anchor="ctr"/>
+          <a:lstStyle/>
+          <a:p>
+            <a:pPr indent="0" marL="0">
+              <a:lnSpc>
+                <a:spcPct val="108000"/>
+              </a:lnSpc>
+              <a:buNone/>
+            </a:pPr>
+            <a:r>
+              <a:rPr lang="en-US" sz="950" dirty="0">
+                <a:solidFill>
+                  <a:srgbClr val="93A9C6"/>
+                </a:solidFill>
+                <a:latin typeface="Calibri" pitchFamily="34" charset="0"/>
+                <a:ea typeface="Calibri" pitchFamily="34" charset="-122"/>
+                <a:cs typeface="Calibri" pitchFamily="34" charset="-120"/>
+              </a:rPr>
+              <a:t>Em construção</a:t>
+            </a:r>
+            <a:endParaRPr lang="en-US" sz="950" dirty="0"/>
+          </a:p>
+        </p:txBody>
+      </p:sp>
+      <p:sp>
+        <p:nvSpPr>
+          <p:cNvPr id="45" name="Shape 42"/>
+          <p:cNvSpPr/>
+          <p:nvPr/>
+        </p:nvSpPr>
+        <p:spPr>
+          <a:xfrm>
+            <a:off x="566928" y="4023360"/>
+            <a:ext cx="11055096" cy="548640"/>
+          </a:xfrm>
+          <a:prstGeom prst="roundRect">
+            <a:avLst>
+              <a:gd name="adj" fmla="val 11667"/>
+            </a:avLst>
+          </a:prstGeom>
+          <a:solidFill>
+            <a:srgbClr val="FFFFFF">
+              <a:alpha val="6000"/>
+            </a:srgbClr>
+          </a:solidFill>
+          <a:ln w="12700">
+            <a:solidFill>
+              <a:srgbClr val="31507F">
+                <a:alpha val="55000"/>
+              </a:srgbClr>
+            </a:solidFill>
+            <a:prstDash val="solid"/>
+          </a:ln>
+        </p:spPr>
+      </p:sp>
+      <p:sp>
+        <p:nvSpPr>
+          <p:cNvPr id="46" name="Text 43"/>
+          <p:cNvSpPr txBox="1"/>
+          <p:nvPr/>
+        </p:nvSpPr>
+        <p:spPr>
+          <a:xfrm>
+            <a:off x="822960" y="4023360"/>
+            <a:ext cx="2011680" cy="548640"/>
+          </a:xfrm>
+          <a:prstGeom prst="rect">
+            <a:avLst/>
+          </a:prstGeom>
+          <a:noFill/>
+          <a:ln/>
+        </p:spPr>
+        <p:txBody>
+          <a:bodyPr wrap="square" lIns="0" tIns="0" rIns="0" bIns="0" rtlCol="0" anchor="ctr"/>
+          <a:lstStyle/>
+          <a:p>
+            <a:pPr indent="0" marL="0">
+              <a:buNone/>
+            </a:pPr>
+            <a:r>
+              <a:rPr lang="en-US" sz="1150" b="1" dirty="0">
+                <a:solidFill>
+                  <a:srgbClr val="FFFFFF"/>
+                </a:solidFill>
+                <a:latin typeface="Calibri" pitchFamily="34" charset="0"/>
+                <a:ea typeface="Calibri" pitchFamily="34" charset="-122"/>
+                <a:cs typeface="Calibri" pitchFamily="34" charset="-120"/>
+              </a:rPr>
+              <a:t>Hora a Hora</a:t>
+            </a:r>
+            <a:endParaRPr lang="en-US" sz="1150" dirty="0"/>
+          </a:p>
+        </p:txBody>
+      </p:sp>
+      <p:sp>
+        <p:nvSpPr>
+          <p:cNvPr id="47" name="Text 44"/>
+          <p:cNvSpPr txBox="1"/>
+          <p:nvPr/>
+        </p:nvSpPr>
+        <p:spPr>
+          <a:xfrm>
+            <a:off x="3054096" y="4023360"/>
+            <a:ext cx="731520" cy="548640"/>
+          </a:xfrm>
+          <a:prstGeom prst="rect">
+            <a:avLst/>
+          </a:prstGeom>
+          <a:noFill/>
+          <a:ln/>
+        </p:spPr>
+        <p:txBody>
+          <a:bodyPr wrap="square" lIns="0" tIns="0" rIns="0" bIns="0" rtlCol="0" anchor="ctr"/>
+          <a:lstStyle/>
+          <a:p>
+            <a:pPr indent="0" marL="0">
+              <a:buNone/>
+            </a:pPr>
+            <a:r>
+              <a:rPr lang="en-US" sz="1100" dirty="0">
+                <a:solidFill>
+                  <a:srgbClr val="D8E4F4"/>
+                </a:solidFill>
+                <a:latin typeface="Calibri" pitchFamily="34" charset="0"/>
+                <a:ea typeface="Calibri" pitchFamily="34" charset="-122"/>
+                <a:cs typeface="Calibri" pitchFamily="34" charset="-120"/>
+              </a:rPr>
+              <a:t>N5</a:t>
+            </a:r>
+            <a:endParaRPr lang="en-US" sz="1100" dirty="0"/>
+          </a:p>
+        </p:txBody>
+      </p:sp>
+      <p:sp>
+        <p:nvSpPr>
+          <p:cNvPr id="48" name="Text 45"/>
+          <p:cNvSpPr txBox="1"/>
+          <p:nvPr/>
+        </p:nvSpPr>
+        <p:spPr>
+          <a:xfrm>
+            <a:off x="3968496" y="4023360"/>
+            <a:ext cx="1554480" cy="548640"/>
+          </a:xfrm>
+          <a:prstGeom prst="rect">
+            <a:avLst/>
+          </a:prstGeom>
+          <a:noFill/>
+          <a:ln/>
+        </p:spPr>
+        <p:txBody>
+          <a:bodyPr wrap="square" lIns="0" tIns="0" rIns="0" bIns="0" rtlCol="0" anchor="ctr"/>
+          <a:lstStyle/>
+          <a:p>
+            <a:pPr indent="0" marL="0">
+              <a:buNone/>
+            </a:pPr>
+            <a:r>
+              <a:rPr lang="en-US" sz="1100" dirty="0">
+                <a:solidFill>
+                  <a:srgbClr val="D8E4F4"/>
+                </a:solidFill>
+                <a:latin typeface="Calibri" pitchFamily="34" charset="0"/>
+                <a:ea typeface="Calibri" pitchFamily="34" charset="-122"/>
+                <a:cs typeface="Calibri" pitchFamily="34" charset="-120"/>
+              </a:rPr>
+              <a:t>Andressa / Deyvid</a:t>
+            </a:r>
+            <a:endParaRPr lang="en-US" sz="1100" dirty="0"/>
+          </a:p>
+        </p:txBody>
+      </p:sp>
+      <p:sp>
+        <p:nvSpPr>
+          <p:cNvPr id="49" name="Shape 46"/>
+          <p:cNvSpPr/>
+          <p:nvPr/>
+        </p:nvSpPr>
+        <p:spPr>
+          <a:xfrm>
+            <a:off x="5705856" y="4178808"/>
+            <a:ext cx="1371600" cy="237744"/>
+          </a:xfrm>
+          <a:prstGeom prst="roundRect">
+            <a:avLst>
+              <a:gd name="adj" fmla="val 23077"/>
+            </a:avLst>
+          </a:prstGeom>
+          <a:solidFill>
+            <a:srgbClr val="FFFFFF">
+              <a:alpha val="12000"/>
+            </a:srgbClr>
+          </a:solidFill>
+          <a:ln w="9525">
+            <a:solidFill>
+              <a:srgbClr val="E9A13B">
+                <a:alpha val="50000"/>
+              </a:srgbClr>
+            </a:solidFill>
+            <a:prstDash val="solid"/>
+          </a:ln>
+        </p:spPr>
+      </p:sp>
+      <p:sp>
+        <p:nvSpPr>
+          <p:cNvPr id="50" name="Text 47"/>
+          <p:cNvSpPr txBox="1"/>
+          <p:nvPr/>
+        </p:nvSpPr>
+        <p:spPr>
+          <a:xfrm>
+            <a:off x="5705856" y="4178808"/>
+            <a:ext cx="1371600" cy="237744"/>
+          </a:xfrm>
+          <a:prstGeom prst="rect">
+            <a:avLst/>
+          </a:prstGeom>
+          <a:noFill/>
+          <a:ln/>
+        </p:spPr>
+        <p:txBody>
+          <a:bodyPr wrap="square" lIns="0" tIns="0" rIns="0" bIns="0" rtlCol="0" anchor="ctr"/>
+          <a:lstStyle/>
+          <a:p>
+            <a:pPr algn="ctr" indent="0" marL="0">
+              <a:buNone/>
+            </a:pPr>
+            <a:r>
+              <a:rPr lang="en-US" sz="800" b="1" spc="60" kern="0" dirty="0">
+                <a:solidFill>
+                  <a:srgbClr val="E9A13B"/>
+                </a:solidFill>
+                <a:latin typeface="Calibri" pitchFamily="34" charset="0"/>
+                <a:ea typeface="Calibri" pitchFamily="34" charset="-122"/>
+                <a:cs typeface="Calibri" pitchFamily="34" charset="-120"/>
+              </a:rPr>
+              <a:t>EM DEV</a:t>
+            </a:r>
+            <a:endParaRPr lang="en-US" sz="800" dirty="0"/>
+          </a:p>
+        </p:txBody>
+      </p:sp>
+      <p:sp>
+        <p:nvSpPr>
+          <p:cNvPr id="51" name="Text 48"/>
+          <p:cNvSpPr txBox="1"/>
+          <p:nvPr/>
+        </p:nvSpPr>
+        <p:spPr>
+          <a:xfrm>
+            <a:off x="7260336" y="4023360"/>
+            <a:ext cx="731520" cy="548640"/>
+          </a:xfrm>
+          <a:prstGeom prst="rect">
+            <a:avLst/>
+          </a:prstGeom>
+          <a:noFill/>
+          <a:ln/>
+        </p:spPr>
+        <p:txBody>
+          <a:bodyPr wrap="square" lIns="0" tIns="0" rIns="0" bIns="0" rtlCol="0" anchor="ctr"/>
+          <a:lstStyle/>
+          <a:p>
+            <a:pPr indent="0" marL="0">
+              <a:buNone/>
+            </a:pPr>
+            <a:r>
+              <a:rPr lang="en-US" sz="1100" b="1" dirty="0">
+                <a:solidFill>
+                  <a:srgbClr val="FFFFFF"/>
+                </a:solidFill>
+                <a:latin typeface="Calibri" pitchFamily="34" charset="0"/>
+                <a:ea typeface="Calibri" pitchFamily="34" charset="-122"/>
+                <a:cs typeface="Calibri" pitchFamily="34" charset="-120"/>
+              </a:rPr>
+              <a:t>05/out</a:t>
+            </a:r>
+            <a:endParaRPr lang="en-US" sz="1100" dirty="0"/>
+          </a:p>
+        </p:txBody>
+      </p:sp>
+      <p:sp>
+        <p:nvSpPr>
+          <p:cNvPr id="52" name="Text 49"/>
+          <p:cNvSpPr txBox="1"/>
+          <p:nvPr/>
+        </p:nvSpPr>
+        <p:spPr>
+          <a:xfrm>
+            <a:off x="8174736" y="4023360"/>
+            <a:ext cx="1298448" cy="548640"/>
+          </a:xfrm>
+          <a:prstGeom prst="rect">
+            <a:avLst/>
+          </a:prstGeom>
+          <a:noFill/>
+          <a:ln/>
+        </p:spPr>
+        <p:txBody>
+          <a:bodyPr wrap="square" lIns="0" tIns="0" rIns="0" bIns="0" rtlCol="0" anchor="ctr"/>
+          <a:lstStyle/>
+          <a:p>
+            <a:pPr indent="0" marL="0">
+              <a:buNone/>
+            </a:pPr>
+            <a:r>
+              <a:rPr lang="en-US" sz="1100" dirty="0">
+                <a:solidFill>
+                  <a:srgbClr val="93A9C6"/>
+                </a:solidFill>
+                <a:latin typeface="Calibri" pitchFamily="34" charset="0"/>
+                <a:ea typeface="Calibri" pitchFamily="34" charset="-122"/>
+                <a:cs typeface="Calibri" pitchFamily="34" charset="-120"/>
+              </a:rPr>
+              <a:t>Não</a:t>
+            </a:r>
+            <a:endParaRPr lang="en-US" sz="1100" dirty="0"/>
+          </a:p>
+        </p:txBody>
+      </p:sp>
+      <p:sp>
+        <p:nvSpPr>
+          <p:cNvPr id="53" name="Text 50"/>
+          <p:cNvSpPr txBox="1"/>
+          <p:nvPr/>
+        </p:nvSpPr>
+        <p:spPr>
+          <a:xfrm>
+            <a:off x="9656064" y="4023360"/>
+            <a:ext cx="1856232" cy="548640"/>
+          </a:xfrm>
+          <a:prstGeom prst="rect">
+            <a:avLst/>
+          </a:prstGeom>
+          <a:noFill/>
+          <a:ln/>
+        </p:spPr>
+        <p:txBody>
+          <a:bodyPr wrap="square" lIns="0" tIns="0" rIns="0" bIns="0" rtlCol="0" anchor="ctr"/>
+          <a:lstStyle/>
+          <a:p>
+            <a:pPr indent="0" marL="0">
+              <a:lnSpc>
+                <a:spcPct val="108000"/>
+              </a:lnSpc>
+              <a:buNone/>
+            </a:pPr>
+            <a:r>
+              <a:rPr lang="en-US" sz="950" dirty="0">
+                <a:solidFill>
+                  <a:srgbClr val="93A9C6"/>
+                </a:solidFill>
+                <a:latin typeface="Calibri" pitchFamily="34" charset="0"/>
+                <a:ea typeface="Calibri" pitchFamily="34" charset="-122"/>
+                <a:cs typeface="Calibri" pitchFamily="34" charset="-120"/>
+              </a:rPr>
+              <a:t>Onboarding e conceitos de base</a:t>
+            </a:r>
+            <a:endParaRPr lang="en-US" sz="950" dirty="0"/>
+          </a:p>
+        </p:txBody>
+      </p:sp>
+      <p:sp>
+        <p:nvSpPr>
+          <p:cNvPr id="54" name="Shape 51"/>
+          <p:cNvSpPr/>
+          <p:nvPr/>
+        </p:nvSpPr>
+        <p:spPr>
+          <a:xfrm>
+            <a:off x="566928" y="4645152"/>
+            <a:ext cx="11055096" cy="548640"/>
+          </a:xfrm>
+          <a:prstGeom prst="roundRect">
+            <a:avLst>
+              <a:gd name="adj" fmla="val 11667"/>
+            </a:avLst>
+          </a:prstGeom>
+          <a:solidFill>
+            <a:srgbClr val="FFFFFF">
+              <a:alpha val="6000"/>
+            </a:srgbClr>
+          </a:solidFill>
+          <a:ln w="12700">
+            <a:solidFill>
+              <a:srgbClr val="31507F">
+                <a:alpha val="55000"/>
+              </a:srgbClr>
+            </a:solidFill>
+            <a:prstDash val="solid"/>
+          </a:ln>
+        </p:spPr>
+      </p:sp>
+      <p:sp>
+        <p:nvSpPr>
+          <p:cNvPr id="55" name="Text 52"/>
+          <p:cNvSpPr txBox="1"/>
+          <p:nvPr/>
+        </p:nvSpPr>
+        <p:spPr>
+          <a:xfrm>
+            <a:off x="822960" y="4645152"/>
+            <a:ext cx="2011680" cy="548640"/>
+          </a:xfrm>
+          <a:prstGeom prst="rect">
+            <a:avLst/>
+          </a:prstGeom>
+          <a:noFill/>
+          <a:ln/>
+        </p:spPr>
+        <p:txBody>
+          <a:bodyPr wrap="square" lIns="0" tIns="0" rIns="0" bIns="0" rtlCol="0" anchor="ctr"/>
+          <a:lstStyle/>
+          <a:p>
+            <a:pPr indent="0" marL="0">
+              <a:buNone/>
+            </a:pPr>
+            <a:r>
+              <a:rPr lang="en-US" sz="1150" b="1" dirty="0">
+                <a:solidFill>
+                  <a:srgbClr val="FFFFFF"/>
+                </a:solidFill>
+                <a:latin typeface="Calibri" pitchFamily="34" charset="0"/>
+                <a:ea typeface="Calibri" pitchFamily="34" charset="-122"/>
+                <a:cs typeface="Calibri" pitchFamily="34" charset="-120"/>
+              </a:rPr>
+              <a:t>Hora a Hora</a:t>
+            </a:r>
+            <a:endParaRPr lang="en-US" sz="1150" dirty="0"/>
+          </a:p>
+        </p:txBody>
+      </p:sp>
+      <p:sp>
+        <p:nvSpPr>
+          <p:cNvPr id="56" name="Text 53"/>
+          <p:cNvSpPr txBox="1"/>
+          <p:nvPr/>
+        </p:nvSpPr>
+        <p:spPr>
+          <a:xfrm>
+            <a:off x="3054096" y="4645152"/>
+            <a:ext cx="731520" cy="548640"/>
+          </a:xfrm>
+          <a:prstGeom prst="rect">
+            <a:avLst/>
+          </a:prstGeom>
+          <a:noFill/>
+          <a:ln/>
+        </p:spPr>
+        <p:txBody>
+          <a:bodyPr wrap="square" lIns="0" tIns="0" rIns="0" bIns="0" rtlCol="0" anchor="ctr"/>
+          <a:lstStyle/>
+          <a:p>
+            <a:pPr indent="0" marL="0">
+              <a:buNone/>
+            </a:pPr>
+            <a:r>
+              <a:rPr lang="en-US" sz="1100" dirty="0">
+                <a:solidFill>
+                  <a:srgbClr val="D8E4F4"/>
+                </a:solidFill>
+                <a:latin typeface="Calibri" pitchFamily="34" charset="0"/>
+                <a:ea typeface="Calibri" pitchFamily="34" charset="-122"/>
+                <a:cs typeface="Calibri" pitchFamily="34" charset="-120"/>
+              </a:rPr>
+              <a:t>N4</a:t>
+            </a:r>
+            <a:endParaRPr lang="en-US" sz="1100" dirty="0"/>
+          </a:p>
+        </p:txBody>
+      </p:sp>
+      <p:sp>
+        <p:nvSpPr>
+          <p:cNvPr id="57" name="Text 54"/>
+          <p:cNvSpPr txBox="1"/>
+          <p:nvPr/>
+        </p:nvSpPr>
+        <p:spPr>
+          <a:xfrm>
+            <a:off x="3968496" y="4645152"/>
+            <a:ext cx="1554480" cy="548640"/>
+          </a:xfrm>
+          <a:prstGeom prst="rect">
+            <a:avLst/>
+          </a:prstGeom>
+          <a:noFill/>
+          <a:ln/>
+        </p:spPr>
+        <p:txBody>
+          <a:bodyPr wrap="square" lIns="0" tIns="0" rIns="0" bIns="0" rtlCol="0" anchor="ctr"/>
+          <a:lstStyle/>
+          <a:p>
+            <a:pPr indent="0" marL="0">
+              <a:buNone/>
+            </a:pPr>
+            <a:r>
+              <a:rPr lang="en-US" sz="1100" dirty="0">
+                <a:solidFill>
+                  <a:srgbClr val="D8E4F4"/>
+                </a:solidFill>
+                <a:latin typeface="Calibri" pitchFamily="34" charset="0"/>
+                <a:ea typeface="Calibri" pitchFamily="34" charset="-122"/>
+                <a:cs typeface="Calibri" pitchFamily="34" charset="-120"/>
+              </a:rPr>
+              <a:t>Lucas</a:t>
+            </a:r>
+            <a:endParaRPr lang="en-US" sz="1100" dirty="0"/>
+          </a:p>
+        </p:txBody>
+      </p:sp>
+      <p:sp>
+        <p:nvSpPr>
+          <p:cNvPr id="58" name="Shape 55"/>
+          <p:cNvSpPr/>
+          <p:nvPr/>
+        </p:nvSpPr>
+        <p:spPr>
+          <a:xfrm>
+            <a:off x="5705856" y="4800600"/>
+            <a:ext cx="1371600" cy="237744"/>
+          </a:xfrm>
+          <a:prstGeom prst="roundRect">
+            <a:avLst>
+              <a:gd name="adj" fmla="val 23077"/>
+            </a:avLst>
+          </a:prstGeom>
+          <a:solidFill>
+            <a:srgbClr val="FFFFFF">
+              <a:alpha val="12000"/>
+            </a:srgbClr>
+          </a:solidFill>
+          <a:ln w="9525">
+            <a:solidFill>
+              <a:srgbClr val="E9A13B">
+                <a:alpha val="50000"/>
+              </a:srgbClr>
+            </a:solidFill>
+            <a:prstDash val="solid"/>
+          </a:ln>
+        </p:spPr>
+      </p:sp>
+      <p:sp>
+        <p:nvSpPr>
+          <p:cNvPr id="59" name="Text 56"/>
+          <p:cNvSpPr txBox="1"/>
+          <p:nvPr/>
+        </p:nvSpPr>
+        <p:spPr>
+          <a:xfrm>
+            <a:off x="5705856" y="4800600"/>
+            <a:ext cx="1371600" cy="237744"/>
+          </a:xfrm>
+          <a:prstGeom prst="rect">
+            <a:avLst/>
+          </a:prstGeom>
+          <a:noFill/>
+          <a:ln/>
+        </p:spPr>
+        <p:txBody>
+          <a:bodyPr wrap="square" lIns="0" tIns="0" rIns="0" bIns="0" rtlCol="0" anchor="ctr"/>
+          <a:lstStyle/>
+          <a:p>
+            <a:pPr algn="ctr" indent="0" marL="0">
+              <a:buNone/>
+            </a:pPr>
+            <a:r>
+              <a:rPr lang="en-US" sz="800" b="1" spc="60" kern="0" dirty="0">
+                <a:solidFill>
+                  <a:srgbClr val="E9A13B"/>
+                </a:solidFill>
+                <a:latin typeface="Calibri" pitchFamily="34" charset="0"/>
+                <a:ea typeface="Calibri" pitchFamily="34" charset="-122"/>
+                <a:cs typeface="Calibri" pitchFamily="34" charset="-120"/>
+              </a:rPr>
+              <a:t>EM DEV</a:t>
+            </a:r>
+            <a:endParaRPr lang="en-US" sz="800" dirty="0"/>
+          </a:p>
+        </p:txBody>
+      </p:sp>
+      <p:sp>
+        <p:nvSpPr>
+          <p:cNvPr id="60" name="Text 57"/>
+          <p:cNvSpPr txBox="1"/>
+          <p:nvPr/>
+        </p:nvSpPr>
+        <p:spPr>
+          <a:xfrm>
+            <a:off x="7260336" y="4645152"/>
+            <a:ext cx="731520" cy="548640"/>
+          </a:xfrm>
+          <a:prstGeom prst="rect">
+            <a:avLst/>
+          </a:prstGeom>
+          <a:noFill/>
+          <a:ln/>
+        </p:spPr>
+        <p:txBody>
+          <a:bodyPr wrap="square" lIns="0" tIns="0" rIns="0" bIns="0" rtlCol="0" anchor="ctr"/>
+          <a:lstStyle/>
+          <a:p>
+            <a:pPr indent="0" marL="0">
+              <a:buNone/>
+            </a:pPr>
+            <a:r>
+              <a:rPr lang="en-US" sz="1100" b="1" dirty="0">
+                <a:solidFill>
+                  <a:srgbClr val="FFFFFF"/>
+                </a:solidFill>
+                <a:latin typeface="Calibri" pitchFamily="34" charset="0"/>
+                <a:ea typeface="Calibri" pitchFamily="34" charset="-122"/>
+                <a:cs typeface="Calibri" pitchFamily="34" charset="-120"/>
+              </a:rPr>
+              <a:t>09/out</a:t>
+            </a:r>
+            <a:endParaRPr lang="en-US" sz="1100" dirty="0"/>
+          </a:p>
+        </p:txBody>
+      </p:sp>
+      <p:sp>
+        <p:nvSpPr>
+          <p:cNvPr id="61" name="Text 58"/>
+          <p:cNvSpPr txBox="1"/>
+          <p:nvPr/>
+        </p:nvSpPr>
+        <p:spPr>
+          <a:xfrm>
+            <a:off x="8174736" y="4645152"/>
+            <a:ext cx="1298448" cy="548640"/>
+          </a:xfrm>
+          <a:prstGeom prst="rect">
+            <a:avLst/>
+          </a:prstGeom>
+          <a:noFill/>
+          <a:ln/>
+        </p:spPr>
+        <p:txBody>
+          <a:bodyPr wrap="square" lIns="0" tIns="0" rIns="0" bIns="0" rtlCol="0" anchor="ctr"/>
+          <a:lstStyle/>
+          <a:p>
+            <a:pPr indent="0" marL="0">
+              <a:buNone/>
+            </a:pPr>
+            <a:r>
+              <a:rPr lang="en-US" sz="1100" dirty="0">
+                <a:solidFill>
+                  <a:srgbClr val="93A9C6"/>
+                </a:solidFill>
+                <a:latin typeface="Calibri" pitchFamily="34" charset="0"/>
+                <a:ea typeface="Calibri" pitchFamily="34" charset="-122"/>
+                <a:cs typeface="Calibri" pitchFamily="34" charset="-120"/>
+              </a:rPr>
+              <a:t>Não</a:t>
+            </a:r>
+            <a:endParaRPr lang="en-US" sz="1100" dirty="0"/>
+          </a:p>
+        </p:txBody>
+      </p:sp>
+      <p:sp>
+        <p:nvSpPr>
+          <p:cNvPr id="62" name="Text 59"/>
+          <p:cNvSpPr txBox="1"/>
+          <p:nvPr/>
+        </p:nvSpPr>
+        <p:spPr>
+          <a:xfrm>
+            <a:off x="9656064" y="4645152"/>
+            <a:ext cx="1856232" cy="548640"/>
+          </a:xfrm>
+          <a:prstGeom prst="rect">
+            <a:avLst/>
+          </a:prstGeom>
+          <a:noFill/>
+          <a:ln/>
+        </p:spPr>
+        <p:txBody>
+          <a:bodyPr wrap="square" lIns="0" tIns="0" rIns="0" bIns="0" rtlCol="0" anchor="ctr"/>
+          <a:lstStyle/>
+          <a:p>
+            <a:pPr indent="0" marL="0">
+              <a:lnSpc>
+                <a:spcPct val="108000"/>
+              </a:lnSpc>
+              <a:buNone/>
+            </a:pPr>
+            <a:r>
+              <a:rPr lang="en-US" sz="950" dirty="0">
+                <a:solidFill>
+                  <a:srgbClr val="93A9C6"/>
+                </a:solidFill>
+                <a:latin typeface="Calibri" pitchFamily="34" charset="0"/>
+                <a:ea typeface="Calibri" pitchFamily="34" charset="-122"/>
+                <a:cs typeface="Calibri" pitchFamily="34" charset="-120"/>
+              </a:rPr>
+              <a:t>Depende de reunião com o Lucas</a:t>
+            </a:r>
+            <a:endParaRPr lang="en-US" sz="950" dirty="0"/>
+          </a:p>
+        </p:txBody>
+      </p:sp>
+      <p:sp>
+        <p:nvSpPr>
+          <p:cNvPr id="63" name="Shape 60"/>
+          <p:cNvSpPr/>
+          <p:nvPr/>
+        </p:nvSpPr>
+        <p:spPr>
+          <a:xfrm>
+            <a:off x="566928" y="5413248"/>
+            <a:ext cx="11055096" cy="969264"/>
+          </a:xfrm>
+          <a:prstGeom prst="roundRect">
+            <a:avLst>
+              <a:gd name="adj" fmla="val 9434"/>
+            </a:avLst>
+          </a:prstGeom>
+          <a:solidFill>
+            <a:srgbClr val="FFFFFF">
+              <a:alpha val="7000"/>
+            </a:srgbClr>
+          </a:solidFill>
+          <a:ln w="12700">
+            <a:solidFill>
+              <a:srgbClr val="31507F"/>
+            </a:solidFill>
+            <a:prstDash val="solid"/>
+          </a:ln>
+        </p:spPr>
+      </p:sp>
+      <p:sp>
+        <p:nvSpPr>
+          <p:cNvPr id="64" name="Text 61"/>
+          <p:cNvSpPr txBox="1"/>
+          <p:nvPr/>
+        </p:nvSpPr>
+        <p:spPr>
+          <a:xfrm>
+            <a:off x="896112" y="5413248"/>
+            <a:ext cx="1234440" cy="969264"/>
+          </a:xfrm>
+          <a:prstGeom prst="rect">
+            <a:avLst/>
+          </a:prstGeom>
+          <a:noFill/>
+          <a:ln/>
+        </p:spPr>
+        <p:txBody>
+          <a:bodyPr wrap="square" lIns="0" tIns="0" rIns="0" bIns="0" rtlCol="0" anchor="ctr"/>
+          <a:lstStyle/>
+          <a:p>
+            <a:pPr indent="0" marL="0">
+              <a:lnSpc>
+                <a:spcPct val="105000"/>
+              </a:lnSpc>
+              <a:buNone/>
+            </a:pPr>
+            <a:r>
+              <a:rPr lang="en-US" sz="1000" b="1" spc="120" kern="0" dirty="0">
+                <a:solidFill>
+                  <a:srgbClr val="E9A13B"/>
+                </a:solidFill>
+                <a:latin typeface="Calibri" pitchFamily="34" charset="0"/>
+                <a:ea typeface="Calibri" pitchFamily="34" charset="-122"/>
+                <a:cs typeface="Calibri" pitchFamily="34" charset="-120"/>
+              </a:rPr>
+              <a:t>PONTOS DE</a:t>
+            </a:r>
+            <a:endParaRPr lang="en-US" sz="1000" dirty="0"/>
+          </a:p>
+          <a:p>
+            <a:pPr indent="0" marL="0">
+              <a:lnSpc>
+                <a:spcPct val="105000"/>
+              </a:lnSpc>
+              <a:buNone/>
+            </a:pPr>
+            <a:r>
+              <a:rPr lang="en-US" sz="1000" b="1" spc="120" kern="0" dirty="0">
+                <a:solidFill>
+                  <a:srgbClr val="E9A13B"/>
+                </a:solidFill>
+                <a:latin typeface="Calibri" pitchFamily="34" charset="0"/>
+                <a:ea typeface="Calibri" pitchFamily="34" charset="-122"/>
+                <a:cs typeface="Calibri" pitchFamily="34" charset="-120"/>
+              </a:rPr>
+              <a:t>ATENÇÃO</a:t>
+            </a:r>
+            <a:endParaRPr lang="en-US" sz="1000" dirty="0"/>
+          </a:p>
+        </p:txBody>
+      </p:sp>
+      <p:sp>
+        <p:nvSpPr>
+          <p:cNvPr id="65" name="Shape 62"/>
+          <p:cNvSpPr/>
+          <p:nvPr/>
+        </p:nvSpPr>
+        <p:spPr>
+          <a:xfrm>
+            <a:off x="2258568" y="5614416"/>
+            <a:ext cx="256032" cy="256032"/>
+          </a:xfrm>
+          <a:prstGeom prst="ellipse">
+            <a:avLst/>
+          </a:prstGeom>
+          <a:solidFill>
+            <a:srgbClr val="E9A13B"/>
+          </a:solidFill>
+          <a:ln/>
+        </p:spPr>
+      </p:sp>
+      <p:pic>
+        <p:nvPicPr>
+          <p:cNvPr id="66" name="Image 1" descr="preencoded.png">    </p:cNvPr>
+          <p:cNvPicPr>
+            <a:picLocks noChangeAspect="1"/>
+          </p:cNvPicPr>
+          <p:nvPr/>
+        </p:nvPicPr>
+        <p:blipFill>
+          <a:blip r:embed="rId2"/>
+          <a:stretch>
+            <a:fillRect/>
+          </a:stretch>
+        </p:blipFill>
+        <p:spPr>
+          <a:xfrm>
+            <a:off x="2322576" y="5678424"/>
+            <a:ext cx="128016" cy="128016"/>
+          </a:xfrm>
+          <a:prstGeom prst="rect">
+            <a:avLst/>
+          </a:prstGeom>
+        </p:spPr>
+      </p:pic>
+      <p:sp>
+        <p:nvSpPr>
+          <p:cNvPr id="67" name="Text 63"/>
+          <p:cNvSpPr txBox="1"/>
+          <p:nvPr/>
+        </p:nvSpPr>
+        <p:spPr>
+          <a:xfrm>
+            <a:off x="2606040" y="5596128"/>
+            <a:ext cx="2609088" cy="274320"/>
+          </a:xfrm>
+          <a:prstGeom prst="rect">
+            <a:avLst/>
+          </a:prstGeom>
+          <a:noFill/>
+          <a:ln/>
+        </p:spPr>
+        <p:txBody>
+          <a:bodyPr wrap="square" lIns="0" tIns="0" rIns="0" bIns="0" rtlCol="0" anchor="ctr"/>
+          <a:lstStyle/>
+          <a:p>
+            <a:pPr indent="0" marL="0">
+              <a:buNone/>
+            </a:pPr>
+            <a:r>
+              <a:rPr lang="en-US" sz="1100" b="1" dirty="0">
+                <a:solidFill>
+                  <a:srgbClr val="FFFFFF"/>
+                </a:solidFill>
+                <a:latin typeface="Calibri" pitchFamily="34" charset="0"/>
+                <a:ea typeface="Calibri" pitchFamily="34" charset="-122"/>
+                <a:cs typeface="Calibri" pitchFamily="34" charset="-120"/>
+              </a:rPr>
+              <a:t>N5  ·  Hora a Hora</a:t>
+            </a:r>
+            <a:endParaRPr lang="en-US" sz="1100" dirty="0"/>
+          </a:p>
+        </p:txBody>
+      </p:sp>
+      <p:sp>
+        <p:nvSpPr>
+          <p:cNvPr id="68" name="Text 64"/>
+          <p:cNvSpPr txBox="1"/>
+          <p:nvPr/>
+        </p:nvSpPr>
+        <p:spPr>
+          <a:xfrm>
+            <a:off x="2606040" y="5888736"/>
+            <a:ext cx="2609088" cy="384048"/>
+          </a:xfrm>
+          <a:prstGeom prst="rect">
+            <a:avLst/>
+          </a:prstGeom>
+          <a:noFill/>
+          <a:ln/>
+        </p:spPr>
+        <p:txBody>
+          <a:bodyPr wrap="square" lIns="0" tIns="0" rIns="0" bIns="0" rtlCol="0" anchor="t"/>
+          <a:lstStyle/>
+          <a:p>
+            <a:pPr indent="0" marL="0">
+              <a:lnSpc>
+                <a:spcPct val="110000"/>
+              </a:lnSpc>
+              <a:buNone/>
+            </a:pPr>
+            <a:r>
+              <a:rPr lang="en-US" sz="900" dirty="0">
+                <a:solidFill>
+                  <a:srgbClr val="D8E4F4"/>
+                </a:solidFill>
+                <a:latin typeface="Calibri" pitchFamily="34" charset="0"/>
+                <a:ea typeface="Calibri" pitchFamily="34" charset="-122"/>
+                <a:cs typeface="Calibri" pitchFamily="34" charset="-120"/>
+              </a:rPr>
+              <a:t>Conceitos de base e onboarding com a Andressa em andamento</a:t>
+            </a:r>
+            <a:endParaRPr lang="en-US" sz="900" dirty="0"/>
+          </a:p>
+        </p:txBody>
+      </p:sp>
+      <p:sp>
+        <p:nvSpPr>
+          <p:cNvPr id="69" name="Shape 65"/>
+          <p:cNvSpPr/>
+          <p:nvPr/>
+        </p:nvSpPr>
+        <p:spPr>
+          <a:xfrm>
+            <a:off x="5452872" y="5614416"/>
+            <a:ext cx="256032" cy="256032"/>
+          </a:xfrm>
+          <a:prstGeom prst="ellipse">
+            <a:avLst/>
+          </a:prstGeom>
+          <a:solidFill>
+            <a:srgbClr val="E9A13B"/>
+          </a:solidFill>
+          <a:ln/>
+        </p:spPr>
+      </p:sp>
+      <p:pic>
+        <p:nvPicPr>
+          <p:cNvPr id="70" name="Image 2" descr="preencoded.png">    </p:cNvPr>
+          <p:cNvPicPr>
+            <a:picLocks noChangeAspect="1"/>
+          </p:cNvPicPr>
+          <p:nvPr/>
+        </p:nvPicPr>
+        <p:blipFill>
+          <a:blip r:embed="rId3"/>
+          <a:stretch>
+            <a:fillRect/>
+          </a:stretch>
+        </p:blipFill>
+        <p:spPr>
+          <a:xfrm>
+            <a:off x="5516880" y="5678424"/>
+            <a:ext cx="128016" cy="128016"/>
+          </a:xfrm>
+          <a:prstGeom prst="rect">
+            <a:avLst/>
+          </a:prstGeom>
+        </p:spPr>
+      </p:pic>
+      <p:sp>
+        <p:nvSpPr>
+          <p:cNvPr id="71" name="Text 66"/>
+          <p:cNvSpPr txBox="1"/>
+          <p:nvPr/>
+        </p:nvSpPr>
+        <p:spPr>
+          <a:xfrm>
+            <a:off x="5800344" y="5596128"/>
+            <a:ext cx="2609088" cy="274320"/>
+          </a:xfrm>
+          <a:prstGeom prst="rect">
+            <a:avLst/>
+          </a:prstGeom>
+          <a:noFill/>
+          <a:ln/>
+        </p:spPr>
+        <p:txBody>
+          <a:bodyPr wrap="square" lIns="0" tIns="0" rIns="0" bIns="0" rtlCol="0" anchor="ctr"/>
+          <a:lstStyle/>
+          <a:p>
+            <a:pPr indent="0" marL="0">
+              <a:buNone/>
+            </a:pPr>
+            <a:r>
+              <a:rPr lang="en-US" sz="1100" b="1" dirty="0">
+                <a:solidFill>
+                  <a:srgbClr val="FFFFFF"/>
+                </a:solidFill>
+                <a:latin typeface="Calibri" pitchFamily="34" charset="0"/>
+                <a:ea typeface="Calibri" pitchFamily="34" charset="-122"/>
+                <a:cs typeface="Calibri" pitchFamily="34" charset="-120"/>
+              </a:rPr>
+              <a:t>N4  ·  Hora a Hora</a:t>
+            </a:r>
+            <a:endParaRPr lang="en-US" sz="1100" dirty="0"/>
+          </a:p>
+        </p:txBody>
+      </p:sp>
+      <p:sp>
+        <p:nvSpPr>
+          <p:cNvPr id="72" name="Text 67"/>
+          <p:cNvSpPr txBox="1"/>
+          <p:nvPr/>
+        </p:nvSpPr>
+        <p:spPr>
+          <a:xfrm>
+            <a:off x="5800344" y="5888736"/>
+            <a:ext cx="2609088" cy="384048"/>
+          </a:xfrm>
+          <a:prstGeom prst="rect">
+            <a:avLst/>
+          </a:prstGeom>
+          <a:noFill/>
+          <a:ln/>
+        </p:spPr>
+        <p:txBody>
+          <a:bodyPr wrap="square" lIns="0" tIns="0" rIns="0" bIns="0" rtlCol="0" anchor="t"/>
+          <a:lstStyle/>
+          <a:p>
+            <a:pPr indent="0" marL="0">
+              <a:lnSpc>
+                <a:spcPct val="110000"/>
+              </a:lnSpc>
+              <a:buNone/>
+            </a:pPr>
+            <a:r>
+              <a:rPr lang="en-US" sz="900" dirty="0">
+                <a:solidFill>
+                  <a:srgbClr val="D8E4F4"/>
+                </a:solidFill>
+                <a:latin typeface="Calibri" pitchFamily="34" charset="0"/>
+                <a:ea typeface="Calibri" pitchFamily="34" charset="-122"/>
+                <a:cs typeface="Calibri" pitchFamily="34" charset="-120"/>
+              </a:rPr>
+              <a:t>Relatório está com a operação; reunião com o Lucas para estruturar os KPIs</a:t>
+            </a:r>
+            <a:endParaRPr lang="en-US" sz="900" dirty="0"/>
+          </a:p>
+        </p:txBody>
+      </p:sp>
+      <p:sp>
+        <p:nvSpPr>
+          <p:cNvPr id="73" name="Shape 68"/>
+          <p:cNvSpPr/>
+          <p:nvPr/>
+        </p:nvSpPr>
+        <p:spPr>
+          <a:xfrm>
+            <a:off x="8647176" y="5614416"/>
+            <a:ext cx="256032" cy="256032"/>
+          </a:xfrm>
+          <a:prstGeom prst="ellipse">
+            <a:avLst/>
+          </a:prstGeom>
+          <a:solidFill>
+            <a:srgbClr val="E9A13B"/>
+          </a:solidFill>
+          <a:ln/>
+        </p:spPr>
+      </p:sp>
+      <p:pic>
+        <p:nvPicPr>
+          <p:cNvPr id="74" name="Image 3" descr="preencoded.png">    </p:cNvPr>
+          <p:cNvPicPr>
+            <a:picLocks noChangeAspect="1"/>
+          </p:cNvPicPr>
+          <p:nvPr/>
+        </p:nvPicPr>
+        <p:blipFill>
+          <a:blip r:embed="rId4"/>
+          <a:stretch>
+            <a:fillRect/>
+          </a:stretch>
+        </p:blipFill>
+        <p:spPr>
+          <a:xfrm>
+            <a:off x="8711184" y="5678424"/>
+            <a:ext cx="128016" cy="128016"/>
+          </a:xfrm>
+          <a:prstGeom prst="rect">
+            <a:avLst/>
+          </a:prstGeom>
+        </p:spPr>
+      </p:pic>
+      <p:sp>
+        <p:nvSpPr>
+          <p:cNvPr id="75" name="Text 69"/>
+          <p:cNvSpPr txBox="1"/>
+          <p:nvPr/>
+        </p:nvSpPr>
+        <p:spPr>
+          <a:xfrm>
+            <a:off x="8994648" y="5596128"/>
+            <a:ext cx="2609088" cy="274320"/>
+          </a:xfrm>
+          <a:prstGeom prst="rect">
+            <a:avLst/>
+          </a:prstGeom>
+          <a:noFill/>
+          <a:ln/>
+        </p:spPr>
+        <p:txBody>
+          <a:bodyPr wrap="square" lIns="0" tIns="0" rIns="0" bIns="0" rtlCol="0" anchor="ctr"/>
+          <a:lstStyle/>
+          <a:p>
+            <a:pPr indent="0" marL="0">
+              <a:buNone/>
+            </a:pPr>
+            <a:r>
+              <a:rPr lang="en-US" sz="1100" b="1" dirty="0">
+                <a:solidFill>
+                  <a:srgbClr val="FFFFFF"/>
+                </a:solidFill>
+                <a:latin typeface="Calibri" pitchFamily="34" charset="0"/>
+                <a:ea typeface="Calibri" pitchFamily="34" charset="-122"/>
+                <a:cs typeface="Calibri" pitchFamily="34" charset="-120"/>
+              </a:rPr>
+              <a:t>Acessos</a:t>
+            </a:r>
+            <a:endParaRPr lang="en-US" sz="1100" dirty="0"/>
+          </a:p>
+        </p:txBody>
+      </p:sp>
+      <p:sp>
+        <p:nvSpPr>
+          <p:cNvPr id="76" name="Text 70"/>
+          <p:cNvSpPr txBox="1"/>
+          <p:nvPr/>
+        </p:nvSpPr>
+        <p:spPr>
+          <a:xfrm>
+            <a:off x="8994648" y="5888736"/>
+            <a:ext cx="2609088" cy="384048"/>
+          </a:xfrm>
+          <a:prstGeom prst="rect">
+            <a:avLst/>
+          </a:prstGeom>
+          <a:noFill/>
+          <a:ln/>
+        </p:spPr>
+        <p:txBody>
+          <a:bodyPr wrap="square" lIns="0" tIns="0" rIns="0" bIns="0" rtlCol="0" anchor="t"/>
+          <a:lstStyle/>
+          <a:p>
+            <a:pPr indent="0" marL="0">
+              <a:lnSpc>
+                <a:spcPct val="110000"/>
+              </a:lnSpc>
+              <a:buNone/>
+            </a:pPr>
+            <a:r>
+              <a:rPr lang="en-US" sz="900" dirty="0">
+                <a:solidFill>
+                  <a:srgbClr val="D8E4F4"/>
+                </a:solidFill>
+                <a:latin typeface="Calibri" pitchFamily="34" charset="0"/>
+                <a:ea typeface="Calibri" pitchFamily="34" charset="-122"/>
+                <a:cs typeface="Calibri" pitchFamily="34" charset="-120"/>
+              </a:rPr>
+              <a:t>Todas as ferramentas liberadas</a:t>
+            </a:r>
+            <a:endParaRPr lang="en-US" sz="900" dirty="0"/>
+          </a:p>
+        </p:txBody>
+      </p:sp>
+    </p:spTree>
+  </p:cSld>
+  <p:clrMapOvr>
+    <a:masterClrMapping/>
+  </p:clrMapOvr>
+</p:sld>
+</file>
+
 <file path=ppt/theme/theme1.xml><?xml version="1.0" encoding="utf-8"?>
 <a:theme xmlns:a="http://schemas.openxmlformats.org/drawingml/2006/main" name="Office Theme">
   <a:themeElements>

</xml_diff>